<commit_message>
Rebuild the deck in the team's own 10-slide structure
The earlier version followed the blank department template (6 slides); the team's
actual deck has 10. Same content, mapped onto their existing slide order so the
institute styling can be kept and the content pasted across.

Figures and every number are generated from results/evaluation.json and
results/benchmark.json, so the slides cannot drift from the code — which is how the
previous deck came to claim MTCNN + FaceNet + MongoDB (none of which the system uses)
and a 95% accuracy that was never measured.
</commit_message>
<xml_diff>
--- a/Server/results/PresenceAI_Presentation.pptx
+++ b/Server/results/PresenceAI_Presentation.pptx
@@ -11,6 +11,11 @@
     <p:sldId id="259" r:id="rId10"/>
     <p:sldId id="260" r:id="rId11"/>
     <p:sldId id="261" r:id="rId12"/>
+    <p:sldId id="262" r:id="rId13"/>
+    <p:sldId id="263" r:id="rId14"/>
+    <p:sldId id="264" r:id="rId15"/>
+    <p:sldId id="265" r:id="rId16"/>
+    <p:sldId id="266" r:id="rId17"/>
   </p:sldIdLst>
   <p:sldSz cx="12191695" cy="6858000" type="screen4x3"/>
   <p:notesSz cx="6858000" cy="9144000"/>
@@ -3101,8 +3106,8 @@
         </p:nvSpPr>
         <p:spPr>
           <a:xfrm>
-            <a:off x="731520" y="822960"/>
-            <a:ext cx="10698480" cy="1371600"/>
+            <a:off x="731520" y="731520"/>
+            <a:ext cx="10698480" cy="1463040"/>
           </a:xfrm>
           <a:prstGeom prst="rect">
             <a:avLst/>
@@ -3133,7 +3138,7 @@
                   <a:srgbClr val="555F6D"/>
                 </a:solidFill>
               </a:rPr>
-              <a:t>Spoof-Resistant Multi-Face Attendance: Recognition Alone Is Not Enough</a:t>
+              <a:t>Spoof-Resistant Multi-Face Attendance — Recognition Alone Is Not Enough</a:t>
             </a:r>
           </a:p>
         </p:txBody>
@@ -3146,8 +3151,8 @@
         </p:nvSpPr>
         <p:spPr>
           <a:xfrm>
-            <a:off x="2377440" y="2468880"/>
-            <a:ext cx="7772400" cy="2926080"/>
+            <a:off x="2743200" y="2743200"/>
+            <a:ext cx="7315200" cy="2377440"/>
           </a:xfrm>
           <a:prstGeom prst="rect">
             <a:avLst/>
@@ -3166,44 +3171,22 @@
               </a:spcAft>
             </a:pPr>
             <a:r>
-              <a:rPr sz="1300" b="1">
-                <a:solidFill>
-                  <a:srgbClr val="1A1A1A"/>
-                </a:solidFill>
-              </a:rPr>
-              <a:t>Problem Statement Title — Automating classroom attendance with multi-face recognition, without it being defeated by a photograph</a:t>
-            </a:r>
-          </a:p>
-          <a:p>
-            <a:pPr>
-              <a:spcAft>
-                <a:spcPts val="500"/>
-              </a:spcAft>
-            </a:pPr>
-          </a:p>
-          <a:p>
-            <a:pPr>
-              <a:spcAft>
-                <a:spcPts val="500"/>
-              </a:spcAft>
-            </a:pPr>
-            <a:r>
-              <a:rPr sz="1300" b="1">
-                <a:solidFill>
-                  <a:srgbClr val="1F3A6E"/>
-                </a:solidFill>
-              </a:rPr>
-              <a:t>Team Members</a:t>
-            </a:r>
-          </a:p>
-          <a:p>
-            <a:pPr>
-              <a:spcAft>
-                <a:spcPts val="500"/>
-              </a:spcAft>
-            </a:pPr>
-            <a:r>
-              <a:rPr sz="1300" b="0">
+              <a:rPr sz="1400" b="1">
+                <a:solidFill>
+                  <a:srgbClr val="1A1A1A"/>
+                </a:solidFill>
+              </a:rPr>
+              <a:t>Team Members' Name and Roll Number</a:t>
+            </a:r>
+          </a:p>
+          <a:p>
+            <a:pPr>
+              <a:spcAft>
+                <a:spcPts val="500"/>
+              </a:spcAft>
+            </a:pPr>
+            <a:r>
+              <a:rPr sz="1400" b="0">
                 <a:solidFill>
                   <a:srgbClr val="1A1A1A"/>
                 </a:solidFill>
@@ -3218,7 +3201,7 @@
               </a:spcAft>
             </a:pPr>
             <a:r>
-              <a:rPr sz="1300" b="0">
+              <a:rPr sz="1400" b="0">
                 <a:solidFill>
                   <a:srgbClr val="1A1A1A"/>
                 </a:solidFill>
@@ -3240,7 +3223,7 @@
               </a:spcAft>
             </a:pPr>
             <a:r>
-              <a:rPr sz="1300" b="1">
+              <a:rPr sz="1400" b="1">
                 <a:solidFill>
                   <a:srgbClr val="1A1A1A"/>
                 </a:solidFill>
@@ -3255,27 +3238,12 @@
               </a:spcAft>
             </a:pPr>
             <a:r>
-              <a:rPr sz="1300" b="1">
-                <a:solidFill>
-                  <a:srgbClr val="1A1A1A"/>
-                </a:solidFill>
-              </a:rPr>
-              <a:t>Mentor — Mr Prodipta Bhowmik</a:t>
-            </a:r>
-          </a:p>
-          <a:p>
-            <a:pPr>
-              <a:spcAft>
-                <a:spcPts val="500"/>
-              </a:spcAft>
-            </a:pPr>
-            <a:r>
-              <a:rPr sz="1300" b="0">
-                <a:solidFill>
-                  <a:srgbClr val="1A1A1A"/>
-                </a:solidFill>
-              </a:rPr>
-              <a:t>PROJICB-781</a:t>
+              <a:rPr sz="1400" b="1">
+                <a:solidFill>
+                  <a:srgbClr val="1A1A1A"/>
+                </a:solidFill>
+              </a:rPr>
+              <a:t>Mentor Name — Mr Prodipta Bhowmik</a:t>
             </a:r>
           </a:p>
         </p:txBody>
@@ -3288,8 +3256,8 @@
         </p:nvSpPr>
         <p:spPr>
           <a:xfrm>
-            <a:off x="731520" y="5943600"/>
-            <a:ext cx="10698480" cy="822960"/>
+            <a:off x="731520" y="5760720"/>
+            <a:ext cx="10698480" cy="914400"/>
           </a:xfrm>
           <a:prstGeom prst="rect">
             <a:avLst/>
@@ -3304,15 +3272,380 @@
           <a:p>
             <a:pPr algn="ctr"/>
             <a:r>
-              <a:rPr sz="1200" b="1"/>
-              <a:t>Department of Computer Science &amp; Engineering (Cyber Security)</a:t>
+              <a:rPr sz="1300" b="1"/>
+              <a:t>Department of Information Technology</a:t>
             </a:r>
           </a:p>
           <a:p>
             <a:pPr algn="ctr"/>
             <a:r>
-              <a:rPr sz="1200" b="0"/>
-              <a:t>Techno Main Salt Lake, Kolkata - 700091</a:t>
+              <a:rPr sz="1300" b="1"/>
+              <a:t>Techno Main Salt Lake</a:t>
+            </a:r>
+          </a:p>
+          <a:p>
+            <a:pPr algn="ctr"/>
+            <a:r>
+              <a:rPr sz="1300" b="1"/>
+              <a:t>Kolkata - 700091</a:t>
+            </a:r>
+          </a:p>
+        </p:txBody>
+      </p:sp>
+    </p:spTree>
+  </p:cSld>
+  <p:clrMapOvr>
+    <a:masterClrMapping/>
+  </p:clrMapOvr>
+</p:sld>
+</file>
+
+<file path=ppt/slides/slide10.xml><?xml version="1.0" encoding="utf-8"?>
+<p:sld xmlns:a="http://schemas.openxmlformats.org/drawingml/2006/main" xmlns:p="http://schemas.openxmlformats.org/presentationml/2006/main" xmlns:r="http://schemas.openxmlformats.org/officeDocument/2006/relationships">
+  <p:cSld>
+    <p:spTree>
+      <p:nvGrpSpPr>
+        <p:cNvPr id="1" name=""/>
+        <p:cNvGrpSpPr/>
+        <p:nvPr/>
+      </p:nvGrpSpPr>
+      <p:grpSpPr/>
+      <p:sp>
+        <p:nvSpPr>
+          <p:cNvPr id="2" name="TextBox 1"/>
+          <p:cNvSpPr txBox="1"/>
+          <p:nvPr/>
+        </p:nvSpPr>
+        <p:spPr>
+          <a:xfrm>
+            <a:off x="365760" y="182880"/>
+            <a:ext cx="11430000" cy="640080"/>
+          </a:xfrm>
+          <a:prstGeom prst="rect">
+            <a:avLst/>
+          </a:prstGeom>
+          <a:noFill/>
+        </p:spPr>
+        <p:txBody>
+          <a:bodyPr wrap="none">
+            <a:spAutoFit/>
+          </a:bodyPr>
+          <a:lstStyle/>
+          <a:p>
+            <a:pPr algn="ctr"/>
+            <a:r>
+              <a:rPr sz="2800" b="1">
+                <a:solidFill>
+                  <a:srgbClr val="1F3A6E"/>
+                </a:solidFill>
+              </a:rPr>
+              <a:t>REFERENCES</a:t>
+            </a:r>
+          </a:p>
+        </p:txBody>
+      </p:sp>
+      <p:sp>
+        <p:nvSpPr>
+          <p:cNvPr id="3" name="TextBox 2"/>
+          <p:cNvSpPr txBox="1"/>
+          <p:nvPr/>
+        </p:nvSpPr>
+        <p:spPr>
+          <a:xfrm>
+            <a:off x="548640" y="960120"/>
+            <a:ext cx="11155680" cy="5577840"/>
+          </a:xfrm>
+          <a:prstGeom prst="rect">
+            <a:avLst/>
+          </a:prstGeom>
+          <a:noFill/>
+        </p:spPr>
+        <p:txBody>
+          <a:bodyPr wrap="square">
+            <a:spAutoFit/>
+          </a:bodyPr>
+          <a:lstStyle/>
+          <a:p>
+            <a:pPr>
+              <a:spcAft>
+                <a:spcPts val="500"/>
+              </a:spcAft>
+            </a:pPr>
+            <a:r>
+              <a:rPr sz="950" b="0">
+                <a:solidFill>
+                  <a:srgbClr val="1A1A1A"/>
+                </a:solidFill>
+              </a:rPr>
+              <a:t>[1]  D'Souza, J. W. S., et al. (2019). Automated Attendance Marking and Management System by Facial Recognition Using Histogram. Array, 3–4: 100014. DOI: 10.1016/j.array.2019.100014</a:t>
+            </a:r>
+          </a:p>
+          <a:p>
+            <a:pPr>
+              <a:spcAft>
+                <a:spcPts val="500"/>
+              </a:spcAft>
+            </a:pPr>
+          </a:p>
+          <a:p>
+            <a:pPr>
+              <a:spcAft>
+                <a:spcPts val="500"/>
+              </a:spcAft>
+            </a:pPr>
+            <a:r>
+              <a:rPr sz="950" b="0">
+                <a:solidFill>
+                  <a:srgbClr val="1A1A1A"/>
+                </a:solidFill>
+              </a:rPr>
+              <a:t>[2]  Arsenovic, M., Sladojevic, S., Anderla, A., Stefanovic, D. (2017). FaceTime — Deep Learning Based Face Recognition Attendance System. IEEE SISY 2017, pp. 53–58. DOI: 10.1109/SISY.2017.8080587</a:t>
+            </a:r>
+          </a:p>
+          <a:p>
+            <a:pPr>
+              <a:spcAft>
+                <a:spcPts val="500"/>
+              </a:spcAft>
+            </a:pPr>
+          </a:p>
+          <a:p>
+            <a:pPr>
+              <a:spcAft>
+                <a:spcPts val="500"/>
+              </a:spcAft>
+            </a:pPr>
+            <a:r>
+              <a:rPr sz="950" b="0">
+                <a:solidFill>
+                  <a:srgbClr val="1A1A1A"/>
+                </a:solidFill>
+              </a:rPr>
+              <a:t>[3]  Kakarla, S., Gangula, P., Rahul, M. S., Singh, C. S. C., Sarma, T. H. (2020). Smart Attendance Management System Based on Face Recognition Using CNN. IEEE-HYDCON 2020, pp. 1–5. DOI: 10.1109/HYDCON48903.2020.9242847</a:t>
+            </a:r>
+          </a:p>
+          <a:p>
+            <a:pPr>
+              <a:spcAft>
+                <a:spcPts val="500"/>
+              </a:spcAft>
+            </a:pPr>
+          </a:p>
+          <a:p>
+            <a:pPr>
+              <a:spcAft>
+                <a:spcPts val="500"/>
+              </a:spcAft>
+            </a:pPr>
+            <a:r>
+              <a:rPr sz="950" b="0">
+                <a:solidFill>
+                  <a:srgbClr val="1A1A1A"/>
+                </a:solidFill>
+              </a:rPr>
+              <a:t>[4]  Varadharajan, E., Dharani, R., Jeevitha, S., Kavinmathi, B., Hemalatha, S. (2016). Automatic Attendance Management System Using Face Detection. IC-GET 2016, pp. 1–3. DOI: 10.1109/GET.2016.7916753</a:t>
+            </a:r>
+          </a:p>
+          <a:p>
+            <a:pPr>
+              <a:spcAft>
+                <a:spcPts val="500"/>
+              </a:spcAft>
+            </a:pPr>
+          </a:p>
+          <a:p>
+            <a:pPr>
+              <a:spcAft>
+                <a:spcPts val="500"/>
+              </a:spcAft>
+            </a:pPr>
+            <a:r>
+              <a:rPr sz="950" b="0">
+                <a:solidFill>
+                  <a:srgbClr val="1A1A1A"/>
+                </a:solidFill>
+              </a:rPr>
+              <a:t>[5]  Siswanto, A. R. S., Nugroho, A. S., Galinium, M. (2014). Implementation of Face Recognition Algorithm for Biometrics Based Time Attendance System. ICISS 2014, pp. 149–154. DOI: 10.1109/ICTSS.2014.7013165</a:t>
+            </a:r>
+          </a:p>
+          <a:p>
+            <a:pPr>
+              <a:spcAft>
+                <a:spcPts val="500"/>
+              </a:spcAft>
+            </a:pPr>
+          </a:p>
+          <a:p>
+            <a:pPr>
+              <a:spcAft>
+                <a:spcPts val="500"/>
+              </a:spcAft>
+            </a:pPr>
+            <a:r>
+              <a:rPr sz="950" b="0">
+                <a:solidFill>
+                  <a:srgbClr val="1A1A1A"/>
+                </a:solidFill>
+              </a:rPr>
+              <a:t>[6]  Deng, J., Guo, J., Xue, N., Zafeiriou, S. (2019). ArcFace: Additive Angular Margin Loss for Deep Face Recognition. CVPR 2019, pp. 4690–4699. DOI: 10.1109/CVPR.2019.00482</a:t>
+            </a:r>
+          </a:p>
+          <a:p>
+            <a:pPr>
+              <a:spcAft>
+                <a:spcPts val="500"/>
+              </a:spcAft>
+            </a:pPr>
+          </a:p>
+          <a:p>
+            <a:pPr>
+              <a:spcAft>
+                <a:spcPts val="500"/>
+              </a:spcAft>
+            </a:pPr>
+            <a:r>
+              <a:rPr sz="950" b="0">
+                <a:solidFill>
+                  <a:srgbClr val="1A1A1A"/>
+                </a:solidFill>
+              </a:rPr>
+              <a:t>[7]  Deng, J., Guo, J., Ververas, E., Kotsia, I., Zafeiriou, S. (2020). RetinaFace: Single-Shot Multi-Level Face Localisation in the Wild. CVPR 2020. DOI: 10.1109/CVPR42600.2020.00525</a:t>
+            </a:r>
+          </a:p>
+          <a:p>
+            <a:pPr>
+              <a:spcAft>
+                <a:spcPts val="500"/>
+              </a:spcAft>
+            </a:pPr>
+          </a:p>
+          <a:p>
+            <a:pPr>
+              <a:spcAft>
+                <a:spcPts val="500"/>
+              </a:spcAft>
+            </a:pPr>
+            <a:r>
+              <a:rPr sz="950" b="0">
+                <a:solidFill>
+                  <a:srgbClr val="1A1A1A"/>
+                </a:solidFill>
+              </a:rPr>
+              <a:t>[8]  Pan, G., Sun, L., Wu, Z., Lao, S. (2007). Eyeblink-based Anti-Spoofing in Face Recognition from a Generic Webcamera. ICCV 2007, pp. 1–8. DOI: 10.1109/ICCV.2007.4409068</a:t>
+            </a:r>
+          </a:p>
+          <a:p>
+            <a:pPr>
+              <a:spcAft>
+                <a:spcPts val="500"/>
+              </a:spcAft>
+            </a:pPr>
+          </a:p>
+          <a:p>
+            <a:pPr>
+              <a:spcAft>
+                <a:spcPts val="500"/>
+              </a:spcAft>
+            </a:pPr>
+            <a:r>
+              <a:rPr sz="950" b="0">
+                <a:solidFill>
+                  <a:srgbClr val="1A1A1A"/>
+                </a:solidFill>
+              </a:rPr>
+              <a:t>[9]  ISO/IEC 30107-3:2023 — Information technology — Biometric presentation attack detection — Part 3: Testing and reporting.</a:t>
+            </a:r>
+          </a:p>
+          <a:p>
+            <a:pPr>
+              <a:spcAft>
+                <a:spcPts val="500"/>
+              </a:spcAft>
+            </a:pPr>
+          </a:p>
+          <a:p>
+            <a:pPr>
+              <a:spcAft>
+                <a:spcPts val="500"/>
+              </a:spcAft>
+            </a:pPr>
+            <a:r>
+              <a:rPr sz="950" b="0">
+                <a:solidFill>
+                  <a:srgbClr val="1A1A1A"/>
+                </a:solidFill>
+              </a:rPr>
+              <a:t>[10] Cao, Q., Shen, L., Xie, W., Parkhi, O. M., Zisserman, A. (2018). VGGFace2: A Dataset for Recognising Faces across Pose and Age. IEEE FG 2018, pp. 67–74.</a:t>
+            </a:r>
+          </a:p>
+          <a:p>
+            <a:pPr>
+              <a:spcAft>
+                <a:spcPts val="500"/>
+              </a:spcAft>
+            </a:pPr>
+          </a:p>
+          <a:p>
+            <a:pPr>
+              <a:spcAft>
+                <a:spcPts val="500"/>
+              </a:spcAft>
+            </a:pPr>
+            <a:r>
+              <a:rPr sz="950" b="1">
+                <a:solidFill>
+                  <a:srgbClr val="1F3A6E"/>
+                </a:solidFill>
+              </a:rPr>
+              <a:t>Source code and all measurement scripts: github.com/SohamBhattacharjee2003/MutiFace-Attendance-System</a:t>
+            </a:r>
+          </a:p>
+        </p:txBody>
+      </p:sp>
+    </p:spTree>
+  </p:cSld>
+  <p:clrMapOvr>
+    <a:masterClrMapping/>
+  </p:clrMapOvr>
+</p:sld>
+</file>
+
+<file path=ppt/slides/slide11.xml><?xml version="1.0" encoding="utf-8"?>
+<p:sld xmlns:a="http://schemas.openxmlformats.org/drawingml/2006/main" xmlns:p="http://schemas.openxmlformats.org/presentationml/2006/main" xmlns:r="http://schemas.openxmlformats.org/officeDocument/2006/relationships">
+  <p:cSld>
+    <p:spTree>
+      <p:nvGrpSpPr>
+        <p:cNvPr id="1" name=""/>
+        <p:cNvGrpSpPr/>
+        <p:nvPr/>
+      </p:nvGrpSpPr>
+      <p:grpSpPr/>
+      <p:sp>
+        <p:nvSpPr>
+          <p:cNvPr id="2" name="TextBox 1"/>
+          <p:cNvSpPr txBox="1"/>
+          <p:nvPr/>
+        </p:nvSpPr>
+        <p:spPr>
+          <a:xfrm>
+            <a:off x="731520" y="2743200"/>
+            <a:ext cx="10698480" cy="1280160"/>
+          </a:xfrm>
+          <a:prstGeom prst="rect">
+            <a:avLst/>
+          </a:prstGeom>
+          <a:noFill/>
+        </p:spPr>
+        <p:txBody>
+          <a:bodyPr wrap="none">
+            <a:spAutoFit/>
+          </a:bodyPr>
+          <a:lstStyle/>
+          <a:p>
+            <a:pPr algn="ctr"/>
+            <a:r>
+              <a:rPr sz="4800" b="1" i="1"/>
+              <a:t>THANK YOU</a:t>
             </a:r>
           </a:p>
         </p:txBody>
@@ -3343,8 +3676,8 @@
         </p:nvSpPr>
         <p:spPr>
           <a:xfrm>
-            <a:off x="411480" y="201168"/>
-            <a:ext cx="11338560" cy="685800"/>
+            <a:off x="365760" y="182880"/>
+            <a:ext cx="11430000" cy="640080"/>
           </a:xfrm>
           <a:prstGeom prst="rect">
             <a:avLst/>
@@ -3359,12 +3692,12 @@
           <a:p>
             <a:pPr algn="ctr"/>
             <a:r>
-              <a:rPr sz="3000" b="1">
+              <a:rPr sz="2800" b="1">
                 <a:solidFill>
                   <a:srgbClr val="1F3A6E"/>
                 </a:solidFill>
               </a:rPr>
-              <a:t>IDEA / PROPOSED SOLUTION</a:t>
+              <a:t>PROJECT TITLE</a:t>
             </a:r>
           </a:p>
         </p:txBody>
@@ -3377,8 +3710,8 @@
         </p:nvSpPr>
         <p:spPr>
           <a:xfrm>
-            <a:off x="502920" y="1051560"/>
-            <a:ext cx="6035040" cy="5120640"/>
+            <a:off x="2011680" y="2194560"/>
+            <a:ext cx="8229600" cy="3291840"/>
           </a:xfrm>
           <a:prstGeom prst="rect">
             <a:avLst/>
@@ -3397,445 +3730,101 @@
               </a:spcAft>
             </a:pPr>
             <a:r>
-              <a:rPr sz="1250" b="1">
+              <a:rPr sz="1600" b="1">
                 <a:solidFill>
                   <a:srgbClr val="1F3A6E"/>
                 </a:solidFill>
               </a:rPr>
-              <a:t>The problem nobody in the literature measures</a:t>
-            </a:r>
-          </a:p>
-          <a:p>
-            <a:pPr>
-              <a:spcAft>
-                <a:spcPts val="500"/>
-              </a:spcAft>
-            </a:pPr>
-            <a:r>
-              <a:rPr sz="1250" b="0">
-                <a:solidFill>
-                  <a:srgbClr val="1A1A1A"/>
-                </a:solidFill>
-              </a:rPr>
-              <a:t>Face recognition is BUILT to give a photo of you the same embedding as you.</a:t>
-            </a:r>
-          </a:p>
-          <a:p>
-            <a:pPr>
-              <a:spcAft>
-                <a:spcPts val="500"/>
-              </a:spcAft>
-            </a:pPr>
-            <a:r>
-              <a:rPr sz="1250" b="0">
-                <a:solidFill>
-                  <a:srgbClr val="1A1A1A"/>
-                </a:solidFill>
-              </a:rPr>
-              <a:t>So recognition alone cannot stop proxy attendance. We tested it:</a:t>
-            </a:r>
-          </a:p>
-          <a:p>
-            <a:pPr>
-              <a:spcAft>
-                <a:spcPts val="500"/>
-              </a:spcAft>
-            </a:pPr>
-            <a:r>
-              <a:rPr sz="1250" b="1">
+              <a:t>Automatic Attendance System using Multiple Face Recognition</a:t>
+            </a:r>
+          </a:p>
+          <a:p>
+            <a:pPr>
+              <a:spcAft>
+                <a:spcPts val="500"/>
+              </a:spcAft>
+            </a:pPr>
+          </a:p>
+          <a:p>
+            <a:pPr>
+              <a:spcAft>
+                <a:spcPts val="500"/>
+              </a:spcAft>
+            </a:pPr>
+            <a:r>
+              <a:rPr sz="1600" b="1">
+                <a:solidFill>
+                  <a:srgbClr val="1A1A1A"/>
+                </a:solidFill>
+              </a:rPr>
+              <a:t>Research focus</a:t>
+            </a:r>
+          </a:p>
+          <a:p>
+            <a:pPr>
+              <a:spcAft>
+                <a:spcPts val="500"/>
+              </a:spcAft>
+            </a:pPr>
+            <a:r>
+              <a:rPr sz="1600" b="0">
+                <a:solidFill>
+                  <a:srgbClr val="1A1A1A"/>
+                </a:solidFill>
+              </a:rPr>
+              <a:t>A state-of-the-art face model still marks a printed photograph present</a:t>
+            </a:r>
+          </a:p>
+          <a:p>
+            <a:pPr>
+              <a:spcAft>
+                <a:spcPts val="500"/>
+              </a:spcAft>
+            </a:pPr>
+            <a:r>
+              <a:rPr sz="1600" b="1">
                 <a:solidFill>
                   <a:srgbClr val="C0392B"/>
                 </a:solidFill>
               </a:rPr>
-              <a:t>a printed photo was marked present 100% of the time.</a:t>
-            </a:r>
-          </a:p>
-          <a:p>
-            <a:pPr>
-              <a:spcAft>
-                <a:spcPts val="500"/>
-              </a:spcAft>
-            </a:pPr>
-          </a:p>
-          <a:p>
-            <a:pPr>
-              <a:spcAft>
-                <a:spcPts val="500"/>
-              </a:spcAft>
-            </a:pPr>
-            <a:r>
-              <a:rPr sz="1250" b="1">
-                <a:solidFill>
-                  <a:srgbClr val="1F3A6E"/>
-                </a:solidFill>
-              </a:rPr>
-              <a:t>Our solution — separate RECOGNISING from MARKING PRESENT</a:t>
-            </a:r>
-          </a:p>
-          <a:p>
-            <a:pPr>
-              <a:spcAft>
-                <a:spcPts val="500"/>
-              </a:spcAft>
-            </a:pPr>
-            <a:r>
-              <a:rPr sz="1250" b="0">
-                <a:solidFill>
-                  <a:srgbClr val="1A1A1A"/>
-                </a:solidFill>
-              </a:rPr>
-              <a:t>Attendance is written once a day and is irreversible: one bad frame marks the</a:t>
-            </a:r>
-          </a:p>
-          <a:p>
-            <a:pPr>
-              <a:spcAft>
-                <a:spcPts val="500"/>
-              </a:spcAft>
-            </a:pPr>
-            <a:r>
-              <a:rPr sz="1250" b="0">
-                <a:solidFill>
-                  <a:srgbClr val="1A1A1A"/>
-                </a:solidFill>
-              </a:rPr>
-              <a:t>wrong student present until tomorrow. So committing is its own decision, taken</a:t>
-            </a:r>
-          </a:p>
-          <a:p>
-            <a:pPr>
-              <a:spcAft>
-                <a:spcPts val="500"/>
-              </a:spcAft>
-            </a:pPr>
-            <a:r>
-              <a:rPr sz="1250" b="0">
-                <a:solidFill>
-                  <a:srgbClr val="1A1A1A"/>
-                </a:solidFill>
-              </a:rPr>
-              <a:t>only after four gates pass and several frames agree:</a:t>
-            </a:r>
-          </a:p>
-          <a:p>
-            <a:pPr lvl="1">
-              <a:spcAft>
-                <a:spcPts val="500"/>
-              </a:spcAft>
-            </a:pPr>
-            <a:r>
-              <a:rPr sz="1250" b="0">
-                <a:solidFill>
-                  <a:srgbClr val="1A1A1A"/>
-                </a:solidFill>
-              </a:rPr>
-              <a:t>1.  Size — a face under 40px is refused, not guessed at</a:t>
-            </a:r>
-          </a:p>
-          <a:p>
-            <a:pPr lvl="1">
-              <a:spcAft>
-                <a:spcPts val="500"/>
-              </a:spcAft>
-            </a:pPr>
-            <a:r>
-              <a:rPr sz="1250" b="0">
-                <a:solidFill>
-                  <a:srgbClr val="1A1A1A"/>
-                </a:solidFill>
-              </a:rPr>
-              <a:t>2.  Threshold — calibrated on 2,880 impostor faces, not hand-picked</a:t>
-            </a:r>
-          </a:p>
-          <a:p>
-            <a:pPr lvl="1">
-              <a:spcAft>
-                <a:spcPts val="500"/>
-              </a:spcAft>
-            </a:pPr>
-            <a:r>
-              <a:rPr sz="1250" b="0">
-                <a:solidFill>
-                  <a:srgbClr val="1A1A1A"/>
-                </a:solidFill>
-              </a:rPr>
-              <a:t>3.  Margin — the runner-up identity must be clearly beaten</a:t>
-            </a:r>
-          </a:p>
-          <a:p>
-            <a:pPr lvl="1">
-              <a:spcAft>
-                <a:spcPts val="500"/>
-              </a:spcAft>
-            </a:pPr>
-            <a:r>
-              <a:rPr sz="1250" b="1">
-                <a:solidFill>
-                  <a:srgbClr val="C0392B"/>
-                </a:solidFill>
-              </a:rPr>
-              <a:t>4.  LIVENESS — is this a person, or a photograph of one?</a:t>
-            </a:r>
-          </a:p>
-        </p:txBody>
-      </p:sp>
-      <p:sp>
-        <p:nvSpPr>
-          <p:cNvPr id="4" name="TextBox 3"/>
-          <p:cNvSpPr txBox="1"/>
-          <p:nvPr/>
-        </p:nvSpPr>
-        <p:spPr>
-          <a:xfrm>
-            <a:off x="6766560" y="1051560"/>
-            <a:ext cx="5029200" cy="5120640"/>
-          </a:xfrm>
-          <a:prstGeom prst="rect">
-            <a:avLst/>
-          </a:prstGeom>
-          <a:noFill/>
-        </p:spPr>
-        <p:txBody>
-          <a:bodyPr wrap="square">
-            <a:spAutoFit/>
-          </a:bodyPr>
-          <a:lstStyle/>
-          <a:p>
-            <a:pPr>
-              <a:spcAft>
-                <a:spcPts val="500"/>
-              </a:spcAft>
-            </a:pPr>
-            <a:r>
-              <a:rPr sz="1150" b="1">
-                <a:solidFill>
-                  <a:srgbClr val="1F3A6E"/>
-                </a:solidFill>
-              </a:rPr>
-              <a:t>Innovation and uniqueness</a:t>
-            </a:r>
-          </a:p>
-          <a:p>
-            <a:pPr>
-              <a:spcAft>
-                <a:spcPts val="500"/>
-              </a:spcAft>
-            </a:pPr>
-          </a:p>
-          <a:p>
-            <a:pPr>
-              <a:spcAft>
-                <a:spcPts val="500"/>
-              </a:spcAft>
-            </a:pPr>
-            <a:r>
-              <a:rPr sz="1150" b="1">
-                <a:solidFill>
-                  <a:srgbClr val="1A1A1A"/>
-                </a:solidFill>
-              </a:rPr>
-              <a:t>• We do NOT claim a new face model.</a:t>
-            </a:r>
-          </a:p>
-          <a:p>
-            <a:pPr>
-              <a:spcAft>
-                <a:spcPts val="500"/>
-              </a:spcAft>
-            </a:pPr>
-            <a:r>
-              <a:rPr sz="1150" b="0">
-                <a:solidFill>
-                  <a:srgbClr val="1A1A1A"/>
-                </a:solidFill>
-              </a:rPr>
-              <a:t>ArcFace is pretrained and frozen. Claiming otherwise would be dishonest, and</a:t>
-            </a:r>
-          </a:p>
-          <a:p>
-            <a:pPr>
-              <a:spcAft>
-                <a:spcPts val="500"/>
-              </a:spcAft>
-            </a:pPr>
-            <a:r>
-              <a:rPr sz="1150" b="0">
-                <a:solidFill>
-                  <a:srgbClr val="1A1A1A"/>
-                </a:solidFill>
-              </a:rPr>
-              <a:t>training our own on 30 students would be worse in every measurable way.</a:t>
-            </a:r>
-          </a:p>
-          <a:p>
-            <a:pPr>
-              <a:spcAft>
-                <a:spcPts val="500"/>
-              </a:spcAft>
-            </a:pPr>
-          </a:p>
-          <a:p>
-            <a:pPr>
-              <a:spcAft>
-                <a:spcPts val="500"/>
-              </a:spcAft>
-            </a:pPr>
-            <a:r>
-              <a:rPr sz="1150" b="1">
-                <a:solidFill>
-                  <a:srgbClr val="1A1A1A"/>
-                </a:solidFill>
-              </a:rPr>
-              <a:t>• Liveness that works on classroom hardware.</a:t>
-            </a:r>
-          </a:p>
-          <a:p>
-            <a:pPr>
-              <a:spcAft>
-                <a:spcPts val="500"/>
-              </a:spcAft>
-            </a:pPr>
-            <a:r>
-              <a:rPr sz="1150" b="0">
-                <a:solidFill>
-                  <a:srgbClr val="1A1A1A"/>
-                </a:solidFill>
-              </a:rPr>
-              <a:t>Blink detection is the standard trick, but a blink lasts ~0.3s and our system</a:t>
-            </a:r>
-          </a:p>
-          <a:p>
-            <a:pPr>
-              <a:spcAft>
-                <a:spcPts val="500"/>
-              </a:spcAft>
-            </a:pPr>
-            <a:r>
-              <a:rPr sz="1150" b="0">
-                <a:solidFill>
-                  <a:srgbClr val="1A1A1A"/>
-                </a:solidFill>
-              </a:rPr>
-              <a:t>samples ~1.4 frames/sec — we measured it failing. Instead we measure facial</a:t>
-            </a:r>
-          </a:p>
-          <a:p>
-            <a:pPr>
-              <a:spcAft>
-                <a:spcPts val="500"/>
-              </a:spcAft>
-            </a:pPr>
-            <a:r>
-              <a:rPr sz="1150" b="0">
-                <a:solidFill>
-                  <a:srgbClr val="1A1A1A"/>
-                </a:solidFill>
-              </a:rPr>
-              <a:t>motion from landmarks the detector already produces: a live face keeps</a:t>
-            </a:r>
-          </a:p>
-          <a:p>
-            <a:pPr>
-              <a:spcAft>
-                <a:spcPts val="500"/>
-              </a:spcAft>
-            </a:pPr>
-            <a:r>
-              <a:rPr sz="1150" b="0">
-                <a:solidFill>
-                  <a:srgbClr val="1A1A1A"/>
-                </a:solidFill>
-              </a:rPr>
-              <a:t>deforming, a photo is rigid. Rotation and scale are normalised away, so waving</a:t>
-            </a:r>
-          </a:p>
-          <a:p>
-            <a:pPr>
-              <a:spcAft>
-                <a:spcPts val="500"/>
-              </a:spcAft>
-            </a:pPr>
-            <a:r>
-              <a:rPr sz="1150" b="0">
-                <a:solidFill>
-                  <a:srgbClr val="1A1A1A"/>
-                </a:solidFill>
-              </a:rPr>
-              <a:t>the photo about does not help the attacker. No extra model, no GPU.</a:t>
-            </a:r>
-          </a:p>
-          <a:p>
-            <a:pPr>
-              <a:spcAft>
-                <a:spcPts val="500"/>
-              </a:spcAft>
-            </a:pPr>
-          </a:p>
-          <a:p>
-            <a:pPr>
-              <a:spcAft>
-                <a:spcPts val="500"/>
-              </a:spcAft>
-            </a:pPr>
-            <a:r>
-              <a:rPr sz="1150" b="1">
-                <a:solidFill>
-                  <a:srgbClr val="1A1A1A"/>
-                </a:solidFill>
-              </a:rPr>
-              <a:t>• Enrolment in 1.4s, not 10 minutes.</a:t>
-            </a:r>
-          </a:p>
-          <a:p>
-            <a:pPr>
-              <a:spcAft>
-                <a:spcPts val="500"/>
-              </a:spcAft>
-            </a:pPr>
-            <a:r>
-              <a:rPr sz="1150" b="0">
-                <a:solidFill>
-                  <a:srgbClr val="1A1A1A"/>
-                </a:solidFill>
-              </a:rPr>
-              <a:t>Embeddings are cached, so a new student costs only their own photos.</a:t>
-            </a:r>
-          </a:p>
-          <a:p>
-            <a:pPr>
-              <a:spcAft>
-                <a:spcPts val="500"/>
-              </a:spcAft>
-            </a:pPr>
-          </a:p>
-          <a:p>
-            <a:pPr>
-              <a:spcAft>
-                <a:spcPts val="500"/>
-              </a:spcAft>
-            </a:pPr>
-            <a:r>
-              <a:rPr sz="1150" b="1">
-                <a:solidFill>
-                  <a:srgbClr val="1E8E5A"/>
-                </a:solidFill>
-              </a:rPr>
-              <a:t>• We report a fix that did NOT work.</a:t>
-            </a:r>
-          </a:p>
-          <a:p>
-            <a:pPr>
-              <a:spcAft>
-                <a:spcPts val="500"/>
-              </a:spcAft>
-            </a:pPr>
-            <a:r>
-              <a:rPr sz="1150" b="0">
-                <a:solidFill>
-                  <a:srgbClr val="1A1A1A"/>
-                </a:solidFill>
-              </a:rPr>
-              <a:t>The top-2 margin guard changed nothing on our cohort. We say so.</a:t>
+              <a:t>100% of the time. We measured it, and we fixed it.</a:t>
+            </a:r>
+          </a:p>
+          <a:p>
+            <a:pPr>
+              <a:spcAft>
+                <a:spcPts val="500"/>
+              </a:spcAft>
+            </a:pPr>
+          </a:p>
+          <a:p>
+            <a:pPr>
+              <a:spcAft>
+                <a:spcPts val="500"/>
+              </a:spcAft>
+            </a:pPr>
+            <a:r>
+              <a:rPr sz="1600" b="0">
+                <a:solidFill>
+                  <a:srgbClr val="1A1A1A"/>
+                </a:solidFill>
+              </a:rPr>
+              <a:t>Detecting and recognising every face in one frame — and then deciding,</a:t>
+            </a:r>
+          </a:p>
+          <a:p>
+            <a:pPr>
+              <a:spcAft>
+                <a:spcPts val="500"/>
+              </a:spcAft>
+            </a:pPr>
+            <a:r>
+              <a:rPr sz="1600" b="0">
+                <a:solidFill>
+                  <a:srgbClr val="1A1A1A"/>
+                </a:solidFill>
+              </a:rPr>
+              <a:t>separately and carefully, who is actually PRESENT.</a:t>
             </a:r>
           </a:p>
         </p:txBody>
@@ -3866,8 +3855,8 @@
         </p:nvSpPr>
         <p:spPr>
           <a:xfrm>
-            <a:off x="411480" y="201168"/>
-            <a:ext cx="11338560" cy="685800"/>
+            <a:off x="365760" y="182880"/>
+            <a:ext cx="11430000" cy="640080"/>
           </a:xfrm>
           <a:prstGeom prst="rect">
             <a:avLst/>
@@ -3882,50 +3871,26 @@
           <a:p>
             <a:pPr algn="ctr"/>
             <a:r>
-              <a:rPr sz="3000" b="1">
+              <a:rPr sz="2800" b="1">
                 <a:solidFill>
                   <a:srgbClr val="1F3A6E"/>
                 </a:solidFill>
               </a:rPr>
-              <a:t>TECHNICAL APPROACH &amp; WORKFLOW</a:t>
-            </a:r>
-          </a:p>
-        </p:txBody>
-      </p:sp>
-      <p:pic>
-        <p:nvPicPr>
-          <p:cNvPr id="3" name="Picture 2" descr="workflow.png"/>
-          <p:cNvPicPr>
-            <a:picLocks noChangeAspect="1"/>
-          </p:cNvPicPr>
+              <a:t>OBJECTIVE OF THE PROJECT</a:t>
+            </a:r>
+          </a:p>
+        </p:txBody>
+      </p:sp>
+      <p:sp>
+        <p:nvSpPr>
+          <p:cNvPr id="3" name="TextBox 2"/>
+          <p:cNvSpPr txBox="1"/>
           <p:nvPr/>
-        </p:nvPicPr>
-        <p:blipFill>
-          <a:blip r:embed="rId2"/>
-          <a:stretch>
-            <a:fillRect/>
-          </a:stretch>
-        </p:blipFill>
+        </p:nvSpPr>
         <p:spPr>
           <a:xfrm>
-            <a:off x="457200" y="1005840"/>
-            <a:ext cx="11247120" cy="2346558"/>
-          </a:xfrm>
-          <a:prstGeom prst="rect">
-            <a:avLst/>
-          </a:prstGeom>
-        </p:spPr>
-      </p:pic>
-      <p:sp>
-        <p:nvSpPr>
-          <p:cNvPr id="4" name="TextBox 3"/>
-          <p:cNvSpPr txBox="1"/>
-          <p:nvPr/>
-        </p:nvSpPr>
-        <p:spPr>
-          <a:xfrm>
-            <a:off x="502920" y="3200400"/>
-            <a:ext cx="5669280" cy="3108960"/>
+            <a:off x="1097280" y="1188720"/>
+            <a:ext cx="10058400" cy="5029200"/>
           </a:xfrm>
           <a:prstGeom prst="rect">
             <a:avLst/>
@@ -3944,282 +3909,175 @@
               </a:spcAft>
             </a:pPr>
             <a:r>
-              <a:rPr sz="1200" b="1">
-                <a:solidFill>
-                  <a:srgbClr val="1F3A6E"/>
-                </a:solidFill>
-              </a:rPr>
-              <a:t>Technologies</a:t>
-            </a:r>
-          </a:p>
-          <a:p>
-            <a:pPr>
-              <a:spcAft>
-                <a:spcPts val="500"/>
-              </a:spcAft>
-            </a:pPr>
-            <a:r>
-              <a:rPr sz="1200" b="0">
-                <a:solidFill>
-                  <a:srgbClr val="1A1A1A"/>
-                </a:solidFill>
-              </a:rPr>
-              <a:t>Detection: RetinaFace / SCRFD (det_10g)</a:t>
-            </a:r>
-          </a:p>
-          <a:p>
-            <a:pPr>
-              <a:spcAft>
-                <a:spcPts val="500"/>
-              </a:spcAft>
-            </a:pPr>
-            <a:r>
-              <a:rPr sz="1200" b="0">
-                <a:solidFill>
-                  <a:srgbClr val="1A1A1A"/>
-                </a:solidFill>
-              </a:rPr>
-              <a:t>Recognition: ArcFace ResNet-50 (buffalo_l, w600k_r50) → 512-d embeddings</a:t>
-            </a:r>
-          </a:p>
-          <a:p>
-            <a:pPr>
-              <a:spcAft>
-                <a:spcPts val="500"/>
-              </a:spcAft>
-            </a:pPr>
-            <a:r>
-              <a:rPr sz="1200" b="0">
-                <a:solidFill>
-                  <a:srgbClr val="1A1A1A"/>
-                </a:solidFill>
-              </a:rPr>
-              <a:t>Runtime: ONNX Runtime, CPU only — no GPU required</a:t>
-            </a:r>
-          </a:p>
-          <a:p>
-            <a:pPr>
-              <a:spcAft>
-                <a:spcPts val="500"/>
-              </a:spcAft>
-            </a:pPr>
-            <a:r>
-              <a:rPr sz="1200" b="0">
-                <a:solidFill>
-                  <a:srgbClr val="1A1A1A"/>
-                </a:solidFill>
-              </a:rPr>
-              <a:t>Classifier: linear SVM + cosine-to-centroid over scikit-learn</a:t>
-            </a:r>
-          </a:p>
-          <a:p>
-            <a:pPr>
-              <a:spcAft>
-                <a:spcPts val="500"/>
-              </a:spcAft>
-            </a:pPr>
-            <a:r>
-              <a:rPr sz="1200" b="0">
-                <a:solidFill>
-                  <a:srgbClr val="1A1A1A"/>
-                </a:solidFill>
-              </a:rPr>
-              <a:t>Backend: Python 3.13 · Flask REST API · token auth</a:t>
-            </a:r>
-          </a:p>
-          <a:p>
-            <a:pPr>
-              <a:spcAft>
-                <a:spcPts val="500"/>
-              </a:spcAft>
-            </a:pPr>
-            <a:r>
-              <a:rPr sz="1200" b="0">
-                <a:solidFill>
-                  <a:srgbClr val="1A1A1A"/>
-                </a:solidFill>
-              </a:rPr>
-              <a:t>Frontend: React · Vite · TailwindCSS</a:t>
-            </a:r>
-          </a:p>
-          <a:p>
-            <a:pPr>
-              <a:spcAft>
-                <a:spcPts val="500"/>
-              </a:spcAft>
-            </a:pPr>
-            <a:r>
-              <a:rPr sz="1200" b="0">
-                <a:solidFill>
-                  <a:srgbClr val="1A1A1A"/>
-                </a:solidFill>
-              </a:rPr>
-              <a:t>Storage: CSV + JSON on disk — no cloud, no database server</a:t>
-            </a:r>
-          </a:p>
-        </p:txBody>
-      </p:sp>
-      <p:sp>
-        <p:nvSpPr>
-          <p:cNvPr id="5" name="TextBox 4"/>
-          <p:cNvSpPr txBox="1"/>
-          <p:nvPr/>
-        </p:nvSpPr>
-        <p:spPr>
-          <a:xfrm>
-            <a:off x="6400800" y="3200400"/>
-            <a:ext cx="5394960" cy="3108960"/>
-          </a:xfrm>
-          <a:prstGeom prst="rect">
-            <a:avLst/>
-          </a:prstGeom>
-          <a:noFill/>
-        </p:spPr>
-        <p:txBody>
-          <a:bodyPr wrap="square">
-            <a:spAutoFit/>
-          </a:bodyPr>
-          <a:lstStyle/>
-          <a:p>
-            <a:pPr>
-              <a:spcAft>
-                <a:spcPts val="500"/>
-              </a:spcAft>
-            </a:pPr>
-            <a:r>
-              <a:rPr sz="1150" b="1">
-                <a:solidFill>
-                  <a:srgbClr val="1F3A6E"/>
-                </a:solidFill>
-              </a:rPr>
-              <a:t>Method — why it is built this way</a:t>
-            </a:r>
-          </a:p>
-          <a:p>
-            <a:pPr>
-              <a:spcAft>
-                <a:spcPts val="500"/>
-              </a:spcAft>
-            </a:pPr>
-            <a:r>
-              <a:rPr sz="1150" b="1">
-                <a:solidFill>
-                  <a:srgbClr val="1A1A1A"/>
-                </a:solidFill>
-              </a:rPr>
-              <a:t>The deep model is frozen and never retrained.</a:t>
-            </a:r>
-          </a:p>
-          <a:p>
-            <a:pPr>
-              <a:spcAft>
-                <a:spcPts val="500"/>
-              </a:spcAft>
-            </a:pPr>
-            <a:r>
-              <a:rPr sz="1150" b="0">
-                <a:solidFill>
-                  <a:srgbClr val="1A1A1A"/>
-                </a:solidFill>
-              </a:rPr>
-              <a:t>It was trained on ~600k identities; what it learned is not 'who is Soham' but</a:t>
-            </a:r>
-          </a:p>
-          <a:p>
-            <a:pPr>
-              <a:spcAft>
-                <a:spcPts val="500"/>
-              </a:spcAft>
-            </a:pPr>
-            <a:r>
-              <a:rPr sz="1150" b="0">
-                <a:solidFill>
-                  <a:srgbClr val="1A1A1A"/>
-                </a:solidFill>
-              </a:rPr>
-              <a:t>'what makes any two faces different'. Enrolling a student = embed their photos</a:t>
-            </a:r>
-          </a:p>
-          <a:p>
-            <a:pPr>
-              <a:spcAft>
-                <a:spcPts val="500"/>
-              </a:spcAft>
-            </a:pPr>
-            <a:r>
-              <a:rPr sz="1150" b="0">
-                <a:solidFill>
-                  <a:srgbClr val="1A1A1A"/>
-                </a:solidFill>
-              </a:rPr>
-              <a:t>and store the average (their centroid). That is a table insert, not a training run.</a:t>
-            </a:r>
-          </a:p>
-          <a:p>
-            <a:pPr>
-              <a:spcAft>
-                <a:spcPts val="500"/>
-              </a:spcAft>
-            </a:pPr>
-          </a:p>
-          <a:p>
-            <a:pPr>
-              <a:spcAft>
-                <a:spcPts val="500"/>
-              </a:spcAft>
-            </a:pPr>
-            <a:r>
-              <a:rPr sz="1150" b="1">
-                <a:solidFill>
-                  <a:srgbClr val="1A1A1A"/>
-                </a:solidFill>
-              </a:rPr>
-              <a:t>Closed-set vs open-set — the key difference</a:t>
-            </a:r>
-          </a:p>
-          <a:p>
-            <a:pPr>
-              <a:spcAft>
-                <a:spcPts val="500"/>
-              </a:spcAft>
-            </a:pPr>
-            <a:r>
-              <a:rPr sz="1150" b="0">
-                <a:solidFill>
-                  <a:srgbClr val="1A1A1A"/>
-                </a:solidFill>
-              </a:rPr>
-              <a:t>Prior work asks 'WHICH of my N students is this?' — a softmax must always name</a:t>
-            </a:r>
-          </a:p>
-          <a:p>
-            <a:pPr>
-              <a:spcAft>
-                <a:spcPts val="500"/>
-              </a:spcAft>
-            </a:pPr>
-            <a:r>
-              <a:rPr sz="1150" b="0">
-                <a:solidFill>
-                  <a:srgbClr val="1A1A1A"/>
-                </a:solidFill>
-              </a:rPr>
-              <a:t>someone. We ask 'is this ANY of my students at all?' The system is allowed to</a:t>
-            </a:r>
-          </a:p>
-          <a:p>
-            <a:pPr>
-              <a:spcAft>
-                <a:spcPts val="500"/>
-              </a:spcAft>
-            </a:pPr>
-            <a:r>
-              <a:rPr sz="1150" b="0">
-                <a:solidFill>
-                  <a:srgbClr val="1A1A1A"/>
-                </a:solidFill>
-              </a:rPr>
-              <a:t>answer 'nobody', which is the only honest answer when a stranger walks past.</a:t>
+              <a:rPr sz="1350" b="1">
+                <a:solidFill>
+                  <a:srgbClr val="1A1A1A"/>
+                </a:solidFill>
+              </a:rPr>
+              <a:t>1.  Automate attendance using multi-face recognition</a:t>
+            </a:r>
+          </a:p>
+          <a:p>
+            <a:pPr>
+              <a:spcAft>
+                <a:spcPts val="500"/>
+              </a:spcAft>
+            </a:pPr>
+            <a:r>
+              <a:rPr sz="1350" b="0">
+                <a:solidFill>
+                  <a:srgbClr val="1A1A1A"/>
+                </a:solidFill>
+              </a:rPr>
+              <a:t>Detect and identify every face in a single frame, not one person at a time.</a:t>
+            </a:r>
+          </a:p>
+          <a:p>
+            <a:pPr>
+              <a:spcAft>
+                <a:spcPts val="500"/>
+              </a:spcAft>
+            </a:pPr>
+          </a:p>
+          <a:p>
+            <a:pPr>
+              <a:spcAft>
+                <a:spcPts val="500"/>
+              </a:spcAft>
+            </a:pPr>
+            <a:r>
+              <a:rPr sz="1350" b="1">
+                <a:solidFill>
+                  <a:srgbClr val="1A1A1A"/>
+                </a:solidFill>
+              </a:rPr>
+              <a:t>2.  Reject strangers — an open-set system</a:t>
+            </a:r>
+          </a:p>
+          <a:p>
+            <a:pPr>
+              <a:spcAft>
+                <a:spcPts val="500"/>
+              </a:spcAft>
+            </a:pPr>
+            <a:r>
+              <a:rPr sz="1350" b="0">
+                <a:solidFill>
+                  <a:srgbClr val="1A1A1A"/>
+                </a:solidFill>
+              </a:rPr>
+              <a:t>A classifier must always name someone. Ours is allowed to answer 'nobody'.</a:t>
+            </a:r>
+          </a:p>
+          <a:p>
+            <a:pPr>
+              <a:spcAft>
+                <a:spcPts val="500"/>
+              </a:spcAft>
+            </a:pPr>
+          </a:p>
+          <a:p>
+            <a:pPr>
+              <a:spcAft>
+                <a:spcPts val="500"/>
+              </a:spcAft>
+            </a:pPr>
+            <a:r>
+              <a:rPr sz="1350" b="1">
+                <a:solidFill>
+                  <a:srgbClr val="C0392B"/>
+                </a:solidFill>
+              </a:rPr>
+              <a:t>3.  Resist presentation attacks (photo / screen spoofing)</a:t>
+            </a:r>
+          </a:p>
+          <a:p>
+            <a:pPr>
+              <a:spcAft>
+                <a:spcPts val="500"/>
+              </a:spcAft>
+            </a:pPr>
+            <a:r>
+              <a:rPr sz="1350" b="0">
+                <a:solidFill>
+                  <a:srgbClr val="1A1A1A"/>
+                </a:solidFill>
+              </a:rPr>
+              <a:t>Recognition alone cannot tell a person from a photo of that person.</a:t>
+            </a:r>
+          </a:p>
+          <a:p>
+            <a:pPr>
+              <a:spcAft>
+                <a:spcPts val="500"/>
+              </a:spcAft>
+            </a:pPr>
+          </a:p>
+          <a:p>
+            <a:pPr>
+              <a:spcAft>
+                <a:spcPts val="500"/>
+              </a:spcAft>
+            </a:pPr>
+            <a:r>
+              <a:rPr sz="1350" b="1">
+                <a:solidFill>
+                  <a:srgbClr val="1A1A1A"/>
+                </a:solidFill>
+              </a:rPr>
+              <a:t>4.  Make the attendance commit reliable, not just the recognition</a:t>
+            </a:r>
+          </a:p>
+          <a:p>
+            <a:pPr>
+              <a:spcAft>
+                <a:spcPts val="500"/>
+              </a:spcAft>
+            </a:pPr>
+            <a:r>
+              <a:rPr sz="1350" b="0">
+                <a:solidFill>
+                  <a:srgbClr val="1A1A1A"/>
+                </a:solidFill>
+              </a:rPr>
+              <a:t>Attendance is irreversible — one bad frame must not mark the wrong student.</a:t>
+            </a:r>
+          </a:p>
+          <a:p>
+            <a:pPr>
+              <a:spcAft>
+                <a:spcPts val="500"/>
+              </a:spcAft>
+            </a:pPr>
+          </a:p>
+          <a:p>
+            <a:pPr>
+              <a:spcAft>
+                <a:spcPts val="500"/>
+              </a:spcAft>
+            </a:pPr>
+            <a:r>
+              <a:rPr sz="1350" b="1">
+                <a:solidFill>
+                  <a:srgbClr val="1A1A1A"/>
+                </a:solidFill>
+              </a:rPr>
+              <a:t>5.  Run on ordinary hardware, offline</a:t>
+            </a:r>
+          </a:p>
+          <a:p>
+            <a:pPr>
+              <a:spcAft>
+                <a:spcPts val="500"/>
+              </a:spcAft>
+            </a:pPr>
+            <a:r>
+              <a:rPr sz="1350" b="0">
+                <a:solidFill>
+                  <a:srgbClr val="1A1A1A"/>
+                </a:solidFill>
+              </a:rPr>
+              <a:t>One laptop, one webcam, no GPU, no cloud, no student data leaving campus.</a:t>
             </a:r>
           </a:p>
         </p:txBody>
@@ -4250,8 +4108,8 @@
         </p:nvSpPr>
         <p:spPr>
           <a:xfrm>
-            <a:off x="411480" y="201168"/>
-            <a:ext cx="11338560" cy="685800"/>
+            <a:off x="365760" y="182880"/>
+            <a:ext cx="11430000" cy="640080"/>
           </a:xfrm>
           <a:prstGeom prst="rect">
             <a:avLst/>
@@ -4266,12 +4124,12 @@
           <a:p>
             <a:pPr algn="ctr"/>
             <a:r>
-              <a:rPr sz="3000" b="1">
+              <a:rPr sz="2800" b="1">
                 <a:solidFill>
                   <a:srgbClr val="1F3A6E"/>
                 </a:solidFill>
               </a:rPr>
-              <a:t>RESULTS</a:t>
+              <a:t>PROBLEM DEFINITION</a:t>
             </a:r>
           </a:p>
         </p:txBody>
@@ -4284,8 +4142,8 @@
         </p:nvSpPr>
         <p:spPr>
           <a:xfrm>
-            <a:off x="457200" y="868680"/>
-            <a:ext cx="11338560" cy="365760"/>
+            <a:off x="640080" y="1097280"/>
+            <a:ext cx="10972800" cy="1463040"/>
           </a:xfrm>
           <a:prstGeom prst="rect">
             <a:avLst/>
@@ -4293,25 +4151,957 @@
           <a:noFill/>
         </p:spPr>
         <p:txBody>
+          <a:bodyPr wrap="square">
+            <a:spAutoFit/>
+          </a:bodyPr>
+          <a:lstStyle/>
+          <a:p>
+            <a:pPr>
+              <a:spcAft>
+                <a:spcPts val="500"/>
+              </a:spcAft>
+            </a:pPr>
+            <a:r>
+              <a:rPr sz="1400" b="1">
+                <a:solidFill>
+                  <a:srgbClr val="1A1A1A"/>
+                </a:solidFill>
+              </a:rPr>
+              <a:t>Traditional manual attendance is slow, error-prone and open to proxy marking.</a:t>
+            </a:r>
+          </a:p>
+          <a:p>
+            <a:pPr>
+              <a:spcAft>
+                <a:spcPts val="500"/>
+              </a:spcAft>
+            </a:pPr>
+            <a:r>
+              <a:rPr sz="1400" b="0">
+                <a:solidFill>
+                  <a:srgbClr val="1A1A1A"/>
+                </a:solidFill>
+              </a:rPr>
+              <a:t>A 60-student roll-call costs ~5 minutes of every lecture — roughly 80 hours a year.</a:t>
+            </a:r>
+          </a:p>
+          <a:p>
+            <a:pPr>
+              <a:spcAft>
+                <a:spcPts val="500"/>
+              </a:spcAft>
+            </a:pPr>
+          </a:p>
+          <a:p>
+            <a:pPr>
+              <a:spcAft>
+                <a:spcPts val="500"/>
+              </a:spcAft>
+            </a:pPr>
+            <a:r>
+              <a:rPr sz="1400" b="1">
+                <a:solidFill>
+                  <a:srgbClr val="1F3A6E"/>
+                </a:solidFill>
+              </a:rPr>
+              <a:t>But automating it with face recognition introduces a NEW problem, and this is the</a:t>
+            </a:r>
+          </a:p>
+          <a:p>
+            <a:pPr>
+              <a:spcAft>
+                <a:spcPts val="500"/>
+              </a:spcAft>
+            </a:pPr>
+            <a:r>
+              <a:rPr sz="1400" b="1">
+                <a:solidFill>
+                  <a:srgbClr val="1F3A6E"/>
+                </a:solidFill>
+              </a:rPr>
+              <a:t>gap our project addresses:</a:t>
+            </a:r>
+          </a:p>
+        </p:txBody>
+      </p:sp>
+      <p:sp>
+        <p:nvSpPr>
+          <p:cNvPr id="4" name="TextBox 3"/>
+          <p:cNvSpPr txBox="1"/>
+          <p:nvPr/>
+        </p:nvSpPr>
+        <p:spPr>
+          <a:xfrm>
+            <a:off x="822960" y="2834640"/>
+            <a:ext cx="10607040" cy="1280160"/>
+          </a:xfrm>
+          <a:prstGeom prst="rect">
+            <a:avLst/>
+          </a:prstGeom>
+          <a:noFill/>
+        </p:spPr>
+        <p:txBody>
+          <a:bodyPr wrap="square">
+            <a:spAutoFit/>
+          </a:bodyPr>
+          <a:lstStyle/>
+          <a:p>
+            <a:pPr>
+              <a:spcAft>
+                <a:spcPts val="500"/>
+              </a:spcAft>
+            </a:pPr>
+            <a:r>
+              <a:rPr sz="1500" b="1">
+                <a:solidFill>
+                  <a:srgbClr val="C0392B"/>
+                </a:solidFill>
+              </a:rPr>
+              <a:t>Face recognition is DESIGNED to give a photo of you the same embedding as you.</a:t>
+            </a:r>
+          </a:p>
+          <a:p>
+            <a:pPr>
+              <a:spcAft>
+                <a:spcPts val="500"/>
+              </a:spcAft>
+            </a:pPr>
+            <a:r>
+              <a:rPr sz="1500" b="1">
+                <a:solidFill>
+                  <a:srgbClr val="C0392B"/>
+                </a:solidFill>
+              </a:rPr>
+              <a:t>That is what makes it a good face model — and it is why recognition alone</a:t>
+            </a:r>
+          </a:p>
+          <a:p>
+            <a:pPr>
+              <a:spcAft>
+                <a:spcPts val="500"/>
+              </a:spcAft>
+            </a:pPr>
+            <a:r>
+              <a:rPr sz="1500" b="1">
+                <a:solidFill>
+                  <a:srgbClr val="C0392B"/>
+                </a:solidFill>
+              </a:rPr>
+              <a:t>cannot prevent proxy attendance. We tested it: a printed photo was marked</a:t>
+            </a:r>
+          </a:p>
+          <a:p>
+            <a:pPr>
+              <a:spcAft>
+                <a:spcPts val="500"/>
+              </a:spcAft>
+            </a:pPr>
+            <a:r>
+              <a:rPr sz="1500" b="1">
+                <a:solidFill>
+                  <a:srgbClr val="C0392B"/>
+                </a:solidFill>
+              </a:rPr>
+              <a:t>present 100% of the time.</a:t>
+            </a:r>
+          </a:p>
+        </p:txBody>
+      </p:sp>
+      <p:sp>
+        <p:nvSpPr>
+          <p:cNvPr id="5" name="TextBox 4"/>
+          <p:cNvSpPr txBox="1"/>
+          <p:nvPr/>
+        </p:nvSpPr>
+        <p:spPr>
+          <a:xfrm>
+            <a:off x="822960" y="4480560"/>
+            <a:ext cx="10607040" cy="1828800"/>
+          </a:xfrm>
+          <a:prstGeom prst="rect">
+            <a:avLst/>
+          </a:prstGeom>
+          <a:noFill/>
+        </p:spPr>
+        <p:txBody>
+          <a:bodyPr wrap="square">
+            <a:spAutoFit/>
+          </a:bodyPr>
+          <a:lstStyle/>
+          <a:p>
+            <a:pPr>
+              <a:spcAft>
+                <a:spcPts val="500"/>
+              </a:spcAft>
+            </a:pPr>
+            <a:r>
+              <a:rPr sz="1300" b="1">
+                <a:solidFill>
+                  <a:srgbClr val="1F3A6E"/>
+                </a:solidFill>
+              </a:rPr>
+              <a:t>Four failures a real deployment must survive</a:t>
+            </a:r>
+          </a:p>
+          <a:p>
+            <a:pPr>
+              <a:spcAft>
+                <a:spcPts val="500"/>
+              </a:spcAft>
+            </a:pPr>
+            <a:r>
+              <a:rPr sz="1300" b="0">
+                <a:solidFill>
+                  <a:srgbClr val="1A1A1A"/>
+                </a:solidFill>
+              </a:rPr>
+              <a:t>•  A photograph or phone screen held up to the camera  →  marked present</a:t>
+            </a:r>
+          </a:p>
+          <a:p>
+            <a:pPr>
+              <a:spcAft>
+                <a:spcPts val="500"/>
+              </a:spcAft>
+            </a:pPr>
+            <a:r>
+              <a:rPr sz="1300" b="0">
+                <a:solidFill>
+                  <a:srgbClr val="1A1A1A"/>
+                </a:solidFill>
+              </a:rPr>
+              <a:t>•  A stranger walking past  →  a softmax has no way to say 'nobody'</a:t>
+            </a:r>
+          </a:p>
+          <a:p>
+            <a:pPr>
+              <a:spcAft>
+                <a:spcPts val="500"/>
+              </a:spcAft>
+            </a:pPr>
+            <a:r>
+              <a:rPr sz="1300" b="0">
+                <a:solidFill>
+                  <a:srgbClr val="1A1A1A"/>
+                </a:solidFill>
+              </a:rPr>
+              <a:t>•  A student at the back of the room  →  too few pixels to identify, but still named</a:t>
+            </a:r>
+          </a:p>
+          <a:p>
+            <a:pPr>
+              <a:spcAft>
+                <a:spcPts val="500"/>
+              </a:spcAft>
+            </a:pPr>
+            <a:r>
+              <a:rPr sz="1300" b="0">
+                <a:solidFill>
+                  <a:srgbClr val="1A1A1A"/>
+                </a:solidFill>
+              </a:rPr>
+              <a:t>•  One misread frame  →  wrong student marked present for the entire day</a:t>
+            </a:r>
+          </a:p>
+        </p:txBody>
+      </p:sp>
+    </p:spTree>
+  </p:cSld>
+  <p:clrMapOvr>
+    <a:masterClrMapping/>
+  </p:clrMapOvr>
+</p:sld>
+</file>
+
+<file path=ppt/slides/slide5.xml><?xml version="1.0" encoding="utf-8"?>
+<p:sld xmlns:a="http://schemas.openxmlformats.org/drawingml/2006/main" xmlns:p="http://schemas.openxmlformats.org/presentationml/2006/main" xmlns:r="http://schemas.openxmlformats.org/officeDocument/2006/relationships">
+  <p:cSld>
+    <p:spTree>
+      <p:nvGrpSpPr>
+        <p:cNvPr id="1" name=""/>
+        <p:cNvGrpSpPr/>
+        <p:nvPr/>
+      </p:nvGrpSpPr>
+      <p:grpSpPr/>
+      <p:sp>
+        <p:nvSpPr>
+          <p:cNvPr id="2" name="TextBox 1"/>
+          <p:cNvSpPr txBox="1"/>
+          <p:nvPr/>
+        </p:nvSpPr>
+        <p:spPr>
+          <a:xfrm>
+            <a:off x="365760" y="182880"/>
+            <a:ext cx="11430000" cy="640080"/>
+          </a:xfrm>
+          <a:prstGeom prst="rect">
+            <a:avLst/>
+          </a:prstGeom>
+          <a:noFill/>
+        </p:spPr>
+        <p:txBody>
           <a:bodyPr wrap="none">
             <a:spAutoFit/>
           </a:bodyPr>
           <a:lstStyle/>
           <a:p>
-            <a:r>
-              <a:rPr sz="1050" i="1">
-                <a:solidFill>
-                  <a:srgbClr val="555F6D"/>
-                </a:solidFill>
-              </a:rPr>
-              <a:t>Protocol: 30 simulated students + 66 strangers (VGGFace2). Test images never used for enrolment; the threshold is calibrated on one half of the strangers and measured on the other.</a:t>
+            <a:pPr algn="ctr"/>
+            <a:r>
+              <a:rPr sz="2800" b="1">
+                <a:solidFill>
+                  <a:srgbClr val="1F3A6E"/>
+                </a:solidFill>
+              </a:rPr>
+              <a:t>LITERATURE REVIEW</a:t>
+            </a:r>
+          </a:p>
+        </p:txBody>
+      </p:sp>
+      <p:sp>
+        <p:nvSpPr>
+          <p:cNvPr id="3" name="TextBox 2"/>
+          <p:cNvSpPr txBox="1"/>
+          <p:nvPr/>
+        </p:nvSpPr>
+        <p:spPr>
+          <a:xfrm>
+            <a:off x="640080" y="1097280"/>
+            <a:ext cx="10972800" cy="4023360"/>
+          </a:xfrm>
+          <a:prstGeom prst="rect">
+            <a:avLst/>
+          </a:prstGeom>
+          <a:noFill/>
+        </p:spPr>
+        <p:txBody>
+          <a:bodyPr wrap="square">
+            <a:spAutoFit/>
+          </a:bodyPr>
+          <a:lstStyle/>
+          <a:p>
+            <a:pPr>
+              <a:spcAft>
+                <a:spcPts val="500"/>
+              </a:spcAft>
+            </a:pPr>
+            <a:r>
+              <a:rPr sz="1250" b="0">
+                <a:solidFill>
+                  <a:srgbClr val="1A1A1A"/>
+                </a:solidFill>
+              </a:rPr>
+              <a:t>D'Souza et al. (2019) [1] — automated attendance via histogram-based features; improves efficiency but is sensitive to lighting and pose.</a:t>
+            </a:r>
+          </a:p>
+          <a:p>
+            <a:pPr>
+              <a:spcAft>
+                <a:spcPts val="500"/>
+              </a:spcAft>
+            </a:pPr>
+          </a:p>
+          <a:p>
+            <a:pPr>
+              <a:spcAft>
+                <a:spcPts val="500"/>
+              </a:spcAft>
+            </a:pPr>
+            <a:r>
+              <a:rPr sz="1250" b="0">
+                <a:solidFill>
+                  <a:srgbClr val="1A1A1A"/>
+                </a:solidFill>
+              </a:rPr>
+              <a:t>Arsenovic et al. (2017) [2] — CNN-based deep learning for attendance; higher accuracy and real-time performance.</a:t>
+            </a:r>
+          </a:p>
+          <a:p>
+            <a:pPr>
+              <a:spcAft>
+                <a:spcPts val="500"/>
+              </a:spcAft>
+            </a:pPr>
+          </a:p>
+          <a:p>
+            <a:pPr>
+              <a:spcAft>
+                <a:spcPts val="500"/>
+              </a:spcAft>
+            </a:pPr>
+            <a:r>
+              <a:rPr sz="1250" b="0">
+                <a:solidFill>
+                  <a:srgbClr val="1A1A1A"/>
+                </a:solidFill>
+              </a:rPr>
+              <a:t>Kakarla et al. (2020) [3] — CNN smart attendance recognising multiple students under moderate pose and expression change.</a:t>
+            </a:r>
+          </a:p>
+          <a:p>
+            <a:pPr>
+              <a:spcAft>
+                <a:spcPts val="500"/>
+              </a:spcAft>
+            </a:pPr>
+          </a:p>
+          <a:p>
+            <a:pPr>
+              <a:spcAft>
+                <a:spcPts val="500"/>
+              </a:spcAft>
+            </a:pPr>
+            <a:r>
+              <a:rPr sz="1250" b="0">
+                <a:solidFill>
+                  <a:srgbClr val="1A1A1A"/>
+                </a:solidFill>
+              </a:rPr>
+              <a:t>Varadharajan et al. (2016) [4] — face-detection classroom attendance; accuracy drops under occlusion and poor lighting.</a:t>
+            </a:r>
+          </a:p>
+          <a:p>
+            <a:pPr>
+              <a:spcAft>
+                <a:spcPts val="500"/>
+              </a:spcAft>
+            </a:pPr>
+          </a:p>
+          <a:p>
+            <a:pPr>
+              <a:spcAft>
+                <a:spcPts val="500"/>
+              </a:spcAft>
+            </a:pPr>
+            <a:r>
+              <a:rPr sz="1250" b="0">
+                <a:solidFill>
+                  <a:srgbClr val="1A1A1A"/>
+                </a:solidFill>
+              </a:rPr>
+              <a:t>Siswanto et al. (2014) [5] — face biometrics as a hygienic alternative to fingerprint attendance.</a:t>
+            </a:r>
+          </a:p>
+          <a:p>
+            <a:pPr>
+              <a:spcAft>
+                <a:spcPts val="500"/>
+              </a:spcAft>
+            </a:pPr>
+          </a:p>
+          <a:p>
+            <a:pPr>
+              <a:spcAft>
+                <a:spcPts val="500"/>
+              </a:spcAft>
+            </a:pPr>
+            <a:r>
+              <a:rPr sz="1250" b="0">
+                <a:solidFill>
+                  <a:srgbClr val="1A1A1A"/>
+                </a:solidFill>
+              </a:rPr>
+              <a:t>Deng et al. (2019) [6] — ArcFace: additive angular margin loss. The 512-d embedding our system uses (pretrained and frozen — we do not claim it).</a:t>
+            </a:r>
+          </a:p>
+        </p:txBody>
+      </p:sp>
+      <p:sp>
+        <p:nvSpPr>
+          <p:cNvPr id="4" name="TextBox 3"/>
+          <p:cNvSpPr txBox="1"/>
+          <p:nvPr/>
+        </p:nvSpPr>
+        <p:spPr>
+          <a:xfrm>
+            <a:off x="640080" y="5394960"/>
+            <a:ext cx="10972800" cy="1005840"/>
+          </a:xfrm>
+          <a:prstGeom prst="rect">
+            <a:avLst/>
+          </a:prstGeom>
+          <a:noFill/>
+        </p:spPr>
+        <p:txBody>
+          <a:bodyPr wrap="square">
+            <a:spAutoFit/>
+          </a:bodyPr>
+          <a:lstStyle/>
+          <a:p>
+            <a:pPr>
+              <a:spcAft>
+                <a:spcPts val="500"/>
+              </a:spcAft>
+            </a:pPr>
+            <a:r>
+              <a:rPr sz="1250" b="1">
+                <a:solidFill>
+                  <a:srgbClr val="C0392B"/>
+                </a:solidFill>
+              </a:rPr>
+              <a:t>RESEARCH GAP</a:t>
+            </a:r>
+          </a:p>
+          <a:p>
+            <a:pPr>
+              <a:spcAft>
+                <a:spcPts val="500"/>
+              </a:spcAft>
+            </a:pPr>
+            <a:r>
+              <a:rPr sz="1250" b="1">
+                <a:solidFill>
+                  <a:srgbClr val="C0392B"/>
+                </a:solidFill>
+              </a:rPr>
+              <a:t>Every attendance paper above reports one accuracy number on clean data. None of them test a presentation attack, none report a stranger-rejection rate, and none treat 'recognised' and 'marked present' as different decisions. That gap is our project.</a:t>
+            </a:r>
+          </a:p>
+        </p:txBody>
+      </p:sp>
+    </p:spTree>
+  </p:cSld>
+  <p:clrMapOvr>
+    <a:masterClrMapping/>
+  </p:clrMapOvr>
+</p:sld>
+</file>
+
+<file path=ppt/slides/slide6.xml><?xml version="1.0" encoding="utf-8"?>
+<p:sld xmlns:a="http://schemas.openxmlformats.org/drawingml/2006/main" xmlns:p="http://schemas.openxmlformats.org/presentationml/2006/main" xmlns:r="http://schemas.openxmlformats.org/officeDocument/2006/relationships">
+  <p:cSld>
+    <p:spTree>
+      <p:nvGrpSpPr>
+        <p:cNvPr id="1" name=""/>
+        <p:cNvGrpSpPr/>
+        <p:nvPr/>
+      </p:nvGrpSpPr>
+      <p:grpSpPr/>
+      <p:sp>
+        <p:nvSpPr>
+          <p:cNvPr id="2" name="TextBox 1"/>
+          <p:cNvSpPr txBox="1"/>
+          <p:nvPr/>
+        </p:nvSpPr>
+        <p:spPr>
+          <a:xfrm>
+            <a:off x="365760" y="182880"/>
+            <a:ext cx="11430000" cy="640080"/>
+          </a:xfrm>
+          <a:prstGeom prst="rect">
+            <a:avLst/>
+          </a:prstGeom>
+          <a:noFill/>
+        </p:spPr>
+        <p:txBody>
+          <a:bodyPr wrap="none">
+            <a:spAutoFit/>
+          </a:bodyPr>
+          <a:lstStyle/>
+          <a:p>
+            <a:pPr algn="ctr"/>
+            <a:r>
+              <a:rPr sz="2800" b="1">
+                <a:solidFill>
+                  <a:srgbClr val="1F3A6E"/>
+                </a:solidFill>
+              </a:rPr>
+              <a:t>PROPOSED METHODOLOGY</a:t>
+            </a:r>
+          </a:p>
+        </p:txBody>
+      </p:sp>
+      <p:sp>
+        <p:nvSpPr>
+          <p:cNvPr id="3" name="TextBox 2"/>
+          <p:cNvSpPr txBox="1"/>
+          <p:nvPr/>
+        </p:nvSpPr>
+        <p:spPr>
+          <a:xfrm>
+            <a:off x="640080" y="1097280"/>
+            <a:ext cx="5760720" cy="2743200"/>
+          </a:xfrm>
+          <a:prstGeom prst="rect">
+            <a:avLst/>
+          </a:prstGeom>
+          <a:noFill/>
+        </p:spPr>
+        <p:txBody>
+          <a:bodyPr wrap="square">
+            <a:spAutoFit/>
+          </a:bodyPr>
+          <a:lstStyle/>
+          <a:p>
+            <a:pPr>
+              <a:spcAft>
+                <a:spcPts val="500"/>
+              </a:spcAft>
+            </a:pPr>
+            <a:r>
+              <a:rPr sz="1250" b="1">
+                <a:solidFill>
+                  <a:srgbClr val="1F3A6E"/>
+                </a:solidFill>
+              </a:rPr>
+              <a:t>How it works</a:t>
+            </a:r>
+          </a:p>
+          <a:p>
+            <a:pPr>
+              <a:spcAft>
+                <a:spcPts val="500"/>
+              </a:spcAft>
+            </a:pPr>
+            <a:r>
+              <a:rPr sz="1250" b="0">
+                <a:solidFill>
+                  <a:srgbClr val="1A1A1A"/>
+                </a:solidFill>
+              </a:rPr>
+              <a:t>Every face in the frame is detected, embedded (512-d) and matched against each</a:t>
+            </a:r>
+          </a:p>
+          <a:p>
+            <a:pPr>
+              <a:spcAft>
+                <a:spcPts val="500"/>
+              </a:spcAft>
+            </a:pPr>
+            <a:r>
+              <a:rPr sz="1250" b="0">
+                <a:solidFill>
+                  <a:srgbClr val="1A1A1A"/>
+                </a:solidFill>
+              </a:rPr>
+              <a:t>enrolled student's centroid. A face must then pass FOUR gates before the system is</a:t>
+            </a:r>
+          </a:p>
+          <a:p>
+            <a:pPr>
+              <a:spcAft>
+                <a:spcPts val="500"/>
+              </a:spcAft>
+            </a:pPr>
+            <a:r>
+              <a:rPr sz="1250" b="0">
+                <a:solidFill>
+                  <a:srgbClr val="1A1A1A"/>
+                </a:solidFill>
+              </a:rPr>
+              <a:t>willing to put a name on it — and several frames must agree before attendance is</a:t>
+            </a:r>
+          </a:p>
+          <a:p>
+            <a:pPr>
+              <a:spcAft>
+                <a:spcPts val="500"/>
+              </a:spcAft>
+            </a:pPr>
+            <a:r>
+              <a:rPr sz="1250" b="0">
+                <a:solidFill>
+                  <a:srgbClr val="1A1A1A"/>
+                </a:solidFill>
+              </a:rPr>
+              <a:t>written. Records go to CSV; nothing leaves the machine.</a:t>
+            </a:r>
+          </a:p>
+          <a:p>
+            <a:pPr>
+              <a:spcAft>
+                <a:spcPts val="500"/>
+              </a:spcAft>
+            </a:pPr>
+          </a:p>
+          <a:p>
+            <a:pPr>
+              <a:spcAft>
+                <a:spcPts val="500"/>
+              </a:spcAft>
+            </a:pPr>
+            <a:r>
+              <a:rPr sz="1250" b="1">
+                <a:solidFill>
+                  <a:srgbClr val="1F3A6E"/>
+                </a:solidFill>
+              </a:rPr>
+              <a:t>Problem addressed</a:t>
+            </a:r>
+          </a:p>
+          <a:p>
+            <a:pPr>
+              <a:spcAft>
+                <a:spcPts val="500"/>
+              </a:spcAft>
+            </a:pPr>
+            <a:r>
+              <a:rPr sz="1250" b="0">
+                <a:solidFill>
+                  <a:srgbClr val="1A1A1A"/>
+                </a:solidFill>
+              </a:rPr>
+              <a:t>Replaces manual roll-call, eliminates the signed-register proxy, rejects strangers,</a:t>
+            </a:r>
+          </a:p>
+          <a:p>
+            <a:pPr>
+              <a:spcAft>
+                <a:spcPts val="500"/>
+              </a:spcAft>
+            </a:pPr>
+            <a:r>
+              <a:rPr sz="1250" b="0">
+                <a:solidFill>
+                  <a:srgbClr val="1A1A1A"/>
+                </a:solidFill>
+              </a:rPr>
+              <a:t>and blocks the photo/screen proxy that defeats ordinary face recognition.</a:t>
+            </a:r>
+          </a:p>
+        </p:txBody>
+      </p:sp>
+      <p:sp>
+        <p:nvSpPr>
+          <p:cNvPr id="4" name="TextBox 3"/>
+          <p:cNvSpPr txBox="1"/>
+          <p:nvPr/>
+        </p:nvSpPr>
+        <p:spPr>
+          <a:xfrm>
+            <a:off x="6583680" y="1097280"/>
+            <a:ext cx="5120640" cy="5120640"/>
+          </a:xfrm>
+          <a:prstGeom prst="rect">
+            <a:avLst/>
+          </a:prstGeom>
+          <a:noFill/>
+        </p:spPr>
+        <p:txBody>
+          <a:bodyPr wrap="square">
+            <a:spAutoFit/>
+          </a:bodyPr>
+          <a:lstStyle/>
+          <a:p>
+            <a:pPr>
+              <a:spcAft>
+                <a:spcPts val="500"/>
+              </a:spcAft>
+            </a:pPr>
+            <a:r>
+              <a:rPr sz="1100" b="1">
+                <a:solidFill>
+                  <a:srgbClr val="1F3A6E"/>
+                </a:solidFill>
+              </a:rPr>
+              <a:t>Innovation and uniqueness — stated honestly</a:t>
+            </a:r>
+          </a:p>
+          <a:p>
+            <a:pPr>
+              <a:spcAft>
+                <a:spcPts val="500"/>
+              </a:spcAft>
+            </a:pPr>
+          </a:p>
+          <a:p>
+            <a:pPr>
+              <a:spcAft>
+                <a:spcPts val="500"/>
+              </a:spcAft>
+            </a:pPr>
+            <a:r>
+              <a:rPr sz="1100" b="1">
+                <a:solidFill>
+                  <a:srgbClr val="C0392B"/>
+                </a:solidFill>
+              </a:rPr>
+              <a:t>We do NOT claim a new face-recognition model.</a:t>
+            </a:r>
+          </a:p>
+          <a:p>
+            <a:pPr>
+              <a:spcAft>
+                <a:spcPts val="500"/>
+              </a:spcAft>
+            </a:pPr>
+            <a:r>
+              <a:rPr sz="1100" b="0">
+                <a:solidFill>
+                  <a:srgbClr val="1A1A1A"/>
+                </a:solidFill>
+              </a:rPr>
+              <a:t>ArcFace is pretrained and frozen. Training our own on 30 students would need a GPU,</a:t>
+            </a:r>
+          </a:p>
+          <a:p>
+            <a:pPr>
+              <a:spcAft>
+                <a:spcPts val="500"/>
+              </a:spcAft>
+            </a:pPr>
+            <a:r>
+              <a:rPr sz="1100" b="0">
+                <a:solidFill>
+                  <a:srgbClr val="1A1A1A"/>
+                </a:solidFill>
+              </a:rPr>
+              <a:t>thousands of images per person, and would still name a stranger every time.</a:t>
+            </a:r>
+          </a:p>
+          <a:p>
+            <a:pPr>
+              <a:spcAft>
+                <a:spcPts val="500"/>
+              </a:spcAft>
+            </a:pPr>
+          </a:p>
+          <a:p>
+            <a:pPr>
+              <a:spcAft>
+                <a:spcPts val="500"/>
+              </a:spcAft>
+            </a:pPr>
+            <a:r>
+              <a:rPr sz="1100" b="1">
+                <a:solidFill>
+                  <a:srgbClr val="1E8E5A"/>
+                </a:solidFill>
+              </a:rPr>
+              <a:t>What IS ours:</a:t>
+            </a:r>
+          </a:p>
+          <a:p>
+            <a:pPr>
+              <a:spcAft>
+                <a:spcPts val="500"/>
+              </a:spcAft>
+            </a:pPr>
+            <a:r>
+              <a:rPr sz="1100" b="0">
+                <a:solidFill>
+                  <a:srgbClr val="1A1A1A"/>
+                </a:solidFill>
+              </a:rPr>
+              <a:t>•  Liveness that works on classroom hardware. Blink detection is the standard trick, but a blink lasts ~0.3 s and our system samples ~1.4 frames/s — we measured it failing. So we measure facial motion from landmarks the detector already produces: a live face keeps deforming, a photo is rigid. Rotation and scale are normalised away, so waving the photo does not help the attacker. No extra model. No GPU.</a:t>
+            </a:r>
+          </a:p>
+          <a:p>
+            <a:pPr>
+              <a:spcAft>
+                <a:spcPts val="500"/>
+              </a:spcAft>
+            </a:pPr>
+            <a:r>
+              <a:rPr sz="1100" b="0">
+                <a:solidFill>
+                  <a:srgbClr val="1A1A1A"/>
+                </a:solidFill>
+              </a:rPr>
+              <a:t>•  A threshold calibrated on 2,880 impostor faces, not hand-picked.</a:t>
+            </a:r>
+          </a:p>
+          <a:p>
+            <a:pPr>
+              <a:spcAft>
+                <a:spcPts val="500"/>
+              </a:spcAft>
+            </a:pPr>
+            <a:r>
+              <a:rPr sz="1100" b="0">
+                <a:solidFill>
+                  <a:srgbClr val="1A1A1A"/>
+                </a:solidFill>
+              </a:rPr>
+              <a:t>•  Attendance treated as an irreversible commit needing agreement across frames.</a:t>
+            </a:r>
+          </a:p>
+          <a:p>
+            <a:pPr>
+              <a:spcAft>
+                <a:spcPts val="500"/>
+              </a:spcAft>
+            </a:pPr>
+            <a:r>
+              <a:rPr sz="1100" b="0">
+                <a:solidFill>
+                  <a:srgbClr val="1A1A1A"/>
+                </a:solidFill>
+              </a:rPr>
+              <a:t>•  Enrolment in 1.4 s (was 607 s) by caching embeddings.</a:t>
+            </a:r>
+          </a:p>
+          <a:p>
+            <a:pPr>
+              <a:spcAft>
+                <a:spcPts val="500"/>
+              </a:spcAft>
+            </a:pPr>
+            <a:r>
+              <a:rPr sz="1100" b="0">
+                <a:solidFill>
+                  <a:srgbClr val="1A1A1A"/>
+                </a:solidFill>
+              </a:rPr>
+              <a:t>•  A guard that did NOT work (top-2 margin) — reported, not hidden.</a:t>
+            </a:r>
+          </a:p>
+        </p:txBody>
+      </p:sp>
+    </p:spTree>
+  </p:cSld>
+  <p:clrMapOvr>
+    <a:masterClrMapping/>
+  </p:clrMapOvr>
+</p:sld>
+</file>
+
+<file path=ppt/slides/slide7.xml><?xml version="1.0" encoding="utf-8"?>
+<p:sld xmlns:a="http://schemas.openxmlformats.org/drawingml/2006/main" xmlns:p="http://schemas.openxmlformats.org/presentationml/2006/main" xmlns:r="http://schemas.openxmlformats.org/officeDocument/2006/relationships">
+  <p:cSld>
+    <p:spTree>
+      <p:nvGrpSpPr>
+        <p:cNvPr id="1" name=""/>
+        <p:cNvGrpSpPr/>
+        <p:nvPr/>
+      </p:nvGrpSpPr>
+      <p:grpSpPr/>
+      <p:sp>
+        <p:nvSpPr>
+          <p:cNvPr id="2" name="TextBox 1"/>
+          <p:cNvSpPr txBox="1"/>
+          <p:nvPr/>
+        </p:nvSpPr>
+        <p:spPr>
+          <a:xfrm>
+            <a:off x="365760" y="182880"/>
+            <a:ext cx="11430000" cy="640080"/>
+          </a:xfrm>
+          <a:prstGeom prst="rect">
+            <a:avLst/>
+          </a:prstGeom>
+          <a:noFill/>
+        </p:spPr>
+        <p:txBody>
+          <a:bodyPr wrap="none">
+            <a:spAutoFit/>
+          </a:bodyPr>
+          <a:lstStyle/>
+          <a:p>
+            <a:pPr algn="ctr"/>
+            <a:r>
+              <a:rPr sz="2800" b="1">
+                <a:solidFill>
+                  <a:srgbClr val="1F3A6E"/>
+                </a:solidFill>
+              </a:rPr>
+              <a:t>EXPERIMENTAL DETAILS</a:t>
             </a:r>
           </a:p>
         </p:txBody>
       </p:sp>
       <p:pic>
         <p:nvPicPr>
-          <p:cNvPr id="4" name="Picture 3" descr="spoof.png"/>
+          <p:cNvPr id="3" name="Picture 2" descr="workflow.png"/>
           <p:cNvPicPr>
             <a:picLocks noChangeAspect="1"/>
           </p:cNvPicPr>
@@ -4325,8 +5115,444 @@
         </p:blipFill>
         <p:spPr>
           <a:xfrm>
-            <a:off x="457200" y="1371600"/>
-            <a:ext cx="3200400" cy="2286000"/>
+            <a:off x="365760" y="868680"/>
+            <a:ext cx="11430000" cy="2286000"/>
+          </a:xfrm>
+          <a:prstGeom prst="rect">
+            <a:avLst/>
+          </a:prstGeom>
+        </p:spPr>
+      </p:pic>
+      <p:sp>
+        <p:nvSpPr>
+          <p:cNvPr id="4" name="TextBox 3"/>
+          <p:cNvSpPr txBox="1"/>
+          <p:nvPr/>
+        </p:nvSpPr>
+        <p:spPr>
+          <a:xfrm>
+            <a:off x="640080" y="3017520"/>
+            <a:ext cx="5303520" cy="3291840"/>
+          </a:xfrm>
+          <a:prstGeom prst="rect">
+            <a:avLst/>
+          </a:prstGeom>
+          <a:noFill/>
+        </p:spPr>
+        <p:txBody>
+          <a:bodyPr wrap="square">
+            <a:spAutoFit/>
+          </a:bodyPr>
+          <a:lstStyle/>
+          <a:p>
+            <a:pPr>
+              <a:spcAft>
+                <a:spcPts val="500"/>
+              </a:spcAft>
+            </a:pPr>
+            <a:r>
+              <a:rPr sz="1200" b="1">
+                <a:solidFill>
+                  <a:srgbClr val="1F3A6E"/>
+                </a:solidFill>
+              </a:rPr>
+              <a:t>Technologies</a:t>
+            </a:r>
+          </a:p>
+          <a:p>
+            <a:pPr>
+              <a:spcAft>
+                <a:spcPts val="500"/>
+              </a:spcAft>
+            </a:pPr>
+            <a:r>
+              <a:rPr sz="1200" b="0">
+                <a:solidFill>
+                  <a:srgbClr val="1A1A1A"/>
+                </a:solidFill>
+              </a:rPr>
+              <a:t>Language:  Python 3.13</a:t>
+            </a:r>
+          </a:p>
+          <a:p>
+            <a:pPr>
+              <a:spcAft>
+                <a:spcPts val="500"/>
+              </a:spcAft>
+            </a:pPr>
+            <a:r>
+              <a:rPr sz="1200" b="0">
+                <a:solidFill>
+                  <a:srgbClr val="1A1A1A"/>
+                </a:solidFill>
+              </a:rPr>
+              <a:t>Detection:  RetinaFace / SCRFD (det_10g)</a:t>
+            </a:r>
+          </a:p>
+          <a:p>
+            <a:pPr>
+              <a:spcAft>
+                <a:spcPts val="500"/>
+              </a:spcAft>
+            </a:pPr>
+            <a:r>
+              <a:rPr sz="1200" b="0">
+                <a:solidFill>
+                  <a:srgbClr val="1A1A1A"/>
+                </a:solidFill>
+              </a:rPr>
+              <a:t>Recognition:  ArcFace ResNet-50 (buffalo_l) → 512-d</a:t>
+            </a:r>
+          </a:p>
+          <a:p>
+            <a:pPr>
+              <a:spcAft>
+                <a:spcPts val="500"/>
+              </a:spcAft>
+            </a:pPr>
+            <a:r>
+              <a:rPr sz="1200" b="0">
+                <a:solidFill>
+                  <a:srgbClr val="1A1A1A"/>
+                </a:solidFill>
+              </a:rPr>
+              <a:t>Runtime:  ONNX Runtime — CPU only, no GPU</a:t>
+            </a:r>
+          </a:p>
+          <a:p>
+            <a:pPr>
+              <a:spcAft>
+                <a:spcPts val="500"/>
+              </a:spcAft>
+            </a:pPr>
+            <a:r>
+              <a:rPr sz="1200" b="0">
+                <a:solidFill>
+                  <a:srgbClr val="1A1A1A"/>
+                </a:solidFill>
+              </a:rPr>
+              <a:t>Classifier:  linear SVM + cosine-to-centroid (scikit-learn)</a:t>
+            </a:r>
+          </a:p>
+          <a:p>
+            <a:pPr>
+              <a:spcAft>
+                <a:spcPts val="500"/>
+              </a:spcAft>
+            </a:pPr>
+            <a:r>
+              <a:rPr sz="1200" b="0">
+                <a:solidFill>
+                  <a:srgbClr val="1A1A1A"/>
+                </a:solidFill>
+              </a:rPr>
+              <a:t>Backend:  Flask REST API, token authentication</a:t>
+            </a:r>
+          </a:p>
+          <a:p>
+            <a:pPr>
+              <a:spcAft>
+                <a:spcPts val="500"/>
+              </a:spcAft>
+            </a:pPr>
+            <a:r>
+              <a:rPr sz="1200" b="0">
+                <a:solidFill>
+                  <a:srgbClr val="1A1A1A"/>
+                </a:solidFill>
+              </a:rPr>
+              <a:t>Frontend:  React · Vite · TailwindCSS</a:t>
+            </a:r>
+          </a:p>
+          <a:p>
+            <a:pPr>
+              <a:spcAft>
+                <a:spcPts val="500"/>
+              </a:spcAft>
+            </a:pPr>
+            <a:r>
+              <a:rPr sz="1200" b="0">
+                <a:solidFill>
+                  <a:srgbClr val="1A1A1A"/>
+                </a:solidFill>
+              </a:rPr>
+              <a:t>Storage:  CSV + JSON on disk — no cloud, no DB server</a:t>
+            </a:r>
+          </a:p>
+        </p:txBody>
+      </p:sp>
+      <p:sp>
+        <p:nvSpPr>
+          <p:cNvPr id="5" name="TextBox 4"/>
+          <p:cNvSpPr txBox="1"/>
+          <p:nvPr/>
+        </p:nvSpPr>
+        <p:spPr>
+          <a:xfrm>
+            <a:off x="6309360" y="3017520"/>
+            <a:ext cx="5394960" cy="3291840"/>
+          </a:xfrm>
+          <a:prstGeom prst="rect">
+            <a:avLst/>
+          </a:prstGeom>
+          <a:noFill/>
+        </p:spPr>
+        <p:txBody>
+          <a:bodyPr wrap="square">
+            <a:spAutoFit/>
+          </a:bodyPr>
+          <a:lstStyle/>
+          <a:p>
+            <a:pPr>
+              <a:spcAft>
+                <a:spcPts val="500"/>
+              </a:spcAft>
+            </a:pPr>
+            <a:r>
+              <a:rPr sz="1150" b="1">
+                <a:solidFill>
+                  <a:srgbClr val="1F3A6E"/>
+                </a:solidFill>
+              </a:rPr>
+              <a:t>Experimental protocol</a:t>
+            </a:r>
+          </a:p>
+          <a:p>
+            <a:pPr>
+              <a:spcAft>
+                <a:spcPts val="500"/>
+              </a:spcAft>
+            </a:pPr>
+            <a:r>
+              <a:rPr sz="1150" b="0">
+                <a:solidFill>
+                  <a:srgbClr val="1A1A1A"/>
+                </a:solidFill>
+              </a:rPr>
+              <a:t>96 VGGFace2 identities → 30 simulated 'students' + 66 'strangers'.</a:t>
+            </a:r>
+          </a:p>
+          <a:p>
+            <a:pPr>
+              <a:spcAft>
+                <a:spcPts val="500"/>
+              </a:spcAft>
+            </a:pPr>
+            <a:r>
+              <a:rPr sz="1150" b="0">
+                <a:solidFill>
+                  <a:srgbClr val="1A1A1A"/>
+                </a:solidFill>
+              </a:rPr>
+              <a:t>Student images split 70/30: enrolment vs held-out test images.</a:t>
+            </a:r>
+          </a:p>
+          <a:p>
+            <a:pPr>
+              <a:spcAft>
+                <a:spcPts val="500"/>
+              </a:spcAft>
+            </a:pPr>
+            <a:r>
+              <a:rPr sz="1150" b="0">
+                <a:solidFill>
+                  <a:srgbClr val="1A1A1A"/>
+                </a:solidFill>
+              </a:rPr>
+              <a:t>Strangers split in half: one half calibrates the threshold,</a:t>
+            </a:r>
+          </a:p>
+          <a:p>
+            <a:pPr>
+              <a:spcAft>
+                <a:spcPts val="500"/>
+              </a:spcAft>
+            </a:pPr>
+            <a:r>
+              <a:rPr sz="1150" b="0">
+                <a:solidFill>
+                  <a:srgbClr val="1A1A1A"/>
+                </a:solidFill>
+              </a:rPr>
+              <a:t>the other half measures it.</a:t>
+            </a:r>
+          </a:p>
+          <a:p>
+            <a:pPr>
+              <a:spcAft>
+                <a:spcPts val="500"/>
+              </a:spcAft>
+            </a:pPr>
+          </a:p>
+          <a:p>
+            <a:pPr>
+              <a:spcAft>
+                <a:spcPts val="500"/>
+              </a:spcAft>
+            </a:pPr>
+            <a:r>
+              <a:rPr sz="1150" b="1">
+                <a:solidFill>
+                  <a:srgbClr val="C0392B"/>
+                </a:solidFill>
+              </a:rPr>
+              <a:t>Both splits are essential.</a:t>
+            </a:r>
+          </a:p>
+          <a:p>
+            <a:pPr>
+              <a:spcAft>
+                <a:spcPts val="500"/>
+              </a:spcAft>
+            </a:pPr>
+            <a:r>
+              <a:rPr sz="1150" b="0">
+                <a:solidFill>
+                  <a:srgbClr val="1A1A1A"/>
+                </a:solidFill>
+              </a:rPr>
+              <a:t>Scoring a face against a centroid built from that same face gives</a:t>
+            </a:r>
+          </a:p>
+          <a:p>
+            <a:pPr>
+              <a:spcAft>
+                <a:spcPts val="500"/>
+              </a:spcAft>
+            </a:pPr>
+            <a:r>
+              <a:rPr sz="1150" b="0">
+                <a:solidFill>
+                  <a:srgbClr val="1A1A1A"/>
+                </a:solidFill>
+              </a:rPr>
+              <a:t>100% and proves nothing. A threshold tuned on the same strangers</a:t>
+            </a:r>
+          </a:p>
+          <a:p>
+            <a:pPr>
+              <a:spcAft>
+                <a:spcPts val="500"/>
+              </a:spcAft>
+            </a:pPr>
+            <a:r>
+              <a:rPr sz="1150" b="0">
+                <a:solidFill>
+                  <a:srgbClr val="1A1A1A"/>
+                </a:solidFill>
+              </a:rPr>
+              <a:t>you then report a false-accept rate against is not a measurement.</a:t>
+            </a:r>
+          </a:p>
+          <a:p>
+            <a:pPr>
+              <a:spcAft>
+                <a:spcPts val="500"/>
+              </a:spcAft>
+            </a:pPr>
+          </a:p>
+          <a:p>
+            <a:pPr>
+              <a:spcAft>
+                <a:spcPts val="500"/>
+              </a:spcAft>
+            </a:pPr>
+            <a:r>
+              <a:rPr sz="1150" b="0">
+                <a:solidFill>
+                  <a:srgbClr val="1A1A1A"/>
+                </a:solidFill>
+              </a:rPr>
+              <a:t>Hardware: MacBook Air, CPU only. 2 real users enrolled for the</a:t>
+            </a:r>
+          </a:p>
+          <a:p>
+            <a:pPr>
+              <a:spcAft>
+                <a:spcPts val="500"/>
+              </a:spcAft>
+            </a:pPr>
+            <a:r>
+              <a:rPr sz="1150" b="0">
+                <a:solidFill>
+                  <a:srgbClr val="1A1A1A"/>
+                </a:solidFill>
+              </a:rPr>
+              <a:t>live deployment demo.</a:t>
+            </a:r>
+          </a:p>
+        </p:txBody>
+      </p:sp>
+    </p:spTree>
+  </p:cSld>
+  <p:clrMapOvr>
+    <a:masterClrMapping/>
+  </p:clrMapOvr>
+</p:sld>
+</file>
+
+<file path=ppt/slides/slide8.xml><?xml version="1.0" encoding="utf-8"?>
+<p:sld xmlns:a="http://schemas.openxmlformats.org/drawingml/2006/main" xmlns:p="http://schemas.openxmlformats.org/presentationml/2006/main" xmlns:r="http://schemas.openxmlformats.org/officeDocument/2006/relationships">
+  <p:cSld>
+    <p:spTree>
+      <p:nvGrpSpPr>
+        <p:cNvPr id="1" name=""/>
+        <p:cNvGrpSpPr/>
+        <p:nvPr/>
+      </p:nvGrpSpPr>
+      <p:grpSpPr/>
+      <p:sp>
+        <p:nvSpPr>
+          <p:cNvPr id="2" name="TextBox 1"/>
+          <p:cNvSpPr txBox="1"/>
+          <p:nvPr/>
+        </p:nvSpPr>
+        <p:spPr>
+          <a:xfrm>
+            <a:off x="365760" y="182880"/>
+            <a:ext cx="11430000" cy="640080"/>
+          </a:xfrm>
+          <a:prstGeom prst="rect">
+            <a:avLst/>
+          </a:prstGeom>
+          <a:noFill/>
+        </p:spPr>
+        <p:txBody>
+          <a:bodyPr wrap="none">
+            <a:spAutoFit/>
+          </a:bodyPr>
+          <a:lstStyle/>
+          <a:p>
+            <a:pPr algn="ctr"/>
+            <a:r>
+              <a:rPr sz="2800" b="1">
+                <a:solidFill>
+                  <a:srgbClr val="1F3A6E"/>
+                </a:solidFill>
+              </a:rPr>
+              <a:t>RESULTS AND ANALYSIS</a:t>
+            </a:r>
+          </a:p>
+        </p:txBody>
+      </p:sp>
+      <p:pic>
+        <p:nvPicPr>
+          <p:cNvPr id="3" name="Picture 2" descr="spoof.png"/>
+          <p:cNvPicPr>
+            <a:picLocks noChangeAspect="1"/>
+          </p:cNvPicPr>
+          <p:nvPr/>
+        </p:nvPicPr>
+        <p:blipFill>
+          <a:blip r:embed="rId2"/>
+          <a:stretch>
+            <a:fillRect/>
+          </a:stretch>
+        </p:blipFill>
+        <p:spPr>
+          <a:xfrm>
+            <a:off x="365760" y="914400"/>
+            <a:ext cx="3072384" cy="2194560"/>
           </a:xfrm>
           <a:prstGeom prst="rect">
             <a:avLst/>
@@ -4335,7 +5561,7 @@
       </p:pic>
       <p:pic>
         <p:nvPicPr>
-          <p:cNvPr id="5" name="Picture 4" descr="ablation.png"/>
+          <p:cNvPr id="4" name="Picture 3" descr="ablation.png"/>
           <p:cNvPicPr>
             <a:picLocks noChangeAspect="1"/>
           </p:cNvPicPr>
@@ -4349,8 +5575,8 @@
         </p:blipFill>
         <p:spPr>
           <a:xfrm>
-            <a:off x="4023360" y="1371600"/>
-            <a:ext cx="4876800" cy="2286000"/>
+            <a:off x="3749039" y="914400"/>
+            <a:ext cx="4535424" cy="2194560"/>
           </a:xfrm>
           <a:prstGeom prst="rect">
             <a:avLst/>
@@ -4359,7 +5585,7 @@
       </p:pic>
       <p:pic>
         <p:nvPicPr>
-          <p:cNvPr id="6" name="Picture 5" descr="degradation.png"/>
+          <p:cNvPr id="5" name="Picture 4" descr="degradation.png"/>
           <p:cNvPicPr>
             <a:picLocks noChangeAspect="1"/>
           </p:cNvPicPr>
@@ -4373,8 +5599,8 @@
         </p:blipFill>
         <p:spPr>
           <a:xfrm>
-            <a:off x="8686800" y="1371600"/>
-            <a:ext cx="3501390" cy="2286000"/>
+            <a:off x="8412480" y="914400"/>
+            <a:ext cx="3218688" cy="2194560"/>
           </a:xfrm>
           <a:prstGeom prst="rect">
             <a:avLst/>
@@ -4383,15 +5609,15 @@
       </p:pic>
       <p:graphicFrame>
         <p:nvGraphicFramePr>
-          <p:cNvPr id="7" name="Table 6"/>
+          <p:cNvPr id="6" name="Table 5"/>
           <p:cNvGraphicFramePr>
             <a:graphicFrameLocks noGrp="1"/>
           </p:cNvGraphicFramePr>
           <p:nvPr/>
         </p:nvGraphicFramePr>
         <p:xfrm>
-          <a:off x="457200" y="3931920"/>
-          <a:ext cx="6766560" cy="2194560"/>
+          <a:off x="457200" y="3383280"/>
+          <a:ext cx="6400800" cy="2194560"/>
         </p:xfrm>
         <a:graphic>
           <a:graphicData uri="http://schemas.openxmlformats.org/drawingml/2006/table">
@@ -4400,9 +5626,9 @@
                 <a:tableStyleId>{5C22544A-7EE6-4342-B048-85BDC9FD1C3A}</a:tableStyleId>
               </a:tblPr>
               <a:tblGrid>
-                <a:gridCol w="3657600"/>
-                <a:gridCol w="1554480"/>
-                <a:gridCol w="1554480"/>
+                <a:gridCol w="3474720"/>
+                <a:gridCol w="1463040"/>
+                <a:gridCol w="1463040"/>
               </a:tblGrid>
               <a:tr h="365760">
                 <a:tc>
@@ -4633,7 +5859,7 @@
                     <a:p>
                       <a:r>
                         <a:rPr sz="1100" b="0"/>
-                        <a:t>Time to mark a student present</a:t>
+                        <a:t>Time to mark present</a:t>
                       </a:r>
                     </a:p>
                   </a:txBody>
@@ -4676,14 +5902,14 @@
       </p:graphicFrame>
       <p:sp>
         <p:nvSpPr>
-          <p:cNvPr id="8" name="TextBox 7"/>
+          <p:cNvPr id="7" name="TextBox 6"/>
           <p:cNvSpPr txBox="1"/>
           <p:nvPr/>
         </p:nvSpPr>
         <p:spPr>
           <a:xfrm>
-            <a:off x="7498079" y="3931920"/>
-            <a:ext cx="4297680" cy="2468880"/>
+            <a:off x="7132320" y="3383280"/>
+            <a:ext cx="4663440" cy="2926080"/>
           </a:xfrm>
           <a:prstGeom prst="rect">
             <a:avLst/>
@@ -4702,67 +5928,67 @@
               </a:spcAft>
             </a:pPr>
             <a:r>
-              <a:rPr sz="1050" b="1">
+              <a:rPr sz="1100" b="1">
                 <a:solidFill>
                   <a:srgbClr val="1F3A6E"/>
                 </a:solidFill>
               </a:rPr>
-              <a:t>Capacity (measured, laptop CPU, no GPU)</a:t>
-            </a:r>
-          </a:p>
-          <a:p>
-            <a:pPr>
-              <a:spcAft>
-                <a:spcPts val="500"/>
-              </a:spcAft>
-            </a:pPr>
-            <a:r>
-              <a:rPr sz="1050" b="0">
-                <a:solidFill>
-                  <a:srgbClr val="1A1A1A"/>
-                </a:solidFill>
-              </a:rPr>
-              <a:t>16 faces recognised in one frame in 1.271s</a:t>
-            </a:r>
-          </a:p>
-          <a:p>
-            <a:pPr>
-              <a:spcAft>
-                <a:spcPts val="500"/>
-              </a:spcAft>
-            </a:pPr>
-            <a:r>
-              <a:rPr sz="1050" b="0">
-                <a:solidFill>
-                  <a:srgbClr val="1A1A1A"/>
-                </a:solidFill>
-              </a:rPr>
-              <a:t>10,000 enrolled students add only 1.2 ms to a match</a:t>
-            </a:r>
-          </a:p>
-          <a:p>
-            <a:pPr>
-              <a:spcAft>
-                <a:spcPts val="500"/>
-              </a:spcAft>
-            </a:pPr>
-            <a:r>
-              <a:rPr sz="1050" b="0">
-                <a:solidFill>
-                  <a:srgbClr val="1A1A1A"/>
-                </a:solidFill>
-              </a:rPr>
-              <a:t>One 1080p camera covers ~7 m — a whole classroom</a:t>
-            </a:r>
-          </a:p>
-          <a:p>
-            <a:pPr>
-              <a:spcAft>
-                <a:spcPts val="500"/>
-              </a:spcAft>
-            </a:pPr>
-            <a:r>
-              <a:rPr sz="1050" b="0">
+              <a:t>Capacity (laptop CPU, no GPU)</a:t>
+            </a:r>
+          </a:p>
+          <a:p>
+            <a:pPr>
+              <a:spcAft>
+                <a:spcPts val="500"/>
+              </a:spcAft>
+            </a:pPr>
+            <a:r>
+              <a:rPr sz="1100" b="0">
+                <a:solidFill>
+                  <a:srgbClr val="1A1A1A"/>
+                </a:solidFill>
+              </a:rPr>
+              <a:t>16 faces in one frame: 1.271 s</a:t>
+            </a:r>
+          </a:p>
+          <a:p>
+            <a:pPr>
+              <a:spcAft>
+                <a:spcPts val="500"/>
+              </a:spcAft>
+            </a:pPr>
+            <a:r>
+              <a:rPr sz="1100" b="0">
+                <a:solidFill>
+                  <a:srgbClr val="1A1A1A"/>
+                </a:solidFill>
+              </a:rPr>
+              <a:t>10,000 enrolled students: +1.2 ms per match</a:t>
+            </a:r>
+          </a:p>
+          <a:p>
+            <a:pPr>
+              <a:spcAft>
+                <a:spcPts val="500"/>
+              </a:spcAft>
+            </a:pPr>
+            <a:r>
+              <a:rPr sz="1100" b="0">
+                <a:solidFill>
+                  <a:srgbClr val="1A1A1A"/>
+                </a:solidFill>
+              </a:rPr>
+              <a:t>One 1080p camera covers ~7 m — a classroom</a:t>
+            </a:r>
+          </a:p>
+          <a:p>
+            <a:pPr>
+              <a:spcAft>
+                <a:spcPts val="500"/>
+              </a:spcAft>
+            </a:pPr>
+            <a:r>
+              <a:rPr sz="1100" b="0">
                 <a:solidFill>
                   <a:srgbClr val="1A1A1A"/>
                 </a:solidFill>
@@ -4784,72 +6010,57 @@
               </a:spcAft>
             </a:pPr>
             <a:r>
-              <a:rPr sz="1050" b="1">
+              <a:rPr sz="1100" b="1">
+                <a:solidFill>
+                  <a:srgbClr val="1F3A6E"/>
+                </a:solidFill>
+              </a:rPr>
+              <a:t>Key findings</a:t>
+            </a:r>
+          </a:p>
+          <a:p>
+            <a:pPr>
+              <a:spcAft>
+                <a:spcPts val="500"/>
+              </a:spcAft>
+            </a:pPr>
+            <a:r>
+              <a:rPr sz="1100" b="0">
+                <a:solidFill>
+                  <a:srgbClr val="1A1A1A"/>
+                </a:solidFill>
+              </a:rPr>
+              <a:t>Calibrating the threshold cut strangers admitted 4×.</a:t>
+            </a:r>
+          </a:p>
+          <a:p>
+            <a:pPr>
+              <a:spcAft>
+                <a:spcPts val="500"/>
+              </a:spcAft>
+            </a:pPr>
+            <a:r>
+              <a:rPr sz="1100" b="0">
+                <a:solidFill>
+                  <a:srgbClr val="1A1A1A"/>
+                </a:solidFill>
+              </a:rPr>
+              <a:t>Temporal voting drove wrong records to zero.</a:t>
+            </a:r>
+          </a:p>
+          <a:p>
+            <a:pPr>
+              <a:spcAft>
+                <a:spcPts val="500"/>
+              </a:spcAft>
+            </a:pPr>
+            <a:r>
+              <a:rPr sz="1100" b="1">
                 <a:solidFill>
                   <a:srgbClr val="C0392B"/>
                 </a:solidFill>
               </a:rPr>
-              <a:t>Honest limitations</a:t>
-            </a:r>
-          </a:p>
-          <a:p>
-            <a:pPr>
-              <a:spcAft>
-                <a:spcPts val="500"/>
-              </a:spcAft>
-            </a:pPr>
-            <a:r>
-              <a:rPr sz="1050" b="0">
-                <a:solidFill>
-                  <a:srgbClr val="1A1A1A"/>
-                </a:solidFill>
-              </a:rPr>
-              <a:t>A VIDEO replay would still pass — we raise the attack cost from</a:t>
-            </a:r>
-          </a:p>
-          <a:p>
-            <a:pPr>
-              <a:spcAft>
-                <a:spcPts val="500"/>
-              </a:spcAft>
-            </a:pPr>
-            <a:r>
-              <a:rPr sz="1050" b="0">
-                <a:solidFill>
-                  <a:srgbClr val="1A1A1A"/>
-                </a:solidFill>
-              </a:rPr>
-              <a:t>'print a photo' to 'record and replay a video', not to zero.</a:t>
-            </a:r>
-          </a:p>
-          <a:p>
-            <a:pPr>
-              <a:spcAft>
-                <a:spcPts val="500"/>
-              </a:spcAft>
-            </a:pPr>
-            <a:r>
-              <a:rPr sz="1050" b="0">
-                <a:solidFill>
-                  <a:srgbClr val="1A1A1A"/>
-                </a:solidFill>
-              </a:rPr>
-              <a:t>The top-2 margin guard did not help; the cohort has no look-alikes.</a:t>
-            </a:r>
-          </a:p>
-          <a:p>
-            <a:pPr>
-              <a:spcAft>
-                <a:spcPts val="500"/>
-              </a:spcAft>
-            </a:pPr>
-            <a:r>
-              <a:rPr sz="1050" b="0">
-                <a:solidFill>
-                  <a:srgbClr val="1A1A1A"/>
-                </a:solidFill>
-              </a:rPr>
-              <a:t>Only 2 real users enrolled — the numbers above come from the 30-identity cohort.</a:t>
+              <a:t>The top-2 margin guard did NOT help — we report it.</a:t>
             </a:r>
           </a:p>
         </p:txBody>
@@ -4862,7 +6073,7 @@
 </p:sld>
 </file>
 
-<file path=ppt/slides/slide5.xml><?xml version="1.0" encoding="utf-8"?>
+<file path=ppt/slides/slide9.xml><?xml version="1.0" encoding="utf-8"?>
 <p:sld xmlns:a="http://schemas.openxmlformats.org/drawingml/2006/main" xmlns:p="http://schemas.openxmlformats.org/presentationml/2006/main" xmlns:r="http://schemas.openxmlformats.org/officeDocument/2006/relationships">
   <p:cSld>
     <p:spTree>
@@ -4880,8 +6091,8 @@
         </p:nvSpPr>
         <p:spPr>
           <a:xfrm>
-            <a:off x="411480" y="201168"/>
-            <a:ext cx="11338560" cy="685800"/>
+            <a:off x="365760" y="182880"/>
+            <a:ext cx="11430000" cy="640080"/>
           </a:xfrm>
           <a:prstGeom prst="rect">
             <a:avLst/>
@@ -4896,12 +6107,12 @@
           <a:p>
             <a:pPr algn="ctr"/>
             <a:r>
-              <a:rPr sz="3000" b="1">
+              <a:rPr sz="2800" b="1">
                 <a:solidFill>
                   <a:srgbClr val="1F3A6E"/>
                 </a:solidFill>
               </a:rPr>
-              <a:t>IMPACT AND BENEFITS</a:t>
+              <a:t>CONCLUSION</a:t>
             </a:r>
           </a:p>
         </p:txBody>
@@ -4914,8 +6125,8 @@
         </p:nvSpPr>
         <p:spPr>
           <a:xfrm>
-            <a:off x="502920" y="1097280"/>
-            <a:ext cx="5852160" cy="5120640"/>
+            <a:off x="640080" y="1097280"/>
+            <a:ext cx="6583680" cy="5120640"/>
           </a:xfrm>
           <a:prstGeom prst="rect">
             <a:avLst/>
@@ -4934,206 +6145,205 @@
               </a:spcAft>
             </a:pPr>
             <a:r>
-              <a:rPr sz="1200" b="1">
+              <a:rPr sz="1250" b="1">
                 <a:solidFill>
                   <a:srgbClr val="1F3A6E"/>
                 </a:solidFill>
               </a:rPr>
-              <a:t>Impact on the target audience</a:t>
-            </a:r>
-          </a:p>
-          <a:p>
-            <a:pPr>
-              <a:spcAft>
-                <a:spcPts val="500"/>
-              </a:spcAft>
-            </a:pPr>
-            <a:r>
-              <a:rPr sz="1200" b="0">
-                <a:solidFill>
-                  <a:srgbClr val="1A1A1A"/>
-                </a:solidFill>
-              </a:rPr>
-              <a:t>A 60-student roll-call takes ~5 minutes of every lecture. Over a 200-day year</a:t>
-            </a:r>
-          </a:p>
-          <a:p>
-            <a:pPr>
-              <a:spcAft>
-                <a:spcPts val="500"/>
-              </a:spcAft>
-            </a:pPr>
-            <a:r>
-              <a:rPr sz="1200" b="0">
-                <a:solidFill>
-                  <a:srgbClr val="1A1A1A"/>
-                </a:solidFill>
-              </a:rPr>
-              <a:t>that is roughly 80 hours of teaching time returned to teaching.</a:t>
-            </a:r>
-          </a:p>
-          <a:p>
-            <a:pPr>
-              <a:spcAft>
-                <a:spcPts val="500"/>
-              </a:spcAft>
-            </a:pPr>
-            <a:r>
-              <a:rPr sz="1200" b="0">
-                <a:solidFill>
-                  <a:srgbClr val="1A1A1A"/>
-                </a:solidFill>
-              </a:rPr>
-              <a:t>Attendance is marked without contact, without a queue, and without a register</a:t>
-            </a:r>
-          </a:p>
-          <a:p>
-            <a:pPr>
-              <a:spcAft>
-                <a:spcPts val="500"/>
-              </a:spcAft>
-            </a:pPr>
-            <a:r>
-              <a:rPr sz="1200" b="0">
-                <a:solidFill>
-                  <a:srgbClr val="1A1A1A"/>
-                </a:solidFill>
-              </a:rPr>
-              <a:t>that can be signed by a friend.</a:t>
-            </a:r>
-          </a:p>
-          <a:p>
-            <a:pPr>
-              <a:spcAft>
-                <a:spcPts val="500"/>
-              </a:spcAft>
-            </a:pPr>
-          </a:p>
-          <a:p>
-            <a:pPr>
-              <a:spcAft>
-                <a:spcPts val="500"/>
-              </a:spcAft>
-            </a:pPr>
-            <a:r>
-              <a:rPr sz="1200" b="1">
-                <a:solidFill>
-                  <a:srgbClr val="1F3A6E"/>
-                </a:solidFill>
-              </a:rPr>
-              <a:t>Social — the proxy problem, honestly</a:t>
-            </a:r>
-          </a:p>
-          <a:p>
-            <a:pPr>
-              <a:spcAft>
-                <a:spcPts val="500"/>
-              </a:spcAft>
-            </a:pPr>
-            <a:r>
-              <a:rPr sz="1200" b="0">
-                <a:solidFill>
-                  <a:srgbClr val="1A1A1A"/>
-                </a:solidFill>
-              </a:rPr>
-              <a:t>Manual proxy (a friend signing for you) is eliminated.</a:t>
-            </a:r>
-          </a:p>
-          <a:p>
-            <a:pPr>
-              <a:spcAft>
-                <a:spcPts val="500"/>
-              </a:spcAft>
-            </a:pPr>
-            <a:r>
-              <a:rPr sz="1200" b="0">
-                <a:solidFill>
-                  <a:srgbClr val="1A1A1A"/>
-                </a:solidFill>
-              </a:rPr>
-              <a:t>Photo/screen proxy is blocked by liveness — measured 100% → 0%.</a:t>
-            </a:r>
-          </a:p>
-          <a:p>
-            <a:pPr>
-              <a:spcAft>
-                <a:spcPts val="500"/>
-              </a:spcAft>
-            </a:pPr>
-            <a:r>
-              <a:rPr sz="1200" b="0">
-                <a:solidFill>
-                  <a:srgbClr val="C0392B"/>
-                </a:solidFill>
-              </a:rPr>
-              <a:t>Video-replay proxy is NOT yet blocked. We state this rather than hide it.</a:t>
-            </a:r>
-          </a:p>
-          <a:p>
-            <a:pPr>
-              <a:spcAft>
-                <a:spcPts val="500"/>
-              </a:spcAft>
-            </a:pPr>
-          </a:p>
-          <a:p>
-            <a:pPr>
-              <a:spcAft>
-                <a:spcPts val="500"/>
-              </a:spcAft>
-            </a:pPr>
-            <a:r>
-              <a:rPr sz="1200" b="1">
-                <a:solidFill>
-                  <a:srgbClr val="1F3A6E"/>
-                </a:solidFill>
-              </a:rPr>
-              <a:t>Privacy — why this beats a cloud face API</a:t>
-            </a:r>
-          </a:p>
-          <a:p>
-            <a:pPr>
-              <a:spcAft>
-                <a:spcPts val="500"/>
-              </a:spcAft>
-            </a:pPr>
-            <a:r>
-              <a:rPr sz="1200" b="0">
-                <a:solidFill>
-                  <a:srgbClr val="1A1A1A"/>
-                </a:solidFill>
-              </a:rPr>
-              <a:t>The system runs fully offline. Students' faces never leave the campus.</a:t>
-            </a:r>
-          </a:p>
-          <a:p>
-            <a:pPr>
-              <a:spcAft>
-                <a:spcPts val="500"/>
-              </a:spcAft>
-            </a:pPr>
-            <a:r>
-              <a:rPr sz="1200" b="0">
-                <a:solidFill>
-                  <a:srgbClr val="1A1A1A"/>
-                </a:solidFill>
-              </a:rPr>
-              <a:t>Under India's DPDP Act 2023, biometric data is sensitive personal data —</a:t>
-            </a:r>
-          </a:p>
-          <a:p>
-            <a:pPr>
-              <a:spcAft>
-                <a:spcPts val="500"/>
-              </a:spcAft>
-            </a:pPr>
-            <a:r>
-              <a:rPr sz="1200" b="0">
-                <a:solidFill>
-                  <a:srgbClr val="1A1A1A"/>
-                </a:solidFill>
-              </a:rPr>
-              <a:t>uploading children's faces to a third-party cloud is a liability, not a feature.</a:t>
+              <a:t>A pretrained face model is not an attendance system.</a:t>
+            </a:r>
+          </a:p>
+          <a:p>
+            <a:pPr>
+              <a:spcAft>
+                <a:spcPts val="500"/>
+              </a:spcAft>
+            </a:pPr>
+            <a:r>
+              <a:rPr sz="1250" b="0">
+                <a:solidFill>
+                  <a:srgbClr val="1A1A1A"/>
+                </a:solidFill>
+              </a:rPr>
+              <a:t>It fails in three measurable ways, and each one is fixable in the decision layer.</a:t>
+            </a:r>
+          </a:p>
+          <a:p>
+            <a:pPr>
+              <a:spcAft>
+                <a:spcPts val="500"/>
+              </a:spcAft>
+            </a:pPr>
+          </a:p>
+          <a:p>
+            <a:pPr>
+              <a:spcAft>
+                <a:spcPts val="500"/>
+              </a:spcAft>
+            </a:pPr>
+            <a:r>
+              <a:rPr sz="1250" b="1">
+                <a:solidFill>
+                  <a:srgbClr val="1A1A1A"/>
+                </a:solidFill>
+              </a:rPr>
+              <a:t>Automation</a:t>
+            </a:r>
+          </a:p>
+          <a:p>
+            <a:pPr>
+              <a:spcAft>
+                <a:spcPts val="500"/>
+              </a:spcAft>
+            </a:pPr>
+            <a:r>
+              <a:rPr sz="1250" b="0">
+                <a:solidFill>
+                  <a:srgbClr val="1A1A1A"/>
+                </a:solidFill>
+              </a:rPr>
+              <a:t>Every face in the frame detected and identified in one pass; enrolment takes 1.4 s.</a:t>
+            </a:r>
+          </a:p>
+          <a:p>
+            <a:pPr>
+              <a:spcAft>
+                <a:spcPts val="500"/>
+              </a:spcAft>
+            </a:pPr>
+          </a:p>
+          <a:p>
+            <a:pPr>
+              <a:spcAft>
+                <a:spcPts val="500"/>
+              </a:spcAft>
+            </a:pPr>
+            <a:r>
+              <a:rPr sz="1250" b="1">
+                <a:solidFill>
+                  <a:srgbClr val="1A1A1A"/>
+                </a:solidFill>
+              </a:rPr>
+              <a:t>Integrity</a:t>
+            </a:r>
+          </a:p>
+          <a:p>
+            <a:pPr>
+              <a:spcAft>
+                <a:spcPts val="500"/>
+              </a:spcAft>
+            </a:pPr>
+            <a:r>
+              <a:rPr sz="1250" b="0">
+                <a:solidFill>
+                  <a:srgbClr val="1A1A1A"/>
+                </a:solidFill>
+              </a:rPr>
+              <a:t>Manual proxy (a friend signing the register) is eliminated. Photo and screen proxy</a:t>
+            </a:r>
+          </a:p>
+          <a:p>
+            <a:pPr>
+              <a:spcAft>
+                <a:spcPts val="500"/>
+              </a:spcAft>
+            </a:pPr>
+            <a:r>
+              <a:rPr sz="1250" b="0">
+                <a:solidFill>
+                  <a:srgbClr val="1A1A1A"/>
+                </a:solidFill>
+              </a:rPr>
+              <a:t>is blocked by liveness — attack success 100% → 0%. Strangers admitted: 0.20%.</a:t>
+            </a:r>
+          </a:p>
+          <a:p>
+            <a:pPr>
+              <a:spcAft>
+                <a:spcPts val="500"/>
+              </a:spcAft>
+            </a:pPr>
+          </a:p>
+          <a:p>
+            <a:pPr>
+              <a:spcAft>
+                <a:spcPts val="500"/>
+              </a:spcAft>
+            </a:pPr>
+            <a:r>
+              <a:rPr sz="1250" b="1">
+                <a:solidFill>
+                  <a:srgbClr val="1A1A1A"/>
+                </a:solidFill>
+              </a:rPr>
+              <a:t>Precision</a:t>
+            </a:r>
+          </a:p>
+          <a:p>
+            <a:pPr>
+              <a:spcAft>
+                <a:spcPts val="500"/>
+              </a:spcAft>
+            </a:pPr>
+            <a:r>
+              <a:rPr sz="1250" b="0">
+                <a:solidFill>
+                  <a:srgbClr val="1A1A1A"/>
+                </a:solidFill>
+              </a:rPr>
+              <a:t>Open-set rejection with a threshold calibrated on 2,880 impostor faces. Faces below</a:t>
+            </a:r>
+          </a:p>
+          <a:p>
+            <a:pPr>
+              <a:spcAft>
+                <a:spcPts val="500"/>
+              </a:spcAft>
+            </a:pPr>
+            <a:r>
+              <a:rPr sz="1250" b="0">
+                <a:solidFill>
+                  <a:srgbClr val="1A1A1A"/>
+                </a:solidFill>
+              </a:rPr>
+              <a:t>40 px are refused rather than guessed at. Wrong attendance records: 0%.</a:t>
+            </a:r>
+          </a:p>
+          <a:p>
+            <a:pPr>
+              <a:spcAft>
+                <a:spcPts val="500"/>
+              </a:spcAft>
+            </a:pPr>
+          </a:p>
+          <a:p>
+            <a:pPr>
+              <a:spcAft>
+                <a:spcPts val="500"/>
+              </a:spcAft>
+            </a:pPr>
+            <a:r>
+              <a:rPr sz="1250" b="1">
+                <a:solidFill>
+                  <a:srgbClr val="1A1A1A"/>
+                </a:solidFill>
+              </a:rPr>
+              <a:t>Efficiency</a:t>
+            </a:r>
+          </a:p>
+          <a:p>
+            <a:pPr>
+              <a:spcAft>
+                <a:spcPts val="500"/>
+              </a:spcAft>
+            </a:pPr>
+            <a:r>
+              <a:rPr sz="1250" b="0">
+                <a:solidFill>
+                  <a:srgbClr val="1A1A1A"/>
+                </a:solidFill>
+              </a:rPr>
+              <a:t>16 faces per frame in 1.3 s on a laptop CPU. Fully offline: no cloud, no GPU, ₹0/year.</a:t>
             </a:r>
           </a:p>
         </p:txBody>
@@ -5146,8 +6356,8 @@
         </p:nvSpPr>
         <p:spPr>
           <a:xfrm>
-            <a:off x="6492240" y="1097280"/>
-            <a:ext cx="5212080" cy="5120640"/>
+            <a:off x="7406640" y="1097280"/>
+            <a:ext cx="4389120" cy="5120640"/>
           </a:xfrm>
           <a:prstGeom prst="rect">
             <a:avLst/>
@@ -5166,549 +6376,235 @@
               </a:spcAft>
             </a:pPr>
             <a:r>
-              <a:rPr sz="1200" b="1">
-                <a:solidFill>
-                  <a:srgbClr val="1F3A6E"/>
-                </a:solidFill>
-              </a:rPr>
-              <a:t>Economic</a:t>
-            </a:r>
-          </a:p>
-          <a:p>
-            <a:pPr>
-              <a:spcAft>
-                <a:spcPts val="500"/>
-              </a:spcAft>
-            </a:pPr>
-            <a:r>
-              <a:rPr sz="1200" b="0">
-                <a:solidFill>
-                  <a:srgbClr val="1A1A1A"/>
-                </a:solidFill>
-              </a:rPr>
-              <a:t>Our system: one laptop + one webcam. No GPU. No servers. No per-scan fee.</a:t>
-            </a:r>
-          </a:p>
-          <a:p>
-            <a:pPr>
-              <a:spcAft>
-                <a:spcPts val="500"/>
-              </a:spcAft>
-            </a:pPr>
-            <a:r>
-              <a:rPr sz="1200" b="0">
-                <a:solidFill>
-                  <a:srgbClr val="1A1A1A"/>
-                </a:solidFill>
-              </a:rPr>
-              <a:t>Recurring cost ≈ ₹0.</a:t>
-            </a:r>
-          </a:p>
-          <a:p>
-            <a:pPr>
-              <a:spcAft>
-                <a:spcPts val="500"/>
-              </a:spcAft>
-            </a:pPr>
-          </a:p>
-          <a:p>
-            <a:pPr>
-              <a:spcAft>
-                <a:spcPts val="500"/>
-              </a:spcAft>
-            </a:pPr>
-            <a:r>
-              <a:rPr sz="1200" b="0">
-                <a:solidFill>
-                  <a:srgbClr val="1A1A1A"/>
-                </a:solidFill>
-              </a:rPr>
-              <a:t>A cloud face API (≈ $0.001 per image) for continuous classroom scanning:</a:t>
-            </a:r>
-          </a:p>
-          <a:p>
-            <a:pPr>
-              <a:spcAft>
-                <a:spcPts val="500"/>
-              </a:spcAft>
-            </a:pPr>
-            <a:r>
-              <a:rPr sz="1200" b="1">
+              <a:rPr sz="1050" b="1">
                 <a:solidFill>
                   <a:srgbClr val="C0392B"/>
                 </a:solidFill>
               </a:rPr>
-              <a:t>≈ ₹1,50,000 per year, per school — and it uploads every student's face.</a:t>
-            </a:r>
-          </a:p>
-          <a:p>
-            <a:pPr>
-              <a:spcAft>
-                <a:spcPts val="500"/>
-              </a:spcAft>
-            </a:pPr>
-          </a:p>
-          <a:p>
-            <a:pPr>
-              <a:spcAft>
-                <a:spcPts val="500"/>
-              </a:spcAft>
-            </a:pPr>
-            <a:r>
-              <a:rPr sz="1200" b="1">
-                <a:solidFill>
-                  <a:srgbClr val="1F3A6E"/>
-                </a:solidFill>
-              </a:rPr>
-              <a:t>Scalability</a:t>
-            </a:r>
-          </a:p>
-          <a:p>
-            <a:pPr>
-              <a:spcAft>
-                <a:spcPts val="500"/>
-              </a:spcAft>
-            </a:pPr>
-            <a:r>
-              <a:rPr sz="1200" b="0">
-                <a:solidFill>
-                  <a:srgbClr val="1A1A1A"/>
-                </a:solidFill>
-              </a:rPr>
-              <a:t>Enrolling 10,000 students costs 1.2 ms per match, because the deep model is</a:t>
-            </a:r>
-          </a:p>
-          <a:p>
-            <a:pPr>
-              <a:spcAft>
-                <a:spcPts val="500"/>
-              </a:spcAft>
-            </a:pPr>
-            <a:r>
-              <a:rPr sz="1200" b="0">
-                <a:solidFill>
-                  <a:srgbClr val="1A1A1A"/>
-                </a:solidFill>
-              </a:rPr>
-              <a:t>frozen and matching is a matrix multiply. A trained-CNN approach would need</a:t>
-            </a:r>
-          </a:p>
-          <a:p>
-            <a:pPr>
-              <a:spcAft>
-                <a:spcPts val="500"/>
-              </a:spcAft>
-            </a:pPr>
-            <a:r>
-              <a:rPr sz="1200" b="0">
-                <a:solidFill>
-                  <a:srgbClr val="1A1A1A"/>
-                </a:solidFill>
-              </a:rPr>
-              <a:t>retraining every time a student joins.</a:t>
-            </a:r>
-          </a:p>
-          <a:p>
-            <a:pPr>
-              <a:spcAft>
-                <a:spcPts val="500"/>
-              </a:spcAft>
-            </a:pPr>
-          </a:p>
-          <a:p>
-            <a:pPr>
-              <a:spcAft>
-                <a:spcPts val="500"/>
-              </a:spcAft>
-            </a:pPr>
-            <a:r>
-              <a:rPr sz="1200" b="1">
-                <a:solidFill>
-                  <a:srgbClr val="1F3A6E"/>
-                </a:solidFill>
-              </a:rPr>
-              <a:t>Auditability</a:t>
-            </a:r>
-          </a:p>
-          <a:p>
-            <a:pPr>
-              <a:spcAft>
-                <a:spcPts val="500"/>
-              </a:spcAft>
-            </a:pPr>
-            <a:r>
-              <a:rPr sz="1200" b="0">
-                <a:solidFill>
-                  <a:srgbClr val="1A1A1A"/>
-                </a:solidFill>
-              </a:rPr>
-              <a:t>Every decision exposes its evidence — the similarity score, the runner-up</a:t>
-            </a:r>
-          </a:p>
-          <a:p>
-            <a:pPr>
-              <a:spcAft>
-                <a:spcPts val="500"/>
-              </a:spcAft>
-            </a:pPr>
-            <a:r>
-              <a:rPr sz="1200" b="0">
-                <a:solidFill>
-                  <a:srgbClr val="1A1A1A"/>
-                </a:solidFill>
-              </a:rPr>
-              <a:t>margin, the face size, the liveness verdict. A disputed attendance record can</a:t>
-            </a:r>
-          </a:p>
-          <a:p>
-            <a:pPr>
-              <a:spcAft>
-                <a:spcPts val="500"/>
-              </a:spcAft>
-            </a:pPr>
-            <a:r>
-              <a:rPr sz="1200" b="0">
-                <a:solidFill>
-                  <a:srgbClr val="1A1A1A"/>
-                </a:solidFill>
-              </a:rPr>
-              <a:t>be explained. Commercial systems are black boxes.</a:t>
-            </a:r>
-          </a:p>
-        </p:txBody>
-      </p:sp>
-    </p:spTree>
-  </p:cSld>
-  <p:clrMapOvr>
-    <a:masterClrMapping/>
-  </p:clrMapOvr>
-</p:sld>
-</file>
-
-<file path=ppt/slides/slide6.xml><?xml version="1.0" encoding="utf-8"?>
-<p:sld xmlns:a="http://schemas.openxmlformats.org/drawingml/2006/main" xmlns:p="http://schemas.openxmlformats.org/presentationml/2006/main" xmlns:r="http://schemas.openxmlformats.org/officeDocument/2006/relationships">
-  <p:cSld>
-    <p:spTree>
-      <p:nvGrpSpPr>
-        <p:cNvPr id="1" name=""/>
-        <p:cNvGrpSpPr/>
-        <p:nvPr/>
-      </p:nvGrpSpPr>
-      <p:grpSpPr/>
-      <p:sp>
-        <p:nvSpPr>
-          <p:cNvPr id="2" name="TextBox 1"/>
-          <p:cNvSpPr txBox="1"/>
-          <p:nvPr/>
-        </p:nvSpPr>
-        <p:spPr>
-          <a:xfrm>
-            <a:off x="411480" y="201168"/>
-            <a:ext cx="11338560" cy="685800"/>
-          </a:xfrm>
-          <a:prstGeom prst="rect">
-            <a:avLst/>
-          </a:prstGeom>
-          <a:noFill/>
-        </p:spPr>
-        <p:txBody>
-          <a:bodyPr wrap="none">
-            <a:spAutoFit/>
-          </a:bodyPr>
-          <a:lstStyle/>
-          <a:p>
-            <a:pPr algn="ctr"/>
-            <a:r>
-              <a:rPr sz="3000" b="1">
-                <a:solidFill>
-                  <a:srgbClr val="1F3A6E"/>
-                </a:solidFill>
-              </a:rPr>
-              <a:t>RESEARCH AND REFERENCES</a:t>
-            </a:r>
-          </a:p>
-        </p:txBody>
-      </p:sp>
-      <p:sp>
-        <p:nvSpPr>
-          <p:cNvPr id="3" name="TextBox 2"/>
-          <p:cNvSpPr txBox="1"/>
-          <p:nvPr/>
-        </p:nvSpPr>
-        <p:spPr>
-          <a:xfrm>
-            <a:off x="502920" y="1005840"/>
-            <a:ext cx="11247120" cy="5394960"/>
-          </a:xfrm>
-          <a:prstGeom prst="rect">
-            <a:avLst/>
-          </a:prstGeom>
-          <a:noFill/>
-        </p:spPr>
-        <p:txBody>
-          <a:bodyPr wrap="square">
-            <a:spAutoFit/>
-          </a:bodyPr>
-          <a:lstStyle/>
-          <a:p>
-            <a:pPr>
-              <a:spcAft>
-                <a:spcPts val="500"/>
-              </a:spcAft>
-            </a:pPr>
-            <a:r>
-              <a:rPr sz="1000" b="1">
-                <a:solidFill>
-                  <a:srgbClr val="1F3A6E"/>
-                </a:solidFill>
-              </a:rPr>
-              <a:t>Core models used (pretrained, frozen — not our contribution)</a:t>
-            </a:r>
-          </a:p>
-          <a:p>
-            <a:pPr>
-              <a:spcAft>
-                <a:spcPts val="500"/>
-              </a:spcAft>
-            </a:pPr>
-            <a:r>
-              <a:rPr sz="1000" b="0">
-                <a:solidFill>
-                  <a:srgbClr val="1A1A1A"/>
-                </a:solidFill>
-              </a:rPr>
-              <a:t>[1]  Deng, J., Guo, J., Xue, N., Zafeiriou, S. (2019). ArcFace: Additive Angular Margin Loss for Deep Face Recognition. CVPR 2019, pp. 4690–4699.  DOI: 10.1109/CVPR.2019.00482</a:t>
-            </a:r>
-          </a:p>
-          <a:p>
-            <a:pPr>
-              <a:spcAft>
-                <a:spcPts val="500"/>
-              </a:spcAft>
-            </a:pPr>
-            <a:r>
-              <a:rPr sz="1000" b="0">
-                <a:solidFill>
-                  <a:srgbClr val="1A1A1A"/>
-                </a:solidFill>
-              </a:rPr>
-              <a:t>[2]  Deng, J., Guo, J., Ververas, E., Kotsia, I., Zafeiriou, S. (2020). RetinaFace: Single-Shot Multi-Level Face Localisation in the Wild. CVPR 2020.  DOI: 10.1109/CVPR42600.2020.00525</a:t>
-            </a:r>
-          </a:p>
-          <a:p>
-            <a:pPr>
-              <a:spcAft>
-                <a:spcPts val="500"/>
-              </a:spcAft>
-            </a:pPr>
-            <a:r>
-              <a:rPr sz="1000" b="0">
-                <a:solidFill>
-                  <a:srgbClr val="1A1A1A"/>
-                </a:solidFill>
-              </a:rPr>
-              <a:t>[3]  Schroff, F., Kalenichenko, D., Philbin, J. (2015). FaceNet: A Unified Embedding for Face Recognition and Clustering. CVPR 2015, pp. 815–823.  DOI: 10.1109/CVPR.2015.7298682</a:t>
-            </a:r>
-          </a:p>
-          <a:p>
-            <a:pPr>
-              <a:spcAft>
-                <a:spcPts val="500"/>
-              </a:spcAft>
-            </a:pPr>
-          </a:p>
-          <a:p>
-            <a:pPr>
-              <a:spcAft>
-                <a:spcPts val="500"/>
-              </a:spcAft>
-            </a:pPr>
-            <a:r>
-              <a:rPr sz="1000" b="1">
-                <a:solidFill>
-                  <a:srgbClr val="1F3A6E"/>
-                </a:solidFill>
-              </a:rPr>
-              <a:t>Attendance systems — prior work (none of which addresses spoofing)</a:t>
-            </a:r>
-          </a:p>
-          <a:p>
-            <a:pPr>
-              <a:spcAft>
-                <a:spcPts val="500"/>
-              </a:spcAft>
-            </a:pPr>
-            <a:r>
-              <a:rPr sz="1000" b="0">
-                <a:solidFill>
-                  <a:srgbClr val="1A1A1A"/>
-                </a:solidFill>
-              </a:rPr>
-              <a:t>[4]  D'Souza, J. W. S., et al. (2019). Automated Attendance Marking and Management System by Facial Recognition Using Histogram. Array, 3–4: 100014.</a:t>
-            </a:r>
-          </a:p>
-          <a:p>
-            <a:pPr>
-              <a:spcAft>
-                <a:spcPts val="500"/>
-              </a:spcAft>
-            </a:pPr>
-            <a:r>
-              <a:rPr sz="1000" b="0">
-                <a:solidFill>
-                  <a:srgbClr val="1A1A1A"/>
-                </a:solidFill>
-              </a:rPr>
-              <a:t>[5]  Arsenovic, M., Sladojevic, S., Anderla, A., Stefanovic, D. (2017). FaceTime — Deep Learning Based Face Recognition Attendance System. IEEE SISY 2017, pp. 53–58.</a:t>
-            </a:r>
-          </a:p>
-          <a:p>
-            <a:pPr>
-              <a:spcAft>
-                <a:spcPts val="500"/>
-              </a:spcAft>
-            </a:pPr>
-            <a:r>
-              <a:rPr sz="1000" b="0">
-                <a:solidFill>
-                  <a:srgbClr val="1A1A1A"/>
-                </a:solidFill>
-              </a:rPr>
-              <a:t>[6]  Kakarla, S., et al. (2020). Smart Attendance Management System Based on Face Recognition Using CNN. IEEE-HYDCON 2020, pp. 1–5.  DOI: 10.1109/HYDCON48903.2020.9242847</a:t>
-            </a:r>
-          </a:p>
-          <a:p>
-            <a:pPr>
-              <a:spcAft>
-                <a:spcPts val="500"/>
-              </a:spcAft>
-            </a:pPr>
-            <a:r>
-              <a:rPr sz="1000" b="0">
-                <a:solidFill>
-                  <a:srgbClr val="1A1A1A"/>
-                </a:solidFill>
-              </a:rPr>
-              <a:t>[7]  Varadharajan, E., et al. (2016). Automatic Attendance Management System Using Face Detection. IC-GET 2016, pp. 1–3.  DOI: 10.1109/GET.2016.7916753</a:t>
-            </a:r>
-          </a:p>
-          <a:p>
-            <a:pPr>
-              <a:spcAft>
-                <a:spcPts val="500"/>
-              </a:spcAft>
-            </a:pPr>
-            <a:r>
-              <a:rPr sz="1000" b="0">
-                <a:solidFill>
-                  <a:srgbClr val="1A1A1A"/>
-                </a:solidFill>
-              </a:rPr>
-              <a:t>[8]  Siswanto, A. R. S., Nugroho, A. S., Galinium, M. (2014). Implementation of Face Recognition Algorithm for Biometrics Based Time Attendance System. ICISS 2014, pp. 149–154.</a:t>
-            </a:r>
-          </a:p>
-          <a:p>
-            <a:pPr>
-              <a:spcAft>
-                <a:spcPts val="500"/>
-              </a:spcAft>
-            </a:pPr>
-          </a:p>
-          <a:p>
-            <a:pPr>
-              <a:spcAft>
-                <a:spcPts val="500"/>
-              </a:spcAft>
-            </a:pPr>
-            <a:r>
-              <a:rPr sz="1000" b="1">
-                <a:solidFill>
-                  <a:srgbClr val="1F3A6E"/>
-                </a:solidFill>
-              </a:rPr>
-              <a:t>Anti-spoofing / presentation attacks — the gap we address</a:t>
-            </a:r>
-          </a:p>
-          <a:p>
-            <a:pPr>
-              <a:spcAft>
-                <a:spcPts val="500"/>
-              </a:spcAft>
-            </a:pPr>
-            <a:r>
-              <a:rPr sz="1000" b="0">
-                <a:solidFill>
-                  <a:srgbClr val="1A1A1A"/>
-                </a:solidFill>
-              </a:rPr>
-              <a:t>[9]  Pan, G., Sun, L., Wu, Z., Lao, S. (2007). Eyeblink-based Anti-Spoofing in Face Recognition from a Generic Webcamera. ICCV 2007, pp. 1–8.</a:t>
-            </a:r>
-          </a:p>
-          <a:p>
-            <a:pPr>
-              <a:spcAft>
-                <a:spcPts val="500"/>
-              </a:spcAft>
-            </a:pPr>
-            <a:r>
-              <a:rPr sz="1000" b="0">
-                <a:solidFill>
-                  <a:srgbClr val="1A1A1A"/>
-                </a:solidFill>
-              </a:rPr>
-              <a:t>[10] ISO/IEC 30107-3:2023 — Biometric Presentation Attack Detection, Part 3: Testing and Reporting.</a:t>
-            </a:r>
-          </a:p>
-          <a:p>
-            <a:pPr>
-              <a:spcAft>
-                <a:spcPts val="500"/>
-              </a:spcAft>
-            </a:pPr>
-          </a:p>
-          <a:p>
-            <a:pPr>
-              <a:spcAft>
-                <a:spcPts val="500"/>
-              </a:spcAft>
-            </a:pPr>
-            <a:r>
-              <a:rPr sz="1000" b="1">
-                <a:solidFill>
-                  <a:srgbClr val="1F3A6E"/>
-                </a:solidFill>
-              </a:rPr>
-              <a:t>Data, code and reproducibility</a:t>
-            </a:r>
-          </a:p>
-          <a:p>
-            <a:pPr>
-              <a:spcAft>
-                <a:spcPts val="500"/>
-              </a:spcAft>
-            </a:pPr>
-            <a:r>
-              <a:rPr sz="1000" b="0">
-                <a:solidFill>
-                  <a:srgbClr val="1A1A1A"/>
-                </a:solidFill>
-              </a:rPr>
-              <a:t>Dataset: VGGFace2 (Cao et al., 2018) — 96 identities used as an impostor cohort.</a:t>
-            </a:r>
-          </a:p>
-          <a:p>
-            <a:pPr>
-              <a:spcAft>
-                <a:spcPts val="500"/>
-              </a:spcAft>
-            </a:pPr>
-            <a:r>
-              <a:rPr sz="1000" b="0">
-                <a:solidFill>
-                  <a:srgbClr val="1A1A1A"/>
-                </a:solidFill>
-              </a:rPr>
-              <a:t>Source code and all measurement scripts: github.com/SohamBhattacharjee2003/MutiFace-Attendance-System</a:t>
+              <a:t>LIMITATIONS &amp; FUTURE WORK</a:t>
+            </a:r>
+          </a:p>
+          <a:p>
+            <a:pPr>
+              <a:spcAft>
+                <a:spcPts val="500"/>
+              </a:spcAft>
+            </a:pPr>
+          </a:p>
+          <a:p>
+            <a:pPr>
+              <a:spcAft>
+                <a:spcPts val="500"/>
+              </a:spcAft>
+            </a:pPr>
+            <a:r>
+              <a:rPr sz="1050" b="1">
+                <a:solidFill>
+                  <a:srgbClr val="1A1A1A"/>
+                </a:solidFill>
+              </a:rPr>
+              <a:t>Video replay still defeats liveness.</a:t>
+            </a:r>
+          </a:p>
+          <a:p>
+            <a:pPr>
+              <a:spcAft>
+                <a:spcPts val="500"/>
+              </a:spcAft>
+            </a:pPr>
+            <a:r>
+              <a:rPr sz="1050" b="0">
+                <a:solidFill>
+                  <a:srgbClr val="1A1A1A"/>
+                </a:solidFill>
+              </a:rPr>
+              <a:t>A recorded face genuinely moves. We raise the attack cost from 'print a photo' to</a:t>
+            </a:r>
+          </a:p>
+          <a:p>
+            <a:pPr>
+              <a:spcAft>
+                <a:spcPts val="500"/>
+              </a:spcAft>
+            </a:pPr>
+            <a:r>
+              <a:rPr sz="1050" b="0">
+                <a:solidFill>
+                  <a:srgbClr val="1A1A1A"/>
+                </a:solidFill>
+              </a:rPr>
+              <a:t>'record and replay a video' — a real gain, not a complete defence. A depth or</a:t>
+            </a:r>
+          </a:p>
+          <a:p>
+            <a:pPr>
+              <a:spcAft>
+                <a:spcPts val="500"/>
+              </a:spcAft>
+            </a:pPr>
+            <a:r>
+              <a:rPr sz="1050" b="0">
+                <a:solidFill>
+                  <a:srgbClr val="1A1A1A"/>
+                </a:solidFill>
+              </a:rPr>
+              <a:t>texture-based anti-spoof model is the next step.</a:t>
+            </a:r>
+          </a:p>
+          <a:p>
+            <a:pPr>
+              <a:spcAft>
+                <a:spcPts val="500"/>
+              </a:spcAft>
+            </a:pPr>
+          </a:p>
+          <a:p>
+            <a:pPr>
+              <a:spcAft>
+                <a:spcPts val="500"/>
+              </a:spcAft>
+            </a:pPr>
+            <a:r>
+              <a:rPr sz="1050" b="1">
+                <a:solidFill>
+                  <a:srgbClr val="1A1A1A"/>
+                </a:solidFill>
+              </a:rPr>
+              <a:t>The look-alike guard is unproven.</a:t>
+            </a:r>
+          </a:p>
+          <a:p>
+            <a:pPr>
+              <a:spcAft>
+                <a:spcPts val="500"/>
+              </a:spcAft>
+            </a:pPr>
+            <a:r>
+              <a:rPr sz="1050" b="0">
+                <a:solidFill>
+                  <a:srgbClr val="1A1A1A"/>
+                </a:solidFill>
+              </a:rPr>
+              <a:t>Our cohort contains no look-alike pairs, so the top-2 margin had nothing to catch.</a:t>
+            </a:r>
+          </a:p>
+          <a:p>
+            <a:pPr>
+              <a:spcAft>
+                <a:spcPts val="500"/>
+              </a:spcAft>
+            </a:pPr>
+            <a:r>
+              <a:rPr sz="1050" b="0">
+                <a:solidFill>
+                  <a:srgbClr val="1A1A1A"/>
+                </a:solidFill>
+              </a:rPr>
+              <a:t>We cannot claim it works.</a:t>
+            </a:r>
+          </a:p>
+          <a:p>
+            <a:pPr>
+              <a:spcAft>
+                <a:spcPts val="500"/>
+              </a:spcAft>
+            </a:pPr>
+          </a:p>
+          <a:p>
+            <a:pPr>
+              <a:spcAft>
+                <a:spcPts val="500"/>
+              </a:spcAft>
+            </a:pPr>
+            <a:r>
+              <a:rPr sz="1050" b="1">
+                <a:solidFill>
+                  <a:srgbClr val="1A1A1A"/>
+                </a:solidFill>
+              </a:rPr>
+              <a:t>Only 2 real users enrolled.</a:t>
+            </a:r>
+          </a:p>
+          <a:p>
+            <a:pPr>
+              <a:spcAft>
+                <a:spcPts val="500"/>
+              </a:spcAft>
+            </a:pPr>
+            <a:r>
+              <a:rPr sz="1050" b="0">
+                <a:solidFill>
+                  <a:srgbClr val="1A1A1A"/>
+                </a:solidFill>
+              </a:rPr>
+              <a:t>All quantitative claims come from the 30-identity cohort. The live system is a</a:t>
+            </a:r>
+          </a:p>
+          <a:p>
+            <a:pPr>
+              <a:spcAft>
+                <a:spcPts val="500"/>
+              </a:spcAft>
+            </a:pPr>
+            <a:r>
+              <a:rPr sz="1050" b="0">
+                <a:solidFill>
+                  <a:srgbClr val="1A1A1A"/>
+                </a:solidFill>
+              </a:rPr>
+              <a:t>feasibility demonstration.</a:t>
+            </a:r>
+          </a:p>
+          <a:p>
+            <a:pPr>
+              <a:spcAft>
+                <a:spcPts val="500"/>
+              </a:spcAft>
+            </a:pPr>
+          </a:p>
+          <a:p>
+            <a:pPr>
+              <a:spcAft>
+                <a:spcPts val="500"/>
+              </a:spcAft>
+            </a:pPr>
+            <a:r>
+              <a:rPr sz="1050" b="1">
+                <a:solidFill>
+                  <a:srgbClr val="1A1A1A"/>
+                </a:solidFill>
+              </a:rPr>
+              <a:t>The cohort is photographic.</a:t>
+            </a:r>
+          </a:p>
+          <a:p>
+            <a:pPr>
+              <a:spcAft>
+                <a:spcPts val="500"/>
+              </a:spcAft>
+            </a:pPr>
+            <a:r>
+              <a:rPr sz="1050" b="0">
+                <a:solidFill>
+                  <a:srgbClr val="1A1A1A"/>
+                </a:solidFill>
+              </a:rPr>
+              <a:t>VGGFace2 images are cleaner than a classroom webcam, so real-world numbers will</a:t>
+            </a:r>
+          </a:p>
+          <a:p>
+            <a:pPr>
+              <a:spcAft>
+                <a:spcPts val="500"/>
+              </a:spcAft>
+            </a:pPr>
+            <a:r>
+              <a:rPr sz="1050" b="0">
+                <a:solidFill>
+                  <a:srgbClr val="1A1A1A"/>
+                </a:solidFill>
+              </a:rPr>
+              <a:t>be worse than these.</a:t>
             </a:r>
           </a:p>
         </p:txBody>

</xml_diff>

<commit_message>
Style the generated deck to match the department template
Adds the blue footer bar and slide numbers from the team's existing template, a rule
under each heading, and filled callout panels behind the load-bearing content: the
"a photo is marked present 100% of the time" finding on Problem Definition, the
research gap on Literature Review, the honest Innovation box on Methodology, and
Limitations on Conclusion.
</commit_message>
<xml_diff>
--- a/Server/results/PresenceAI_Presentation.pptx
+++ b/Server/results/PresenceAI_Presentation.pptx
@@ -3346,7 +3346,51 @@
       </p:sp>
       <p:sp>
         <p:nvSpPr>
-          <p:cNvPr id="3" name="TextBox 2"/>
+          <p:cNvPr id="3" name="Rectangle 2"/>
+          <p:cNvSpPr/>
+          <p:nvPr/>
+        </p:nvSpPr>
+        <p:spPr>
+          <a:xfrm>
+            <a:off x="4937760" y="841248"/>
+            <a:ext cx="2286000" cy="41148"/>
+          </a:xfrm>
+          <a:prstGeom prst="rect">
+            <a:avLst/>
+          </a:prstGeom>
+          <a:solidFill>
+            <a:srgbClr val="1F77C2"/>
+          </a:solidFill>
+          <a:ln>
+            <a:noFill/>
+          </a:ln>
+          <a:effectLst/>
+        </p:spPr>
+        <p:style>
+          <a:lnRef idx="1">
+            <a:schemeClr val="accent1"/>
+          </a:lnRef>
+          <a:fillRef idx="3">
+            <a:schemeClr val="accent1"/>
+          </a:fillRef>
+          <a:effectRef idx="2">
+            <a:schemeClr val="accent1"/>
+          </a:effectRef>
+          <a:fontRef idx="minor">
+            <a:schemeClr val="lt1"/>
+          </a:fontRef>
+        </p:style>
+        <p:txBody>
+          <a:bodyPr rtlCol="0" anchor="ctr"/>
+          <a:lstStyle/>
+          <a:p>
+            <a:pPr algn="ctr"/>
+          </a:p>
+        </p:txBody>
+      </p:sp>
+      <p:sp>
+        <p:nvSpPr>
+          <p:cNvPr id="4" name="TextBox 3"/>
           <p:cNvSpPr txBox="1"/>
           <p:nvPr/>
         </p:nvSpPr>
@@ -3598,6 +3642,84 @@
                 </a:solidFill>
               </a:rPr>
               <a:t>Source code and all measurement scripts: github.com/SohamBhattacharjee2003/MutiFace-Attendance-System</a:t>
+            </a:r>
+          </a:p>
+        </p:txBody>
+      </p:sp>
+      <p:sp>
+        <p:nvSpPr>
+          <p:cNvPr id="5" name="Rectangle 4"/>
+          <p:cNvSpPr/>
+          <p:nvPr/>
+        </p:nvSpPr>
+        <p:spPr>
+          <a:xfrm>
+            <a:off x="0" y="6446520"/>
+            <a:ext cx="12191695" cy="411480"/>
+          </a:xfrm>
+          <a:prstGeom prst="rect">
+            <a:avLst/>
+          </a:prstGeom>
+          <a:solidFill>
+            <a:srgbClr val="1F77C2"/>
+          </a:solidFill>
+          <a:ln>
+            <a:noFill/>
+          </a:ln>
+          <a:effectLst/>
+        </p:spPr>
+        <p:style>
+          <a:lnRef idx="1">
+            <a:schemeClr val="accent1"/>
+          </a:lnRef>
+          <a:fillRef idx="3">
+            <a:schemeClr val="accent1"/>
+          </a:fillRef>
+          <a:effectRef idx="2">
+            <a:schemeClr val="accent1"/>
+          </a:effectRef>
+          <a:fontRef idx="minor">
+            <a:schemeClr val="lt1"/>
+          </a:fontRef>
+        </p:style>
+        <p:txBody>
+          <a:bodyPr rtlCol="0" anchor="ctr"/>
+          <a:lstStyle/>
+          <a:p>
+            <a:pPr algn="ctr"/>
+          </a:p>
+        </p:txBody>
+      </p:sp>
+      <p:sp>
+        <p:nvSpPr>
+          <p:cNvPr id="6" name="TextBox 5"/>
+          <p:cNvSpPr txBox="1"/>
+          <p:nvPr/>
+        </p:nvSpPr>
+        <p:spPr>
+          <a:xfrm>
+            <a:off x="11430000" y="6473952"/>
+            <a:ext cx="640080" cy="365760"/>
+          </a:xfrm>
+          <a:prstGeom prst="rect">
+            <a:avLst/>
+          </a:prstGeom>
+          <a:noFill/>
+        </p:spPr>
+        <p:txBody>
+          <a:bodyPr wrap="none">
+            <a:spAutoFit/>
+          </a:bodyPr>
+          <a:lstStyle/>
+          <a:p>
+            <a:pPr algn="r"/>
+            <a:r>
+              <a:rPr sz="1200" b="1">
+                <a:solidFill>
+                  <a:srgbClr val="FFFFFF"/>
+                </a:solidFill>
+              </a:rPr>
+              <a:t>9</a:t>
             </a:r>
           </a:p>
         </p:txBody>
@@ -3650,6 +3772,84 @@
           </a:p>
         </p:txBody>
       </p:sp>
+      <p:sp>
+        <p:nvSpPr>
+          <p:cNvPr id="3" name="Rectangle 2"/>
+          <p:cNvSpPr/>
+          <p:nvPr/>
+        </p:nvSpPr>
+        <p:spPr>
+          <a:xfrm>
+            <a:off x="0" y="6446520"/>
+            <a:ext cx="12191695" cy="411480"/>
+          </a:xfrm>
+          <a:prstGeom prst="rect">
+            <a:avLst/>
+          </a:prstGeom>
+          <a:solidFill>
+            <a:srgbClr val="1F77C2"/>
+          </a:solidFill>
+          <a:ln>
+            <a:noFill/>
+          </a:ln>
+          <a:effectLst/>
+        </p:spPr>
+        <p:style>
+          <a:lnRef idx="1">
+            <a:schemeClr val="accent1"/>
+          </a:lnRef>
+          <a:fillRef idx="3">
+            <a:schemeClr val="accent1"/>
+          </a:fillRef>
+          <a:effectRef idx="2">
+            <a:schemeClr val="accent1"/>
+          </a:effectRef>
+          <a:fontRef idx="minor">
+            <a:schemeClr val="lt1"/>
+          </a:fontRef>
+        </p:style>
+        <p:txBody>
+          <a:bodyPr rtlCol="0" anchor="ctr"/>
+          <a:lstStyle/>
+          <a:p>
+            <a:pPr algn="ctr"/>
+          </a:p>
+        </p:txBody>
+      </p:sp>
+      <p:sp>
+        <p:nvSpPr>
+          <p:cNvPr id="4" name="TextBox 3"/>
+          <p:cNvSpPr txBox="1"/>
+          <p:nvPr/>
+        </p:nvSpPr>
+        <p:spPr>
+          <a:xfrm>
+            <a:off x="11430000" y="6473952"/>
+            <a:ext cx="640080" cy="365760"/>
+          </a:xfrm>
+          <a:prstGeom prst="rect">
+            <a:avLst/>
+          </a:prstGeom>
+          <a:noFill/>
+        </p:spPr>
+        <p:txBody>
+          <a:bodyPr wrap="none">
+            <a:spAutoFit/>
+          </a:bodyPr>
+          <a:lstStyle/>
+          <a:p>
+            <a:pPr algn="r"/>
+            <a:r>
+              <a:rPr sz="1200" b="1">
+                <a:solidFill>
+                  <a:srgbClr val="FFFFFF"/>
+                </a:solidFill>
+              </a:rPr>
+              <a:t>10</a:t>
+            </a:r>
+          </a:p>
+        </p:txBody>
+      </p:sp>
     </p:spTree>
   </p:cSld>
   <p:clrMapOvr>
@@ -3704,7 +3904,51 @@
       </p:sp>
       <p:sp>
         <p:nvSpPr>
-          <p:cNvPr id="3" name="TextBox 2"/>
+          <p:cNvPr id="3" name="Rectangle 2"/>
+          <p:cNvSpPr/>
+          <p:nvPr/>
+        </p:nvSpPr>
+        <p:spPr>
+          <a:xfrm>
+            <a:off x="4937760" y="841248"/>
+            <a:ext cx="2286000" cy="41148"/>
+          </a:xfrm>
+          <a:prstGeom prst="rect">
+            <a:avLst/>
+          </a:prstGeom>
+          <a:solidFill>
+            <a:srgbClr val="1F77C2"/>
+          </a:solidFill>
+          <a:ln>
+            <a:noFill/>
+          </a:ln>
+          <a:effectLst/>
+        </p:spPr>
+        <p:style>
+          <a:lnRef idx="1">
+            <a:schemeClr val="accent1"/>
+          </a:lnRef>
+          <a:fillRef idx="3">
+            <a:schemeClr val="accent1"/>
+          </a:fillRef>
+          <a:effectRef idx="2">
+            <a:schemeClr val="accent1"/>
+          </a:effectRef>
+          <a:fontRef idx="minor">
+            <a:schemeClr val="lt1"/>
+          </a:fontRef>
+        </p:style>
+        <p:txBody>
+          <a:bodyPr rtlCol="0" anchor="ctr"/>
+          <a:lstStyle/>
+          <a:p>
+            <a:pPr algn="ctr"/>
+          </a:p>
+        </p:txBody>
+      </p:sp>
+      <p:sp>
+        <p:nvSpPr>
+          <p:cNvPr id="4" name="TextBox 3"/>
           <p:cNvSpPr txBox="1"/>
           <p:nvPr/>
         </p:nvSpPr>
@@ -3825,6 +4069,84 @@
                 </a:solidFill>
               </a:rPr>
               <a:t>separately and carefully, who is actually PRESENT.</a:t>
+            </a:r>
+          </a:p>
+        </p:txBody>
+      </p:sp>
+      <p:sp>
+        <p:nvSpPr>
+          <p:cNvPr id="5" name="Rectangle 4"/>
+          <p:cNvSpPr/>
+          <p:nvPr/>
+        </p:nvSpPr>
+        <p:spPr>
+          <a:xfrm>
+            <a:off x="0" y="6446520"/>
+            <a:ext cx="12191695" cy="411480"/>
+          </a:xfrm>
+          <a:prstGeom prst="rect">
+            <a:avLst/>
+          </a:prstGeom>
+          <a:solidFill>
+            <a:srgbClr val="1F77C2"/>
+          </a:solidFill>
+          <a:ln>
+            <a:noFill/>
+          </a:ln>
+          <a:effectLst/>
+        </p:spPr>
+        <p:style>
+          <a:lnRef idx="1">
+            <a:schemeClr val="accent1"/>
+          </a:lnRef>
+          <a:fillRef idx="3">
+            <a:schemeClr val="accent1"/>
+          </a:fillRef>
+          <a:effectRef idx="2">
+            <a:schemeClr val="accent1"/>
+          </a:effectRef>
+          <a:fontRef idx="minor">
+            <a:schemeClr val="lt1"/>
+          </a:fontRef>
+        </p:style>
+        <p:txBody>
+          <a:bodyPr rtlCol="0" anchor="ctr"/>
+          <a:lstStyle/>
+          <a:p>
+            <a:pPr algn="ctr"/>
+          </a:p>
+        </p:txBody>
+      </p:sp>
+      <p:sp>
+        <p:nvSpPr>
+          <p:cNvPr id="6" name="TextBox 5"/>
+          <p:cNvSpPr txBox="1"/>
+          <p:nvPr/>
+        </p:nvSpPr>
+        <p:spPr>
+          <a:xfrm>
+            <a:off x="11430000" y="6473952"/>
+            <a:ext cx="640080" cy="365760"/>
+          </a:xfrm>
+          <a:prstGeom prst="rect">
+            <a:avLst/>
+          </a:prstGeom>
+          <a:noFill/>
+        </p:spPr>
+        <p:txBody>
+          <a:bodyPr wrap="none">
+            <a:spAutoFit/>
+          </a:bodyPr>
+          <a:lstStyle/>
+          <a:p>
+            <a:pPr algn="r"/>
+            <a:r>
+              <a:rPr sz="1200" b="1">
+                <a:solidFill>
+                  <a:srgbClr val="FFFFFF"/>
+                </a:solidFill>
+              </a:rPr>
+              <a:t>1</a:t>
             </a:r>
           </a:p>
         </p:txBody>
@@ -3883,7 +4205,51 @@
       </p:sp>
       <p:sp>
         <p:nvSpPr>
-          <p:cNvPr id="3" name="TextBox 2"/>
+          <p:cNvPr id="3" name="Rectangle 2"/>
+          <p:cNvSpPr/>
+          <p:nvPr/>
+        </p:nvSpPr>
+        <p:spPr>
+          <a:xfrm>
+            <a:off x="4937760" y="841248"/>
+            <a:ext cx="2286000" cy="41148"/>
+          </a:xfrm>
+          <a:prstGeom prst="rect">
+            <a:avLst/>
+          </a:prstGeom>
+          <a:solidFill>
+            <a:srgbClr val="1F77C2"/>
+          </a:solidFill>
+          <a:ln>
+            <a:noFill/>
+          </a:ln>
+          <a:effectLst/>
+        </p:spPr>
+        <p:style>
+          <a:lnRef idx="1">
+            <a:schemeClr val="accent1"/>
+          </a:lnRef>
+          <a:fillRef idx="3">
+            <a:schemeClr val="accent1"/>
+          </a:fillRef>
+          <a:effectRef idx="2">
+            <a:schemeClr val="accent1"/>
+          </a:effectRef>
+          <a:fontRef idx="minor">
+            <a:schemeClr val="lt1"/>
+          </a:fontRef>
+        </p:style>
+        <p:txBody>
+          <a:bodyPr rtlCol="0" anchor="ctr"/>
+          <a:lstStyle/>
+          <a:p>
+            <a:pPr algn="ctr"/>
+          </a:p>
+        </p:txBody>
+      </p:sp>
+      <p:sp>
+        <p:nvSpPr>
+          <p:cNvPr id="4" name="TextBox 3"/>
           <p:cNvSpPr txBox="1"/>
           <p:nvPr/>
         </p:nvSpPr>
@@ -4078,6 +4444,84 @@
                 </a:solidFill>
               </a:rPr>
               <a:t>One laptop, one webcam, no GPU, no cloud, no student data leaving campus.</a:t>
+            </a:r>
+          </a:p>
+        </p:txBody>
+      </p:sp>
+      <p:sp>
+        <p:nvSpPr>
+          <p:cNvPr id="5" name="Rectangle 4"/>
+          <p:cNvSpPr/>
+          <p:nvPr/>
+        </p:nvSpPr>
+        <p:spPr>
+          <a:xfrm>
+            <a:off x="0" y="6446520"/>
+            <a:ext cx="12191695" cy="411480"/>
+          </a:xfrm>
+          <a:prstGeom prst="rect">
+            <a:avLst/>
+          </a:prstGeom>
+          <a:solidFill>
+            <a:srgbClr val="1F77C2"/>
+          </a:solidFill>
+          <a:ln>
+            <a:noFill/>
+          </a:ln>
+          <a:effectLst/>
+        </p:spPr>
+        <p:style>
+          <a:lnRef idx="1">
+            <a:schemeClr val="accent1"/>
+          </a:lnRef>
+          <a:fillRef idx="3">
+            <a:schemeClr val="accent1"/>
+          </a:fillRef>
+          <a:effectRef idx="2">
+            <a:schemeClr val="accent1"/>
+          </a:effectRef>
+          <a:fontRef idx="minor">
+            <a:schemeClr val="lt1"/>
+          </a:fontRef>
+        </p:style>
+        <p:txBody>
+          <a:bodyPr rtlCol="0" anchor="ctr"/>
+          <a:lstStyle/>
+          <a:p>
+            <a:pPr algn="ctr"/>
+          </a:p>
+        </p:txBody>
+      </p:sp>
+      <p:sp>
+        <p:nvSpPr>
+          <p:cNvPr id="6" name="TextBox 5"/>
+          <p:cNvSpPr txBox="1"/>
+          <p:nvPr/>
+        </p:nvSpPr>
+        <p:spPr>
+          <a:xfrm>
+            <a:off x="11430000" y="6473952"/>
+            <a:ext cx="640080" cy="365760"/>
+          </a:xfrm>
+          <a:prstGeom prst="rect">
+            <a:avLst/>
+          </a:prstGeom>
+          <a:noFill/>
+        </p:spPr>
+        <p:txBody>
+          <a:bodyPr wrap="none">
+            <a:spAutoFit/>
+          </a:bodyPr>
+          <a:lstStyle/>
+          <a:p>
+            <a:pPr algn="r"/>
+            <a:r>
+              <a:rPr sz="1200" b="1">
+                <a:solidFill>
+                  <a:srgbClr val="FFFFFF"/>
+                </a:solidFill>
+              </a:rPr>
+              <a:t>2</a:t>
             </a:r>
           </a:p>
         </p:txBody>
@@ -4136,7 +4580,51 @@
       </p:sp>
       <p:sp>
         <p:nvSpPr>
-          <p:cNvPr id="3" name="TextBox 2"/>
+          <p:cNvPr id="3" name="Rectangle 2"/>
+          <p:cNvSpPr/>
+          <p:nvPr/>
+        </p:nvSpPr>
+        <p:spPr>
+          <a:xfrm>
+            <a:off x="4937760" y="841248"/>
+            <a:ext cx="2286000" cy="41148"/>
+          </a:xfrm>
+          <a:prstGeom prst="rect">
+            <a:avLst/>
+          </a:prstGeom>
+          <a:solidFill>
+            <a:srgbClr val="1F77C2"/>
+          </a:solidFill>
+          <a:ln>
+            <a:noFill/>
+          </a:ln>
+          <a:effectLst/>
+        </p:spPr>
+        <p:style>
+          <a:lnRef idx="1">
+            <a:schemeClr val="accent1"/>
+          </a:lnRef>
+          <a:fillRef idx="3">
+            <a:schemeClr val="accent1"/>
+          </a:fillRef>
+          <a:effectRef idx="2">
+            <a:schemeClr val="accent1"/>
+          </a:effectRef>
+          <a:fontRef idx="minor">
+            <a:schemeClr val="lt1"/>
+          </a:fontRef>
+        </p:style>
+        <p:txBody>
+          <a:bodyPr rtlCol="0" anchor="ctr"/>
+          <a:lstStyle/>
+          <a:p>
+            <a:pPr algn="ctr"/>
+          </a:p>
+        </p:txBody>
+      </p:sp>
+      <p:sp>
+        <p:nvSpPr>
+          <p:cNvPr id="4" name="TextBox 3"/>
           <p:cNvSpPr txBox="1"/>
           <p:nvPr/>
         </p:nvSpPr>
@@ -4226,14 +4714,58 @@
       </p:sp>
       <p:sp>
         <p:nvSpPr>
-          <p:cNvPr id="4" name="TextBox 3"/>
+          <p:cNvPr id="5" name="Rounded Rectangle 4"/>
+          <p:cNvSpPr/>
+          <p:nvPr/>
+        </p:nvSpPr>
+        <p:spPr>
+          <a:xfrm>
+            <a:off x="640080" y="2697480"/>
+            <a:ext cx="10881360" cy="1600200"/>
+          </a:xfrm>
+          <a:prstGeom prst="roundRect">
+            <a:avLst/>
+          </a:prstGeom>
+          <a:solidFill>
+            <a:srgbClr val="FDECEA"/>
+          </a:solidFill>
+          <a:ln w="15875">
+            <a:solidFill>
+              <a:srgbClr val="C0392B"/>
+            </a:solidFill>
+          </a:ln>
+          <a:effectLst/>
+        </p:spPr>
+        <p:style>
+          <a:lnRef idx="1">
+            <a:schemeClr val="accent1"/>
+          </a:lnRef>
+          <a:fillRef idx="3">
+            <a:schemeClr val="accent1"/>
+          </a:fillRef>
+          <a:effectRef idx="2">
+            <a:schemeClr val="accent1"/>
+          </a:effectRef>
+          <a:fontRef idx="minor">
+            <a:schemeClr val="lt1"/>
+          </a:fontRef>
+        </p:style>
+        <p:txBody>
+          <a:bodyPr rtlCol="0" anchor="ctr"/>
+          <a:lstStyle/>
+          <a:p/>
+        </p:txBody>
+      </p:sp>
+      <p:sp>
+        <p:nvSpPr>
+          <p:cNvPr id="6" name="TextBox 5"/>
           <p:cNvSpPr txBox="1"/>
           <p:nvPr/>
         </p:nvSpPr>
         <p:spPr>
           <a:xfrm>
-            <a:off x="822960" y="2834640"/>
-            <a:ext cx="10607040" cy="1280160"/>
+            <a:off x="868680" y="2880360"/>
+            <a:ext cx="10424160" cy="1280160"/>
           </a:xfrm>
           <a:prstGeom prst="rect">
             <a:avLst/>
@@ -4252,7 +4784,7 @@
               </a:spcAft>
             </a:pPr>
             <a:r>
-              <a:rPr sz="1500" b="1">
+              <a:rPr sz="1450" b="1">
                 <a:solidFill>
                   <a:srgbClr val="C0392B"/>
                 </a:solidFill>
@@ -4267,7 +4799,7 @@
               </a:spcAft>
             </a:pPr>
             <a:r>
-              <a:rPr sz="1500" b="1">
+              <a:rPr sz="1450" b="1">
                 <a:solidFill>
                   <a:srgbClr val="C0392B"/>
                 </a:solidFill>
@@ -4282,7 +4814,7 @@
               </a:spcAft>
             </a:pPr>
             <a:r>
-              <a:rPr sz="1500" b="1">
+              <a:rPr sz="1450" b="1">
                 <a:solidFill>
                   <a:srgbClr val="C0392B"/>
                 </a:solidFill>
@@ -4297,7 +4829,7 @@
               </a:spcAft>
             </a:pPr>
             <a:r>
-              <a:rPr sz="1500" b="1">
+              <a:rPr sz="1450" b="1">
                 <a:solidFill>
                   <a:srgbClr val="C0392B"/>
                 </a:solidFill>
@@ -4309,14 +4841,58 @@
       </p:sp>
       <p:sp>
         <p:nvSpPr>
-          <p:cNvPr id="5" name="TextBox 4"/>
+          <p:cNvPr id="7" name="Rounded Rectangle 6"/>
+          <p:cNvSpPr/>
+          <p:nvPr/>
+        </p:nvSpPr>
+        <p:spPr>
+          <a:xfrm>
+            <a:off x="640080" y="4389120"/>
+            <a:ext cx="10881360" cy="1783080"/>
+          </a:xfrm>
+          <a:prstGeom prst="roundRect">
+            <a:avLst/>
+          </a:prstGeom>
+          <a:solidFill>
+            <a:srgbClr val="F4F6F9"/>
+          </a:solidFill>
+          <a:ln w="15875">
+            <a:solidFill>
+              <a:srgbClr val="1F3A6E"/>
+            </a:solidFill>
+          </a:ln>
+          <a:effectLst/>
+        </p:spPr>
+        <p:style>
+          <a:lnRef idx="1">
+            <a:schemeClr val="accent1"/>
+          </a:lnRef>
+          <a:fillRef idx="3">
+            <a:schemeClr val="accent1"/>
+          </a:fillRef>
+          <a:effectRef idx="2">
+            <a:schemeClr val="accent1"/>
+          </a:effectRef>
+          <a:fontRef idx="minor">
+            <a:schemeClr val="lt1"/>
+          </a:fontRef>
+        </p:style>
+        <p:txBody>
+          <a:bodyPr rtlCol="0" anchor="ctr"/>
+          <a:lstStyle/>
+          <a:p/>
+        </p:txBody>
+      </p:sp>
+      <p:sp>
+        <p:nvSpPr>
+          <p:cNvPr id="8" name="TextBox 7"/>
           <p:cNvSpPr txBox="1"/>
           <p:nvPr/>
         </p:nvSpPr>
         <p:spPr>
           <a:xfrm>
-            <a:off x="822960" y="4480560"/>
-            <a:ext cx="10607040" cy="1828800"/>
+            <a:off x="868680" y="4526280"/>
+            <a:ext cx="10424160" cy="1645920"/>
           </a:xfrm>
           <a:prstGeom prst="rect">
             <a:avLst/>
@@ -4335,7 +4911,7 @@
               </a:spcAft>
             </a:pPr>
             <a:r>
-              <a:rPr sz="1300" b="1">
+              <a:rPr sz="1250" b="1">
                 <a:solidFill>
                   <a:srgbClr val="1F3A6E"/>
                 </a:solidFill>
@@ -4350,7 +4926,7 @@
               </a:spcAft>
             </a:pPr>
             <a:r>
-              <a:rPr sz="1300" b="0">
+              <a:rPr sz="1250" b="0">
                 <a:solidFill>
                   <a:srgbClr val="1A1A1A"/>
                 </a:solidFill>
@@ -4365,7 +4941,7 @@
               </a:spcAft>
             </a:pPr>
             <a:r>
-              <a:rPr sz="1300" b="0">
+              <a:rPr sz="1250" b="0">
                 <a:solidFill>
                   <a:srgbClr val="1A1A1A"/>
                 </a:solidFill>
@@ -4380,7 +4956,7 @@
               </a:spcAft>
             </a:pPr>
             <a:r>
-              <a:rPr sz="1300" b="0">
+              <a:rPr sz="1250" b="0">
                 <a:solidFill>
                   <a:srgbClr val="1A1A1A"/>
                 </a:solidFill>
@@ -4395,12 +4971,90 @@
               </a:spcAft>
             </a:pPr>
             <a:r>
-              <a:rPr sz="1300" b="0">
+              <a:rPr sz="1250" b="0">
                 <a:solidFill>
                   <a:srgbClr val="1A1A1A"/>
                 </a:solidFill>
               </a:rPr>
               <a:t>•  One misread frame  →  wrong student marked present for the entire day</a:t>
+            </a:r>
+          </a:p>
+        </p:txBody>
+      </p:sp>
+      <p:sp>
+        <p:nvSpPr>
+          <p:cNvPr id="9" name="Rectangle 8"/>
+          <p:cNvSpPr/>
+          <p:nvPr/>
+        </p:nvSpPr>
+        <p:spPr>
+          <a:xfrm>
+            <a:off x="0" y="6446520"/>
+            <a:ext cx="12191695" cy="411480"/>
+          </a:xfrm>
+          <a:prstGeom prst="rect">
+            <a:avLst/>
+          </a:prstGeom>
+          <a:solidFill>
+            <a:srgbClr val="1F77C2"/>
+          </a:solidFill>
+          <a:ln>
+            <a:noFill/>
+          </a:ln>
+          <a:effectLst/>
+        </p:spPr>
+        <p:style>
+          <a:lnRef idx="1">
+            <a:schemeClr val="accent1"/>
+          </a:lnRef>
+          <a:fillRef idx="3">
+            <a:schemeClr val="accent1"/>
+          </a:fillRef>
+          <a:effectRef idx="2">
+            <a:schemeClr val="accent1"/>
+          </a:effectRef>
+          <a:fontRef idx="minor">
+            <a:schemeClr val="lt1"/>
+          </a:fontRef>
+        </p:style>
+        <p:txBody>
+          <a:bodyPr rtlCol="0" anchor="ctr"/>
+          <a:lstStyle/>
+          <a:p>
+            <a:pPr algn="ctr"/>
+          </a:p>
+        </p:txBody>
+      </p:sp>
+      <p:sp>
+        <p:nvSpPr>
+          <p:cNvPr id="10" name="TextBox 9"/>
+          <p:cNvSpPr txBox="1"/>
+          <p:nvPr/>
+        </p:nvSpPr>
+        <p:spPr>
+          <a:xfrm>
+            <a:off x="11430000" y="6473952"/>
+            <a:ext cx="640080" cy="365760"/>
+          </a:xfrm>
+          <a:prstGeom prst="rect">
+            <a:avLst/>
+          </a:prstGeom>
+          <a:noFill/>
+        </p:spPr>
+        <p:txBody>
+          <a:bodyPr wrap="none">
+            <a:spAutoFit/>
+          </a:bodyPr>
+          <a:lstStyle/>
+          <a:p>
+            <a:pPr algn="r"/>
+            <a:r>
+              <a:rPr sz="1200" b="1">
+                <a:solidFill>
+                  <a:srgbClr val="FFFFFF"/>
+                </a:solidFill>
+              </a:rPr>
+              <a:t>3</a:t>
             </a:r>
           </a:p>
         </p:txBody>
@@ -4459,7 +5113,51 @@
       </p:sp>
       <p:sp>
         <p:nvSpPr>
-          <p:cNvPr id="3" name="TextBox 2"/>
+          <p:cNvPr id="3" name="Rectangle 2"/>
+          <p:cNvSpPr/>
+          <p:nvPr/>
+        </p:nvSpPr>
+        <p:spPr>
+          <a:xfrm>
+            <a:off x="4937760" y="841248"/>
+            <a:ext cx="2286000" cy="41148"/>
+          </a:xfrm>
+          <a:prstGeom prst="rect">
+            <a:avLst/>
+          </a:prstGeom>
+          <a:solidFill>
+            <a:srgbClr val="1F77C2"/>
+          </a:solidFill>
+          <a:ln>
+            <a:noFill/>
+          </a:ln>
+          <a:effectLst/>
+        </p:spPr>
+        <p:style>
+          <a:lnRef idx="1">
+            <a:schemeClr val="accent1"/>
+          </a:lnRef>
+          <a:fillRef idx="3">
+            <a:schemeClr val="accent1"/>
+          </a:fillRef>
+          <a:effectRef idx="2">
+            <a:schemeClr val="accent1"/>
+          </a:effectRef>
+          <a:fontRef idx="minor">
+            <a:schemeClr val="lt1"/>
+          </a:fontRef>
+        </p:style>
+        <p:txBody>
+          <a:bodyPr rtlCol="0" anchor="ctr"/>
+          <a:lstStyle/>
+          <a:p>
+            <a:pPr algn="ctr"/>
+          </a:p>
+        </p:txBody>
+      </p:sp>
+      <p:sp>
+        <p:nvSpPr>
+          <p:cNvPr id="4" name="TextBox 3"/>
           <p:cNvSpPr txBox="1"/>
           <p:nvPr/>
         </p:nvSpPr>
@@ -4607,14 +5305,58 @@
       </p:sp>
       <p:sp>
         <p:nvSpPr>
-          <p:cNvPr id="4" name="TextBox 3"/>
+          <p:cNvPr id="5" name="Rounded Rectangle 4"/>
+          <p:cNvSpPr/>
+          <p:nvPr/>
+        </p:nvSpPr>
+        <p:spPr>
+          <a:xfrm>
+            <a:off x="548640" y="5257800"/>
+            <a:ext cx="11064240" cy="1097280"/>
+          </a:xfrm>
+          <a:prstGeom prst="roundRect">
+            <a:avLst/>
+          </a:prstGeom>
+          <a:solidFill>
+            <a:srgbClr val="FDECEA"/>
+          </a:solidFill>
+          <a:ln w="15875">
+            <a:solidFill>
+              <a:srgbClr val="C0392B"/>
+            </a:solidFill>
+          </a:ln>
+          <a:effectLst/>
+        </p:spPr>
+        <p:style>
+          <a:lnRef idx="1">
+            <a:schemeClr val="accent1"/>
+          </a:lnRef>
+          <a:fillRef idx="3">
+            <a:schemeClr val="accent1"/>
+          </a:fillRef>
+          <a:effectRef idx="2">
+            <a:schemeClr val="accent1"/>
+          </a:effectRef>
+          <a:fontRef idx="minor">
+            <a:schemeClr val="lt1"/>
+          </a:fontRef>
+        </p:style>
+        <p:txBody>
+          <a:bodyPr rtlCol="0" anchor="ctr"/>
+          <a:lstStyle/>
+          <a:p/>
+        </p:txBody>
+      </p:sp>
+      <p:sp>
+        <p:nvSpPr>
+          <p:cNvPr id="6" name="TextBox 5"/>
           <p:cNvSpPr txBox="1"/>
           <p:nvPr/>
         </p:nvSpPr>
         <p:spPr>
           <a:xfrm>
-            <a:off x="640080" y="5394960"/>
-            <a:ext cx="10972800" cy="1005840"/>
+            <a:off x="777240" y="5349240"/>
+            <a:ext cx="10698480" cy="960120"/>
           </a:xfrm>
           <a:prstGeom prst="rect">
             <a:avLst/>
@@ -4633,7 +5375,7 @@
               </a:spcAft>
             </a:pPr>
             <a:r>
-              <a:rPr sz="1250" b="1">
+              <a:rPr sz="1150" b="1">
                 <a:solidFill>
                   <a:srgbClr val="C0392B"/>
                 </a:solidFill>
@@ -4648,12 +5390,90 @@
               </a:spcAft>
             </a:pPr>
             <a:r>
-              <a:rPr sz="1250" b="1">
+              <a:rPr sz="1150" b="1">
                 <a:solidFill>
                   <a:srgbClr val="C0392B"/>
                 </a:solidFill>
               </a:rPr>
               <a:t>Every attendance paper above reports one accuracy number on clean data. None of them test a presentation attack, none report a stranger-rejection rate, and none treat 'recognised' and 'marked present' as different decisions. That gap is our project.</a:t>
+            </a:r>
+          </a:p>
+        </p:txBody>
+      </p:sp>
+      <p:sp>
+        <p:nvSpPr>
+          <p:cNvPr id="7" name="Rectangle 6"/>
+          <p:cNvSpPr/>
+          <p:nvPr/>
+        </p:nvSpPr>
+        <p:spPr>
+          <a:xfrm>
+            <a:off x="0" y="6446520"/>
+            <a:ext cx="12191695" cy="411480"/>
+          </a:xfrm>
+          <a:prstGeom prst="rect">
+            <a:avLst/>
+          </a:prstGeom>
+          <a:solidFill>
+            <a:srgbClr val="1F77C2"/>
+          </a:solidFill>
+          <a:ln>
+            <a:noFill/>
+          </a:ln>
+          <a:effectLst/>
+        </p:spPr>
+        <p:style>
+          <a:lnRef idx="1">
+            <a:schemeClr val="accent1"/>
+          </a:lnRef>
+          <a:fillRef idx="3">
+            <a:schemeClr val="accent1"/>
+          </a:fillRef>
+          <a:effectRef idx="2">
+            <a:schemeClr val="accent1"/>
+          </a:effectRef>
+          <a:fontRef idx="minor">
+            <a:schemeClr val="lt1"/>
+          </a:fontRef>
+        </p:style>
+        <p:txBody>
+          <a:bodyPr rtlCol="0" anchor="ctr"/>
+          <a:lstStyle/>
+          <a:p>
+            <a:pPr algn="ctr"/>
+          </a:p>
+        </p:txBody>
+      </p:sp>
+      <p:sp>
+        <p:nvSpPr>
+          <p:cNvPr id="8" name="TextBox 7"/>
+          <p:cNvSpPr txBox="1"/>
+          <p:nvPr/>
+        </p:nvSpPr>
+        <p:spPr>
+          <a:xfrm>
+            <a:off x="11430000" y="6473952"/>
+            <a:ext cx="640080" cy="365760"/>
+          </a:xfrm>
+          <a:prstGeom prst="rect">
+            <a:avLst/>
+          </a:prstGeom>
+          <a:noFill/>
+        </p:spPr>
+        <p:txBody>
+          <a:bodyPr wrap="none">
+            <a:spAutoFit/>
+          </a:bodyPr>
+          <a:lstStyle/>
+          <a:p>
+            <a:pPr algn="r"/>
+            <a:r>
+              <a:rPr sz="1200" b="1">
+                <a:solidFill>
+                  <a:srgbClr val="FFFFFF"/>
+                </a:solidFill>
+              </a:rPr>
+              <a:t>4</a:t>
             </a:r>
           </a:p>
         </p:txBody>
@@ -4712,7 +5532,95 @@
       </p:sp>
       <p:sp>
         <p:nvSpPr>
-          <p:cNvPr id="3" name="TextBox 2"/>
+          <p:cNvPr id="3" name="Rectangle 2"/>
+          <p:cNvSpPr/>
+          <p:nvPr/>
+        </p:nvSpPr>
+        <p:spPr>
+          <a:xfrm>
+            <a:off x="4937760" y="841248"/>
+            <a:ext cx="2286000" cy="41148"/>
+          </a:xfrm>
+          <a:prstGeom prst="rect">
+            <a:avLst/>
+          </a:prstGeom>
+          <a:solidFill>
+            <a:srgbClr val="1F77C2"/>
+          </a:solidFill>
+          <a:ln>
+            <a:noFill/>
+          </a:ln>
+          <a:effectLst/>
+        </p:spPr>
+        <p:style>
+          <a:lnRef idx="1">
+            <a:schemeClr val="accent1"/>
+          </a:lnRef>
+          <a:fillRef idx="3">
+            <a:schemeClr val="accent1"/>
+          </a:fillRef>
+          <a:effectRef idx="2">
+            <a:schemeClr val="accent1"/>
+          </a:effectRef>
+          <a:fontRef idx="minor">
+            <a:schemeClr val="lt1"/>
+          </a:fontRef>
+        </p:style>
+        <p:txBody>
+          <a:bodyPr rtlCol="0" anchor="ctr"/>
+          <a:lstStyle/>
+          <a:p>
+            <a:pPr algn="ctr"/>
+          </a:p>
+        </p:txBody>
+      </p:sp>
+      <p:sp>
+        <p:nvSpPr>
+          <p:cNvPr id="4" name="Rounded Rectangle 3"/>
+          <p:cNvSpPr/>
+          <p:nvPr/>
+        </p:nvSpPr>
+        <p:spPr>
+          <a:xfrm>
+            <a:off x="548640" y="1005840"/>
+            <a:ext cx="5669280" cy="2926080"/>
+          </a:xfrm>
+          <a:prstGeom prst="roundRect">
+            <a:avLst/>
+          </a:prstGeom>
+          <a:solidFill>
+            <a:srgbClr val="E8F1FB"/>
+          </a:solidFill>
+          <a:ln w="15875">
+            <a:solidFill>
+              <a:srgbClr val="1F3A6E"/>
+            </a:solidFill>
+          </a:ln>
+          <a:effectLst/>
+        </p:spPr>
+        <p:style>
+          <a:lnRef idx="1">
+            <a:schemeClr val="accent1"/>
+          </a:lnRef>
+          <a:fillRef idx="3">
+            <a:schemeClr val="accent1"/>
+          </a:fillRef>
+          <a:effectRef idx="2">
+            <a:schemeClr val="accent1"/>
+          </a:effectRef>
+          <a:fontRef idx="minor">
+            <a:schemeClr val="lt1"/>
+          </a:fontRef>
+        </p:style>
+        <p:txBody>
+          <a:bodyPr rtlCol="0" anchor="ctr"/>
+          <a:lstStyle/>
+          <a:p/>
+        </p:txBody>
+      </p:sp>
+      <p:sp>
+        <p:nvSpPr>
+          <p:cNvPr id="5" name="TextBox 4"/>
           <p:cNvSpPr txBox="1"/>
           <p:nvPr/>
         </p:nvSpPr>
@@ -4862,7 +5770,51 @@
       </p:sp>
       <p:sp>
         <p:nvSpPr>
-          <p:cNvPr id="4" name="TextBox 3"/>
+          <p:cNvPr id="6" name="Rounded Rectangle 5"/>
+          <p:cNvSpPr/>
+          <p:nvPr/>
+        </p:nvSpPr>
+        <p:spPr>
+          <a:xfrm>
+            <a:off x="6446520" y="1005840"/>
+            <a:ext cx="5257800" cy="5303520"/>
+          </a:xfrm>
+          <a:prstGeom prst="roundRect">
+            <a:avLst/>
+          </a:prstGeom>
+          <a:solidFill>
+            <a:srgbClr val="E7F6EE"/>
+          </a:solidFill>
+          <a:ln w="15875">
+            <a:solidFill>
+              <a:srgbClr val="1E8E5A"/>
+            </a:solidFill>
+          </a:ln>
+          <a:effectLst/>
+        </p:spPr>
+        <p:style>
+          <a:lnRef idx="1">
+            <a:schemeClr val="accent1"/>
+          </a:lnRef>
+          <a:fillRef idx="3">
+            <a:schemeClr val="accent1"/>
+          </a:fillRef>
+          <a:effectRef idx="2">
+            <a:schemeClr val="accent1"/>
+          </a:effectRef>
+          <a:fontRef idx="minor">
+            <a:schemeClr val="lt1"/>
+          </a:fontRef>
+        </p:style>
+        <p:txBody>
+          <a:bodyPr rtlCol="0" anchor="ctr"/>
+          <a:lstStyle/>
+          <a:p/>
+        </p:txBody>
+      </p:sp>
+      <p:sp>
+        <p:nvSpPr>
+          <p:cNvPr id="7" name="TextBox 6"/>
           <p:cNvSpPr txBox="1"/>
           <p:nvPr/>
         </p:nvSpPr>
@@ -5043,6 +5995,84 @@
                 </a:solidFill>
               </a:rPr>
               <a:t>•  A guard that did NOT work (top-2 margin) — reported, not hidden.</a:t>
+            </a:r>
+          </a:p>
+        </p:txBody>
+      </p:sp>
+      <p:sp>
+        <p:nvSpPr>
+          <p:cNvPr id="8" name="Rectangle 7"/>
+          <p:cNvSpPr/>
+          <p:nvPr/>
+        </p:nvSpPr>
+        <p:spPr>
+          <a:xfrm>
+            <a:off x="0" y="6446520"/>
+            <a:ext cx="12191695" cy="411480"/>
+          </a:xfrm>
+          <a:prstGeom prst="rect">
+            <a:avLst/>
+          </a:prstGeom>
+          <a:solidFill>
+            <a:srgbClr val="1F77C2"/>
+          </a:solidFill>
+          <a:ln>
+            <a:noFill/>
+          </a:ln>
+          <a:effectLst/>
+        </p:spPr>
+        <p:style>
+          <a:lnRef idx="1">
+            <a:schemeClr val="accent1"/>
+          </a:lnRef>
+          <a:fillRef idx="3">
+            <a:schemeClr val="accent1"/>
+          </a:fillRef>
+          <a:effectRef idx="2">
+            <a:schemeClr val="accent1"/>
+          </a:effectRef>
+          <a:fontRef idx="minor">
+            <a:schemeClr val="lt1"/>
+          </a:fontRef>
+        </p:style>
+        <p:txBody>
+          <a:bodyPr rtlCol="0" anchor="ctr"/>
+          <a:lstStyle/>
+          <a:p>
+            <a:pPr algn="ctr"/>
+          </a:p>
+        </p:txBody>
+      </p:sp>
+      <p:sp>
+        <p:nvSpPr>
+          <p:cNvPr id="9" name="TextBox 8"/>
+          <p:cNvSpPr txBox="1"/>
+          <p:nvPr/>
+        </p:nvSpPr>
+        <p:spPr>
+          <a:xfrm>
+            <a:off x="11430000" y="6473952"/>
+            <a:ext cx="640080" cy="365760"/>
+          </a:xfrm>
+          <a:prstGeom prst="rect">
+            <a:avLst/>
+          </a:prstGeom>
+          <a:noFill/>
+        </p:spPr>
+        <p:txBody>
+          <a:bodyPr wrap="none">
+            <a:spAutoFit/>
+          </a:bodyPr>
+          <a:lstStyle/>
+          <a:p>
+            <a:pPr algn="r"/>
+            <a:r>
+              <a:rPr sz="1200" b="1">
+                <a:solidFill>
+                  <a:srgbClr val="FFFFFF"/>
+                </a:solidFill>
+              </a:rPr>
+              <a:t>5</a:t>
             </a:r>
           </a:p>
         </p:txBody>
@@ -5099,9 +6129,53 @@
           </a:p>
         </p:txBody>
       </p:sp>
+      <p:sp>
+        <p:nvSpPr>
+          <p:cNvPr id="3" name="Rectangle 2"/>
+          <p:cNvSpPr/>
+          <p:nvPr/>
+        </p:nvSpPr>
+        <p:spPr>
+          <a:xfrm>
+            <a:off x="4937760" y="841248"/>
+            <a:ext cx="2286000" cy="41148"/>
+          </a:xfrm>
+          <a:prstGeom prst="rect">
+            <a:avLst/>
+          </a:prstGeom>
+          <a:solidFill>
+            <a:srgbClr val="1F77C2"/>
+          </a:solidFill>
+          <a:ln>
+            <a:noFill/>
+          </a:ln>
+          <a:effectLst/>
+        </p:spPr>
+        <p:style>
+          <a:lnRef idx="1">
+            <a:schemeClr val="accent1"/>
+          </a:lnRef>
+          <a:fillRef idx="3">
+            <a:schemeClr val="accent1"/>
+          </a:fillRef>
+          <a:effectRef idx="2">
+            <a:schemeClr val="accent1"/>
+          </a:effectRef>
+          <a:fontRef idx="minor">
+            <a:schemeClr val="lt1"/>
+          </a:fontRef>
+        </p:style>
+        <p:txBody>
+          <a:bodyPr rtlCol="0" anchor="ctr"/>
+          <a:lstStyle/>
+          <a:p>
+            <a:pPr algn="ctr"/>
+          </a:p>
+        </p:txBody>
+      </p:sp>
       <p:pic>
         <p:nvPicPr>
-          <p:cNvPr id="3" name="Picture 2" descr="workflow.png"/>
+          <p:cNvPr id="4" name="Picture 3" descr="workflow.png"/>
           <p:cNvPicPr>
             <a:picLocks noChangeAspect="1"/>
           </p:cNvPicPr>
@@ -5125,7 +6199,7 @@
       </p:pic>
       <p:sp>
         <p:nvSpPr>
-          <p:cNvPr id="4" name="TextBox 3"/>
+          <p:cNvPr id="5" name="TextBox 4"/>
           <p:cNvSpPr txBox="1"/>
           <p:nvPr/>
         </p:nvSpPr>
@@ -5283,7 +6357,7 @@
       </p:sp>
       <p:sp>
         <p:nvSpPr>
-          <p:cNvPr id="5" name="TextBox 4"/>
+          <p:cNvPr id="6" name="TextBox 5"/>
           <p:cNvSpPr txBox="1"/>
           <p:nvPr/>
         </p:nvSpPr>
@@ -5479,6 +6553,84 @@
                 </a:solidFill>
               </a:rPr>
               <a:t>live deployment demo.</a:t>
+            </a:r>
+          </a:p>
+        </p:txBody>
+      </p:sp>
+      <p:sp>
+        <p:nvSpPr>
+          <p:cNvPr id="7" name="Rectangle 6"/>
+          <p:cNvSpPr/>
+          <p:nvPr/>
+        </p:nvSpPr>
+        <p:spPr>
+          <a:xfrm>
+            <a:off x="0" y="6446520"/>
+            <a:ext cx="12191695" cy="411480"/>
+          </a:xfrm>
+          <a:prstGeom prst="rect">
+            <a:avLst/>
+          </a:prstGeom>
+          <a:solidFill>
+            <a:srgbClr val="1F77C2"/>
+          </a:solidFill>
+          <a:ln>
+            <a:noFill/>
+          </a:ln>
+          <a:effectLst/>
+        </p:spPr>
+        <p:style>
+          <a:lnRef idx="1">
+            <a:schemeClr val="accent1"/>
+          </a:lnRef>
+          <a:fillRef idx="3">
+            <a:schemeClr val="accent1"/>
+          </a:fillRef>
+          <a:effectRef idx="2">
+            <a:schemeClr val="accent1"/>
+          </a:effectRef>
+          <a:fontRef idx="minor">
+            <a:schemeClr val="lt1"/>
+          </a:fontRef>
+        </p:style>
+        <p:txBody>
+          <a:bodyPr rtlCol="0" anchor="ctr"/>
+          <a:lstStyle/>
+          <a:p>
+            <a:pPr algn="ctr"/>
+          </a:p>
+        </p:txBody>
+      </p:sp>
+      <p:sp>
+        <p:nvSpPr>
+          <p:cNvPr id="8" name="TextBox 7"/>
+          <p:cNvSpPr txBox="1"/>
+          <p:nvPr/>
+        </p:nvSpPr>
+        <p:spPr>
+          <a:xfrm>
+            <a:off x="11430000" y="6473952"/>
+            <a:ext cx="640080" cy="365760"/>
+          </a:xfrm>
+          <a:prstGeom prst="rect">
+            <a:avLst/>
+          </a:prstGeom>
+          <a:noFill/>
+        </p:spPr>
+        <p:txBody>
+          <a:bodyPr wrap="none">
+            <a:spAutoFit/>
+          </a:bodyPr>
+          <a:lstStyle/>
+          <a:p>
+            <a:pPr algn="r"/>
+            <a:r>
+              <a:rPr sz="1200" b="1">
+                <a:solidFill>
+                  <a:srgbClr val="FFFFFF"/>
+                </a:solidFill>
+              </a:rPr>
+              <a:t>6</a:t>
             </a:r>
           </a:p>
         </p:txBody>
@@ -5535,9 +6687,53 @@
           </a:p>
         </p:txBody>
       </p:sp>
+      <p:sp>
+        <p:nvSpPr>
+          <p:cNvPr id="3" name="Rectangle 2"/>
+          <p:cNvSpPr/>
+          <p:nvPr/>
+        </p:nvSpPr>
+        <p:spPr>
+          <a:xfrm>
+            <a:off x="4937760" y="841248"/>
+            <a:ext cx="2286000" cy="41148"/>
+          </a:xfrm>
+          <a:prstGeom prst="rect">
+            <a:avLst/>
+          </a:prstGeom>
+          <a:solidFill>
+            <a:srgbClr val="1F77C2"/>
+          </a:solidFill>
+          <a:ln>
+            <a:noFill/>
+          </a:ln>
+          <a:effectLst/>
+        </p:spPr>
+        <p:style>
+          <a:lnRef idx="1">
+            <a:schemeClr val="accent1"/>
+          </a:lnRef>
+          <a:fillRef idx="3">
+            <a:schemeClr val="accent1"/>
+          </a:fillRef>
+          <a:effectRef idx="2">
+            <a:schemeClr val="accent1"/>
+          </a:effectRef>
+          <a:fontRef idx="minor">
+            <a:schemeClr val="lt1"/>
+          </a:fontRef>
+        </p:style>
+        <p:txBody>
+          <a:bodyPr rtlCol="0" anchor="ctr"/>
+          <a:lstStyle/>
+          <a:p>
+            <a:pPr algn="ctr"/>
+          </a:p>
+        </p:txBody>
+      </p:sp>
       <p:pic>
         <p:nvPicPr>
-          <p:cNvPr id="3" name="Picture 2" descr="spoof.png"/>
+          <p:cNvPr id="4" name="Picture 3" descr="spoof.png"/>
           <p:cNvPicPr>
             <a:picLocks noChangeAspect="1"/>
           </p:cNvPicPr>
@@ -5561,7 +6757,7 @@
       </p:pic>
       <p:pic>
         <p:nvPicPr>
-          <p:cNvPr id="4" name="Picture 3" descr="ablation.png"/>
+          <p:cNvPr id="5" name="Picture 4" descr="ablation.png"/>
           <p:cNvPicPr>
             <a:picLocks noChangeAspect="1"/>
           </p:cNvPicPr>
@@ -5585,7 +6781,7 @@
       </p:pic>
       <p:pic>
         <p:nvPicPr>
-          <p:cNvPr id="5" name="Picture 4" descr="degradation.png"/>
+          <p:cNvPr id="6" name="Picture 5" descr="degradation.png"/>
           <p:cNvPicPr>
             <a:picLocks noChangeAspect="1"/>
           </p:cNvPicPr>
@@ -5609,7 +6805,7 @@
       </p:pic>
       <p:graphicFrame>
         <p:nvGraphicFramePr>
-          <p:cNvPr id="6" name="Table 5"/>
+          <p:cNvPr id="7" name="Table 6"/>
           <p:cNvGraphicFramePr>
             <a:graphicFrameLocks noGrp="1"/>
           </p:cNvGraphicFramePr>
@@ -5902,7 +7098,7 @@
       </p:graphicFrame>
       <p:sp>
         <p:nvSpPr>
-          <p:cNvPr id="7" name="TextBox 6"/>
+          <p:cNvPr id="8" name="TextBox 7"/>
           <p:cNvSpPr txBox="1"/>
           <p:nvPr/>
         </p:nvSpPr>
@@ -6061,6 +7257,84 @@
                 </a:solidFill>
               </a:rPr>
               <a:t>The top-2 margin guard did NOT help — we report it.</a:t>
+            </a:r>
+          </a:p>
+        </p:txBody>
+      </p:sp>
+      <p:sp>
+        <p:nvSpPr>
+          <p:cNvPr id="9" name="Rectangle 8"/>
+          <p:cNvSpPr/>
+          <p:nvPr/>
+        </p:nvSpPr>
+        <p:spPr>
+          <a:xfrm>
+            <a:off x="0" y="6446520"/>
+            <a:ext cx="12191695" cy="411480"/>
+          </a:xfrm>
+          <a:prstGeom prst="rect">
+            <a:avLst/>
+          </a:prstGeom>
+          <a:solidFill>
+            <a:srgbClr val="1F77C2"/>
+          </a:solidFill>
+          <a:ln>
+            <a:noFill/>
+          </a:ln>
+          <a:effectLst/>
+        </p:spPr>
+        <p:style>
+          <a:lnRef idx="1">
+            <a:schemeClr val="accent1"/>
+          </a:lnRef>
+          <a:fillRef idx="3">
+            <a:schemeClr val="accent1"/>
+          </a:fillRef>
+          <a:effectRef idx="2">
+            <a:schemeClr val="accent1"/>
+          </a:effectRef>
+          <a:fontRef idx="minor">
+            <a:schemeClr val="lt1"/>
+          </a:fontRef>
+        </p:style>
+        <p:txBody>
+          <a:bodyPr rtlCol="0" anchor="ctr"/>
+          <a:lstStyle/>
+          <a:p>
+            <a:pPr algn="ctr"/>
+          </a:p>
+        </p:txBody>
+      </p:sp>
+      <p:sp>
+        <p:nvSpPr>
+          <p:cNvPr id="10" name="TextBox 9"/>
+          <p:cNvSpPr txBox="1"/>
+          <p:nvPr/>
+        </p:nvSpPr>
+        <p:spPr>
+          <a:xfrm>
+            <a:off x="11430000" y="6473952"/>
+            <a:ext cx="640080" cy="365760"/>
+          </a:xfrm>
+          <a:prstGeom prst="rect">
+            <a:avLst/>
+          </a:prstGeom>
+          <a:noFill/>
+        </p:spPr>
+        <p:txBody>
+          <a:bodyPr wrap="none">
+            <a:spAutoFit/>
+          </a:bodyPr>
+          <a:lstStyle/>
+          <a:p>
+            <a:pPr algn="r"/>
+            <a:r>
+              <a:rPr sz="1200" b="1">
+                <a:solidFill>
+                  <a:srgbClr val="FFFFFF"/>
+                </a:solidFill>
+              </a:rPr>
+              <a:t>7</a:t>
             </a:r>
           </a:p>
         </p:txBody>
@@ -6119,7 +7393,51 @@
       </p:sp>
       <p:sp>
         <p:nvSpPr>
-          <p:cNvPr id="3" name="TextBox 2"/>
+          <p:cNvPr id="3" name="Rectangle 2"/>
+          <p:cNvSpPr/>
+          <p:nvPr/>
+        </p:nvSpPr>
+        <p:spPr>
+          <a:xfrm>
+            <a:off x="4937760" y="841248"/>
+            <a:ext cx="2286000" cy="41148"/>
+          </a:xfrm>
+          <a:prstGeom prst="rect">
+            <a:avLst/>
+          </a:prstGeom>
+          <a:solidFill>
+            <a:srgbClr val="1F77C2"/>
+          </a:solidFill>
+          <a:ln>
+            <a:noFill/>
+          </a:ln>
+          <a:effectLst/>
+        </p:spPr>
+        <p:style>
+          <a:lnRef idx="1">
+            <a:schemeClr val="accent1"/>
+          </a:lnRef>
+          <a:fillRef idx="3">
+            <a:schemeClr val="accent1"/>
+          </a:fillRef>
+          <a:effectRef idx="2">
+            <a:schemeClr val="accent1"/>
+          </a:effectRef>
+          <a:fontRef idx="minor">
+            <a:schemeClr val="lt1"/>
+          </a:fontRef>
+        </p:style>
+        <p:txBody>
+          <a:bodyPr rtlCol="0" anchor="ctr"/>
+          <a:lstStyle/>
+          <a:p>
+            <a:pPr algn="ctr"/>
+          </a:p>
+        </p:txBody>
+      </p:sp>
+      <p:sp>
+        <p:nvSpPr>
+          <p:cNvPr id="4" name="TextBox 3"/>
           <p:cNvSpPr txBox="1"/>
           <p:nvPr/>
         </p:nvSpPr>
@@ -6350,7 +7668,51 @@
       </p:sp>
       <p:sp>
         <p:nvSpPr>
-          <p:cNvPr id="4" name="TextBox 3"/>
+          <p:cNvPr id="5" name="Rounded Rectangle 4"/>
+          <p:cNvSpPr/>
+          <p:nvPr/>
+        </p:nvSpPr>
+        <p:spPr>
+          <a:xfrm>
+            <a:off x="7269480" y="1005840"/>
+            <a:ext cx="4572000" cy="5303520"/>
+          </a:xfrm>
+          <a:prstGeom prst="roundRect">
+            <a:avLst/>
+          </a:prstGeom>
+          <a:solidFill>
+            <a:srgbClr val="FDECEA"/>
+          </a:solidFill>
+          <a:ln w="15875">
+            <a:solidFill>
+              <a:srgbClr val="C0392B"/>
+            </a:solidFill>
+          </a:ln>
+          <a:effectLst/>
+        </p:spPr>
+        <p:style>
+          <a:lnRef idx="1">
+            <a:schemeClr val="accent1"/>
+          </a:lnRef>
+          <a:fillRef idx="3">
+            <a:schemeClr val="accent1"/>
+          </a:fillRef>
+          <a:effectRef idx="2">
+            <a:schemeClr val="accent1"/>
+          </a:effectRef>
+          <a:fontRef idx="minor">
+            <a:schemeClr val="lt1"/>
+          </a:fontRef>
+        </p:style>
+        <p:txBody>
+          <a:bodyPr rtlCol="0" anchor="ctr"/>
+          <a:lstStyle/>
+          <a:p/>
+        </p:txBody>
+      </p:sp>
+      <p:sp>
+        <p:nvSpPr>
+          <p:cNvPr id="6" name="TextBox 5"/>
           <p:cNvSpPr txBox="1"/>
           <p:nvPr/>
         </p:nvSpPr>
@@ -6605,6 +7967,84 @@
                 </a:solidFill>
               </a:rPr>
               <a:t>be worse than these.</a:t>
+            </a:r>
+          </a:p>
+        </p:txBody>
+      </p:sp>
+      <p:sp>
+        <p:nvSpPr>
+          <p:cNvPr id="7" name="Rectangle 6"/>
+          <p:cNvSpPr/>
+          <p:nvPr/>
+        </p:nvSpPr>
+        <p:spPr>
+          <a:xfrm>
+            <a:off x="0" y="6446520"/>
+            <a:ext cx="12191695" cy="411480"/>
+          </a:xfrm>
+          <a:prstGeom prst="rect">
+            <a:avLst/>
+          </a:prstGeom>
+          <a:solidFill>
+            <a:srgbClr val="1F77C2"/>
+          </a:solidFill>
+          <a:ln>
+            <a:noFill/>
+          </a:ln>
+          <a:effectLst/>
+        </p:spPr>
+        <p:style>
+          <a:lnRef idx="1">
+            <a:schemeClr val="accent1"/>
+          </a:lnRef>
+          <a:fillRef idx="3">
+            <a:schemeClr val="accent1"/>
+          </a:fillRef>
+          <a:effectRef idx="2">
+            <a:schemeClr val="accent1"/>
+          </a:effectRef>
+          <a:fontRef idx="minor">
+            <a:schemeClr val="lt1"/>
+          </a:fontRef>
+        </p:style>
+        <p:txBody>
+          <a:bodyPr rtlCol="0" anchor="ctr"/>
+          <a:lstStyle/>
+          <a:p>
+            <a:pPr algn="ctr"/>
+          </a:p>
+        </p:txBody>
+      </p:sp>
+      <p:sp>
+        <p:nvSpPr>
+          <p:cNvPr id="8" name="TextBox 7"/>
+          <p:cNvSpPr txBox="1"/>
+          <p:nvPr/>
+        </p:nvSpPr>
+        <p:spPr>
+          <a:xfrm>
+            <a:off x="11430000" y="6473952"/>
+            <a:ext cx="640080" cy="365760"/>
+          </a:xfrm>
+          <a:prstGeom prst="rect">
+            <a:avLst/>
+          </a:prstGeom>
+          <a:noFill/>
+        </p:spPr>
+        <p:txBody>
+          <a:bodyPr wrap="none">
+            <a:spAutoFit/>
+          </a:bodyPr>
+          <a:lstStyle/>
+          <a:p>
+            <a:pPr algn="r"/>
+            <a:r>
+              <a:rPr sz="1200" b="1">
+                <a:solidFill>
+                  <a:srgbClr val="FFFFFF"/>
+                </a:solidFill>
+              </a:rPr>
+              <a:t>8</a:t>
             </a:r>
           </a:p>
         </p:txBody>

</xml_diff>

<commit_message>
Fix a 100x error in the ablation chart, and the stale Classifier row
- evaluation.json stores FAR and the false-log rate as FRACTIONS (0.0081 = 0.81%),
  but the chart plotted the raw value on an axis labelled "Error rate (%)" — so the
  bars read 0.008% instead of 0.81%. Scaled by 100.
- The stack table said "Linear SVM + cosine-to-centroid". The SVM is loaded but never
  called: /predict compares the embedding against every centroid directly, because the
  top-2 margin gate needs the runner-up score and an SVM only returns its winner. The
  row now says "Nearest-centroid, cosine similarity (no classifier)".

Both are the same class of bug the generator was meant to prevent — the numbers are
read from the measurement files, but the prose and the chart axes were not, so they
drifted when the code changed underneath them.
</commit_message>
<xml_diff>
--- a/Server/results/PresenceAI_Presentation.pptx
+++ b/Server/results/PresenceAI_Presentation.pptx
@@ -7937,7 +7937,7 @@
                 </a:solidFill>
                 <a:latin typeface="Calibri"/>
               </a:rPr>
-              <a:t>Classifier</a:t>
+              <a:t>Matching</a:t>
             </a:r>
           </a:p>
         </p:txBody>
@@ -8020,7 +8020,7 @@
                 </a:solidFill>
                 <a:latin typeface="Calibri"/>
               </a:rPr>
-              <a:t>Linear SVM + cosine-to-centroid  (scikit-learn)</a:t>
+              <a:t>Nearest-centroid, cosine similarity  (no classifier)</a:t>
             </a:r>
           </a:p>
         </p:txBody>

</xml_diff>